<commit_message>
Use keyword-level dedup rule for Gmarket and soften add-on option title
Co-Authored-By: Claude Opus 5.5 <noreply@anthropic.com>
Claude-Session: https://claude.ai/code/session_01LNckV4PF1WFWnv5VJ442kU
</commit_message>
<xml_diff>
--- a/쿠팡_오픈마켓_11월_261013_취합본.pptx
+++ b/쿠팡_오픈마켓_11월_261013_취합본.pptx
@@ -7617,172 +7617,7 @@
                 <a:ea typeface="에이투지체 8 ExtraBold"/>
                 <a:cs typeface="에이투지체 8 ExtraBold"/>
               </a:rPr>
-              <a:t>광고로</a:t>
-            </a:r>
-            <a:r>
-              <a:rPr sz="1900" b="0" dirty="0">
-                <a:solidFill>
-                  <a:srgbClr val="FFFFFF"/>
-                </a:solidFill>
-                <a:highlight>
-                  <a:srgbClr val="0000FF"/>
-                </a:highlight>
-                <a:latin typeface="에이투지체 8 ExtraBold"/>
-                <a:ea typeface="에이투지체 8 ExtraBold"/>
-                <a:cs typeface="에이투지체 8 ExtraBold"/>
-              </a:rPr>
-              <a:t> </a:t>
-            </a:r>
-            <a:r>
-              <a:rPr sz="1900" b="0" dirty="0" err="1">
-                <a:solidFill>
-                  <a:srgbClr val="FFFFFF"/>
-                </a:solidFill>
-                <a:highlight>
-                  <a:srgbClr val="0000FF"/>
-                </a:highlight>
-                <a:latin typeface="에이투지체 8 ExtraBold"/>
-                <a:ea typeface="에이투지체 8 ExtraBold"/>
-                <a:cs typeface="에이투지체 8 ExtraBold"/>
-              </a:rPr>
-              <a:t>들어온</a:t>
-            </a:r>
-            <a:r>
-              <a:rPr sz="1900" b="0" dirty="0">
-                <a:solidFill>
-                  <a:srgbClr val="FFFFFF"/>
-                </a:solidFill>
-                <a:highlight>
-                  <a:srgbClr val="0000FF"/>
-                </a:highlight>
-                <a:latin typeface="에이투지체 8 ExtraBold"/>
-                <a:ea typeface="에이투지체 8 ExtraBold"/>
-                <a:cs typeface="에이투지체 8 ExtraBold"/>
-              </a:rPr>
-              <a:t> </a:t>
-            </a:r>
-            <a:r>
-              <a:rPr sz="1900" b="0" dirty="0" err="1">
-                <a:solidFill>
-                  <a:srgbClr val="FFFFFF"/>
-                </a:solidFill>
-                <a:highlight>
-                  <a:srgbClr val="0000FF"/>
-                </a:highlight>
-                <a:latin typeface="에이투지체 8 ExtraBold"/>
-                <a:ea typeface="에이투지체 8 ExtraBold"/>
-                <a:cs typeface="에이투지체 8 ExtraBold"/>
-              </a:rPr>
-              <a:t>고객이</a:t>
-            </a:r>
-            <a:r>
-              <a:rPr sz="1900" b="0" dirty="0">
-                <a:solidFill>
-                  <a:srgbClr val="FFFFFF"/>
-                </a:solidFill>
-                <a:highlight>
-                  <a:srgbClr val="0000FF"/>
-                </a:highlight>
-                <a:latin typeface="에이투지체 8 ExtraBold"/>
-                <a:ea typeface="에이투지체 8 ExtraBold"/>
-                <a:cs typeface="에이투지체 8 ExtraBold"/>
-              </a:rPr>
-              <a:t> </a:t>
-            </a:r>
-            <a:r>
-              <a:rPr sz="1900" b="0" dirty="0" err="1">
-                <a:solidFill>
-                  <a:srgbClr val="FFFFFF"/>
-                </a:solidFill>
-                <a:highlight>
-                  <a:srgbClr val="0000FF"/>
-                </a:highlight>
-                <a:latin typeface="에이투지체 8 ExtraBold"/>
-                <a:ea typeface="에이투지체 8 ExtraBold"/>
-                <a:cs typeface="에이투지체 8 ExtraBold"/>
-              </a:rPr>
-              <a:t>다른</a:t>
-            </a:r>
-            <a:r>
-              <a:rPr sz="1900" b="0" dirty="0">
-                <a:solidFill>
-                  <a:srgbClr val="FFFFFF"/>
-                </a:solidFill>
-                <a:highlight>
-                  <a:srgbClr val="0000FF"/>
-                </a:highlight>
-                <a:latin typeface="에이투지체 8 ExtraBold"/>
-                <a:ea typeface="에이투지체 8 ExtraBold"/>
-                <a:cs typeface="에이투지체 8 ExtraBold"/>
-              </a:rPr>
-              <a:t> </a:t>
-            </a:r>
-            <a:r>
-              <a:rPr sz="1900" b="0" dirty="0" err="1">
-                <a:solidFill>
-                  <a:srgbClr val="FFFFFF"/>
-                </a:solidFill>
-                <a:highlight>
-                  <a:srgbClr val="0000FF"/>
-                </a:highlight>
-                <a:latin typeface="에이투지체 8 ExtraBold"/>
-                <a:ea typeface="에이투지체 8 ExtraBold"/>
-                <a:cs typeface="에이투지체 8 ExtraBold"/>
-              </a:rPr>
-              <a:t>상품도</a:t>
-            </a:r>
-            <a:r>
-              <a:rPr sz="1900" b="0" dirty="0">
-                <a:solidFill>
-                  <a:srgbClr val="FFFFFF"/>
-                </a:solidFill>
-                <a:highlight>
-                  <a:srgbClr val="0000FF"/>
-                </a:highlight>
-                <a:latin typeface="에이투지체 8 ExtraBold"/>
-                <a:ea typeface="에이투지체 8 ExtraBold"/>
-                <a:cs typeface="에이투지체 8 ExtraBold"/>
-              </a:rPr>
-              <a:t> </a:t>
-            </a:r>
-            <a:r>
-              <a:rPr lang="ko-KR" altLang="en-US" sz="1900" b="0" dirty="0">
-                <a:solidFill>
-                  <a:srgbClr val="FFFFFF"/>
-                </a:solidFill>
-                <a:highlight>
-                  <a:srgbClr val="0000FF"/>
-                </a:highlight>
-                <a:latin typeface="에이투지체 8 ExtraBold"/>
-                <a:ea typeface="에이투지체 8 ExtraBold"/>
-                <a:cs typeface="에이투지체 8 ExtraBold"/>
-              </a:rPr>
-              <a:t>볼 수 있</a:t>
-            </a:r>
-            <a:r>
-              <a:rPr sz="1900" b="0" dirty="0" err="1">
-                <a:solidFill>
-                  <a:srgbClr val="FFFFFF"/>
-                </a:solidFill>
-                <a:highlight>
-                  <a:srgbClr val="0000FF"/>
-                </a:highlight>
-                <a:latin typeface="에이투지체 8 ExtraBold"/>
-                <a:ea typeface="에이투지체 8 ExtraBold"/>
-                <a:cs typeface="에이투지체 8 ExtraBold"/>
-              </a:rPr>
-              <a:t>도록</a:t>
-            </a:r>
-            <a:r>
-              <a:rPr sz="1900" b="0" dirty="0">
-                <a:solidFill>
-                  <a:srgbClr val="222222"/>
-                </a:solidFill>
-                <a:latin typeface="에이투지체 8 ExtraBold"/>
-                <a:ea typeface="에이투지체 8 ExtraBold"/>
-                <a:cs typeface="에이투지체 8 ExtraBold"/>
-              </a:rPr>
-              <a:t> </a:t>
+              <a:t>상세 페이지 추가구성을 바꾸면</a:t>
             </a:r>
             <a:endParaRPr lang="en-US" sz="1900" b="0" dirty="0">
               <a:solidFill>
@@ -7808,62 +7643,7 @@
                 <a:ea typeface="에이투지체 8 ExtraBold"/>
                 <a:cs typeface="에이투지체 8 ExtraBold"/>
               </a:rPr>
-              <a:t>추가구성</a:t>
-            </a:r>
-            <a:r>
-              <a:rPr sz="1900" b="0" dirty="0">
-                <a:solidFill>
-                  <a:srgbClr val="222222"/>
-                </a:solidFill>
-                <a:latin typeface="에이투지체 8 ExtraBold"/>
-                <a:ea typeface="에이투지체 8 ExtraBold"/>
-                <a:cs typeface="에이투지체 8 ExtraBold"/>
-              </a:rPr>
-              <a:t> </a:t>
-            </a:r>
-            <a:r>
-              <a:rPr lang="ko-KR" altLang="en-US" sz="1900" b="0" dirty="0">
-                <a:solidFill>
-                  <a:srgbClr val="222222"/>
-                </a:solidFill>
-                <a:latin typeface="에이투지체 8 ExtraBold"/>
-                <a:ea typeface="에이투지체 8 ExtraBold"/>
-                <a:cs typeface="에이투지체 8 ExtraBold"/>
-              </a:rPr>
-              <a:t>순서 변경</a:t>
-            </a:r>
-            <a:r>
-              <a:rPr sz="1900" b="0" dirty="0">
-                <a:solidFill>
-                  <a:srgbClr val="222222"/>
-                </a:solidFill>
-                <a:latin typeface="에이투지체 8 ExtraBold"/>
-                <a:ea typeface="에이투지체 8 ExtraBold"/>
-                <a:cs typeface="에이투지체 8 ExtraBold"/>
-              </a:rPr>
-              <a:t>을</a:t>
-            </a:r>
-            <a:r>
-              <a:rPr lang="en-US" sz="1900" dirty="0">
-                <a:solidFill>
-                  <a:srgbClr val="222222"/>
-                </a:solidFill>
-                <a:latin typeface="에이투지체 8 ExtraBold"/>
-                <a:ea typeface="에이투지체 8 ExtraBold"/>
-                <a:cs typeface="에이투지체 8 ExtraBold"/>
-              </a:rPr>
-              <a:t> </a:t>
-            </a:r>
-            <a:r>
-              <a:rPr sz="1900" b="0" dirty="0" err="1">
-                <a:solidFill>
-                  <a:srgbClr val="222222"/>
-                </a:solidFill>
-                <a:latin typeface="에이투지체 8 ExtraBold"/>
-                <a:ea typeface="에이투지체 8 ExtraBold"/>
-                <a:cs typeface="에이투지체 8 ExtraBold"/>
-              </a:rPr>
-              <a:t>제안합니다</a:t>
+              <a:t>광고로 들어온 고객이 다른 상품도 볼 수 있습니다</a:t>
             </a:r>
             <a:endParaRPr sz="1900" b="0" dirty="0">
               <a:solidFill>
@@ -8089,8 +7869,8 @@
         </p:nvSpPr>
         <p:spPr>
           <a:xfrm>
-            <a:off x="740664" y="5632704"/>
-            <a:ext cx="10671048" cy="347472"/>
+            <a:off x="740664" y="5702565"/>
+            <a:ext cx="10671048" cy="207749"/>
           </a:xfrm>
           <a:prstGeom prst="rect">
             <a:avLst/>
@@ -8103,18 +7883,24 @@
           </a:bodyPr>
           <a:lstStyle/>
           <a:p>
-            <a:pPr algn="l"/>
-            <a:r>
-              <a:rPr sz="1350" b="0">
+            <a:r>
+              <a:rPr lang="ko-KR" altLang="ko-KR" sz="1350" dirty="0">
                 <a:solidFill>
                   <a:srgbClr val="004F9F"/>
                 </a:solidFill>
                 <a:latin typeface="에이투지체 6 SemiBold"/>
                 <a:ea typeface="에이투지체 6 SemiBold"/>
-                <a:cs typeface="에이투지체 6 SemiBold"/>
-              </a:rPr>
-              <a:t>추가구성 변경은 판매 채널 담당과 협의하고, 변경 전후 광고 유입 고객의 구매 전환율과 객단가를 비교해 공유합니다</a:t>
-            </a:r>
+              </a:rPr>
+              <a:t>추가구성 변경 전 후, 광고 유입 고객의 구매 전환율과 객단가를 비교하여 상품별 최적화된 옵션을 설정합니다</a:t>
+            </a:r>
+            <a:endParaRPr sz="1350" b="0" dirty="0">
+              <a:solidFill>
+                <a:srgbClr val="004F9F"/>
+              </a:solidFill>
+              <a:latin typeface="에이투지체 6 SemiBold"/>
+              <a:ea typeface="에이투지체 6 SemiBold"/>
+              <a:cs typeface="에이투지체 6 SemiBold"/>
+            </a:endParaRPr>
           </a:p>
         </p:txBody>
       </p:sp>
@@ -10326,7 +10112,7 @@
           <a:p>
             <a:pPr algn="l"/>
             <a:r>
-              <a:rPr sz="1350" b="0">
+              <a:rPr sz="1350" b="0" dirty="0">
                 <a:solidFill>
                   <a:srgbClr val="004F9F"/>
                 </a:solidFill>
@@ -10334,8 +10120,159 @@
                 <a:ea typeface="에이투지체 6 SemiBold"/>
                 <a:cs typeface="에이투지체 6 SemiBold"/>
               </a:rPr>
-              <a:t>지마켓·11번가는 쿠팡에서 검증된 상품과 검색어를 중심으로 예산을 늘립니다</a:t>
-            </a:r>
+              <a:t>지마켓·11번가는 </a:t>
+            </a:r>
+            <a:r>
+              <a:rPr sz="1350" b="0" dirty="0" err="1">
+                <a:solidFill>
+                  <a:srgbClr val="004F9F"/>
+                </a:solidFill>
+                <a:latin typeface="에이투지체 6 SemiBold"/>
+                <a:ea typeface="에이투지체 6 SemiBold"/>
+                <a:cs typeface="에이투지체 6 SemiBold"/>
+              </a:rPr>
+              <a:t>쿠팡에서</a:t>
+            </a:r>
+            <a:r>
+              <a:rPr sz="1350" b="0" dirty="0">
+                <a:solidFill>
+                  <a:srgbClr val="004F9F"/>
+                </a:solidFill>
+                <a:latin typeface="에이투지체 6 SemiBold"/>
+                <a:ea typeface="에이투지체 6 SemiBold"/>
+                <a:cs typeface="에이투지체 6 SemiBold"/>
+              </a:rPr>
+              <a:t> </a:t>
+            </a:r>
+            <a:r>
+              <a:rPr sz="1350" b="0" dirty="0" err="1">
+                <a:solidFill>
+                  <a:srgbClr val="004F9F"/>
+                </a:solidFill>
+                <a:latin typeface="에이투지체 6 SemiBold"/>
+                <a:ea typeface="에이투지체 6 SemiBold"/>
+                <a:cs typeface="에이투지체 6 SemiBold"/>
+              </a:rPr>
+              <a:t>검증된</a:t>
+            </a:r>
+            <a:r>
+              <a:rPr sz="1350" b="0" dirty="0">
+                <a:solidFill>
+                  <a:srgbClr val="004F9F"/>
+                </a:solidFill>
+                <a:latin typeface="에이투지체 6 SemiBold"/>
+                <a:ea typeface="에이투지체 6 SemiBold"/>
+                <a:cs typeface="에이투지체 6 SemiBold"/>
+              </a:rPr>
+              <a:t> </a:t>
+            </a:r>
+            <a:r>
+              <a:rPr sz="1350" b="0" dirty="0" err="1">
+                <a:solidFill>
+                  <a:srgbClr val="004F9F"/>
+                </a:solidFill>
+                <a:latin typeface="에이투지체 6 SemiBold"/>
+                <a:ea typeface="에이투지체 6 SemiBold"/>
+                <a:cs typeface="에이투지체 6 SemiBold"/>
+              </a:rPr>
+              <a:t>상품과</a:t>
+            </a:r>
+            <a:r>
+              <a:rPr sz="1350" b="0" dirty="0">
+                <a:solidFill>
+                  <a:srgbClr val="004F9F"/>
+                </a:solidFill>
+                <a:latin typeface="에이투지체 6 SemiBold"/>
+                <a:ea typeface="에이투지체 6 SemiBold"/>
+                <a:cs typeface="에이투지체 6 SemiBold"/>
+              </a:rPr>
+              <a:t> </a:t>
+            </a:r>
+            <a:r>
+              <a:rPr sz="1350" b="0" dirty="0" err="1">
+                <a:solidFill>
+                  <a:srgbClr val="004F9F"/>
+                </a:solidFill>
+                <a:latin typeface="에이투지체 6 SemiBold"/>
+                <a:ea typeface="에이투지체 6 SemiBold"/>
+                <a:cs typeface="에이투지체 6 SemiBold"/>
+              </a:rPr>
+              <a:t>검색어를</a:t>
+            </a:r>
+            <a:r>
+              <a:rPr sz="1350" b="0" dirty="0">
+                <a:solidFill>
+                  <a:srgbClr val="004F9F"/>
+                </a:solidFill>
+                <a:latin typeface="에이투지체 6 SemiBold"/>
+                <a:ea typeface="에이투지체 6 SemiBold"/>
+                <a:cs typeface="에이투지체 6 SemiBold"/>
+              </a:rPr>
+              <a:t> </a:t>
+            </a:r>
+            <a:r>
+              <a:rPr sz="1350" b="0" dirty="0" err="1">
+                <a:solidFill>
+                  <a:srgbClr val="004F9F"/>
+                </a:solidFill>
+                <a:latin typeface="에이투지체 6 SemiBold"/>
+                <a:ea typeface="에이투지체 6 SemiBold"/>
+                <a:cs typeface="에이투지체 6 SemiBold"/>
+              </a:rPr>
+              <a:t>중심으로</a:t>
+            </a:r>
+            <a:r>
+              <a:rPr sz="1350" b="0" dirty="0">
+                <a:solidFill>
+                  <a:srgbClr val="004F9F"/>
+                </a:solidFill>
+                <a:latin typeface="에이투지체 6 SemiBold"/>
+                <a:ea typeface="에이투지체 6 SemiBold"/>
+                <a:cs typeface="에이투지체 6 SemiBold"/>
+              </a:rPr>
+              <a:t> </a:t>
+            </a:r>
+            <a:r>
+              <a:rPr sz="1350" b="0" dirty="0" err="1">
+                <a:solidFill>
+                  <a:srgbClr val="004F9F"/>
+                </a:solidFill>
+                <a:latin typeface="에이투지체 6 SemiBold"/>
+                <a:ea typeface="에이투지체 6 SemiBold"/>
+                <a:cs typeface="에이투지체 6 SemiBold"/>
+              </a:rPr>
+              <a:t>예산을</a:t>
+            </a:r>
+            <a:r>
+              <a:rPr sz="1350" b="0" dirty="0">
+                <a:solidFill>
+                  <a:srgbClr val="004F9F"/>
+                </a:solidFill>
+                <a:latin typeface="에이투지체 6 SemiBold"/>
+                <a:ea typeface="에이투지체 6 SemiBold"/>
+                <a:cs typeface="에이투지체 6 SemiBold"/>
+              </a:rPr>
+              <a:t> </a:t>
+            </a:r>
+            <a:r>
+              <a:rPr sz="1350" b="0" dirty="0" err="1">
+                <a:solidFill>
+                  <a:srgbClr val="004F9F"/>
+                </a:solidFill>
+                <a:latin typeface="에이투지체 6 SemiBold"/>
+                <a:ea typeface="에이투지체 6 SemiBold"/>
+                <a:cs typeface="에이투지체 6 SemiBold"/>
+              </a:rPr>
+              <a:t>늘립니다</a:t>
+            </a:r>
+            <a:endParaRPr sz="1350" b="0" dirty="0">
+              <a:solidFill>
+                <a:srgbClr val="004F9F"/>
+              </a:solidFill>
+              <a:latin typeface="에이투지체 6 SemiBold"/>
+              <a:ea typeface="에이투지체 6 SemiBold"/>
+              <a:cs typeface="에이투지체 6 SemiBold"/>
+            </a:endParaRPr>
           </a:p>
         </p:txBody>
       </p:sp>
@@ -14921,7 +14858,7 @@
                 <a:latin typeface="에이투지체 5 Medium"/>
                 <a:ea typeface="에이투지체 5 Medium"/>
               </a:rPr>
-              <a:t>캠페인 간 상품 중복 없이 운영</a:t>
+              <a:t>같은 키워드 중복 입찰 없이 운영</a:t>
             </a:r>
           </a:p>
         </p:txBody>

</xml_diff>

<commit_message>
Make slide 3 takeaway action-oriented to lead into Coupang core tasks
Co-Authored-By: Claude Opus 5.5 <noreply@anthropic.com>
Claude-Session: https://claude.ai/code/session_01LNckV4PF1WFWnv5VJ442kU
</commit_message>
<xml_diff>
--- a/쿠팡_오픈마켓_11월_261013_취합본.pptx
+++ b/쿠팡_오픈마켓_11월_261013_취합본.pptx
@@ -789,9 +789,7 @@
           <a:bodyPr/>
           <a:lstStyle/>
           <a:p>
-            <a:r>
-              <a:t>출처: 두드림_11월 운영전략_쿠팡, 오픈마켓_RFP_261012(2).pptx1·2페이지.쿠팡40%는두드림제공26년10월외부몰집행비중이며11월확정배분아님.상품가격·배송·리뷰는2026-10-12조회기준.10개이하·1상품1캠페인은제안운영원칙.5클릭무전환은원문예시를제외후보검토기준으로완화하고전환반영기간확인후적용.</a:t>
-            </a:r>
+            <a:endParaRPr dirty="0"/>
           </a:p>
         </p:txBody>
       </p:sp>
@@ -866,9 +864,7 @@
           <a:bodyPr/>
           <a:lstStyle/>
           <a:p>
-            <a:r>
-              <a:t>출처: 두드림_11월 운영전략_쿠팡, 오픈마켓_RFP_261012(2).pptx3~5페이지.상품·광고운영현황2026-10-12조회.지마켓AI Product Ads유형은제공상품소개서ver1.4기준이며직접운영형CPC는순위보장아닌상한.운영유형이동과대표1~2개상품검증은제안.11번가·지마켓공식대행이력은사전검토자료27페이지.</a:t>
-            </a:r>
+            <a:endParaRPr dirty="0"/>
           </a:p>
         </p:txBody>
       </p:sp>
@@ -12911,7 +12907,7 @@
               </a:defRPr>
             </a:pPr>
             <a:r>
-              <a:rPr sz="1500">
+              <a:rPr sz="1500" dirty="0">
                 <a:solidFill>
                   <a:srgbClr val="004F9F"/>
                 </a:solidFill>
@@ -12919,8 +12915,49 @@
                 <a:ea typeface="에이투지체 6 SemiBold"/>
                 <a:cs typeface="에이투지체 6 SemiBold"/>
               </a:rPr>
-              <a:t>11번가  공식 스토어 초기 운영</a:t>
-            </a:r>
+              <a:t>11번가 </a:t>
+            </a:r>
+            <a:r>
+              <a:rPr sz="1500" dirty="0" err="1">
+                <a:solidFill>
+                  <a:srgbClr val="004F9F"/>
+                </a:solidFill>
+                <a:latin typeface="에이투지체 6 SemiBold"/>
+                <a:ea typeface="에이투지체 6 SemiBold"/>
+                <a:cs typeface="에이투지체 6 SemiBold"/>
+              </a:rPr>
+              <a:t>초기</a:t>
+            </a:r>
+            <a:r>
+              <a:rPr sz="1500" dirty="0">
+                <a:solidFill>
+                  <a:srgbClr val="004F9F"/>
+                </a:solidFill>
+                <a:latin typeface="에이투지체 6 SemiBold"/>
+                <a:ea typeface="에이투지체 6 SemiBold"/>
+                <a:cs typeface="에이투지체 6 SemiBold"/>
+              </a:rPr>
+              <a:t> </a:t>
+            </a:r>
+            <a:r>
+              <a:rPr sz="1500" dirty="0" err="1">
+                <a:solidFill>
+                  <a:srgbClr val="004F9F"/>
+                </a:solidFill>
+                <a:latin typeface="에이투지체 6 SemiBold"/>
+                <a:ea typeface="에이투지체 6 SemiBold"/>
+                <a:cs typeface="에이투지체 6 SemiBold"/>
+              </a:rPr>
+              <a:t>운영</a:t>
+            </a:r>
+            <a:endParaRPr sz="1500" dirty="0">
+              <a:solidFill>
+                <a:srgbClr val="004F9F"/>
+              </a:solidFill>
+              <a:latin typeface="에이투지체 6 SemiBold"/>
+              <a:ea typeface="에이투지체 6 SemiBold"/>
+              <a:cs typeface="에이투지체 6 SemiBold"/>
+            </a:endParaRPr>
           </a:p>
         </p:txBody>
       </p:sp>
@@ -14831,8 +14868,8 @@
         </p:nvSpPr>
         <p:spPr>
           <a:xfrm>
-            <a:off x="1097280" y="4956048"/>
-            <a:ext cx="2926080" cy="438912"/>
+            <a:off x="1097280" y="5087018"/>
+            <a:ext cx="2926080" cy="176972"/>
           </a:xfrm>
           <a:prstGeom prst="rect">
             <a:avLst/>
@@ -14851,15 +14888,122 @@
               </a:spcAft>
             </a:pPr>
             <a:r>
-              <a:rPr sz="1150">
+              <a:rPr lang="ko-KR" altLang="en-US" sz="1150" dirty="0">
                 <a:solidFill>
                   <a:srgbClr val="222222"/>
                 </a:solidFill>
                 <a:latin typeface="에이투지체 5 Medium"/>
                 <a:ea typeface="에이투지체 5 Medium"/>
               </a:rPr>
-              <a:t>같은 키워드 중복 입찰 없이 운영</a:t>
-            </a:r>
+              <a:t>동일</a:t>
+            </a:r>
+            <a:r>
+              <a:rPr sz="1150" dirty="0">
+                <a:solidFill>
+                  <a:srgbClr val="222222"/>
+                </a:solidFill>
+                <a:latin typeface="에이투지체 5 Medium"/>
+                <a:ea typeface="에이투지체 5 Medium"/>
+              </a:rPr>
+              <a:t> </a:t>
+            </a:r>
+            <a:r>
+              <a:rPr sz="1150" dirty="0" err="1">
+                <a:solidFill>
+                  <a:srgbClr val="222222"/>
+                </a:solidFill>
+                <a:latin typeface="에이투지체 5 Medium"/>
+                <a:ea typeface="에이투지체 5 Medium"/>
+              </a:rPr>
+              <a:t>키워드</a:t>
+            </a:r>
+            <a:r>
+              <a:rPr sz="1150" dirty="0">
+                <a:solidFill>
+                  <a:srgbClr val="222222"/>
+                </a:solidFill>
+                <a:latin typeface="에이투지체 5 Medium"/>
+                <a:ea typeface="에이투지체 5 Medium"/>
+              </a:rPr>
+              <a:t> </a:t>
+            </a:r>
+            <a:r>
+              <a:rPr sz="1150" dirty="0" err="1">
+                <a:solidFill>
+                  <a:srgbClr val="222222"/>
+                </a:solidFill>
+                <a:latin typeface="에이투지체 5 Medium"/>
+                <a:ea typeface="에이투지체 5 Medium"/>
+              </a:rPr>
+              <a:t>중복</a:t>
+            </a:r>
+            <a:r>
+              <a:rPr sz="1150" dirty="0">
+                <a:solidFill>
+                  <a:srgbClr val="222222"/>
+                </a:solidFill>
+                <a:latin typeface="에이투지체 5 Medium"/>
+                <a:ea typeface="에이투지체 5 Medium"/>
+              </a:rPr>
+              <a:t> </a:t>
+            </a:r>
+            <a:r>
+              <a:rPr sz="1150" dirty="0" err="1">
+                <a:solidFill>
+                  <a:srgbClr val="222222"/>
+                </a:solidFill>
+                <a:latin typeface="에이투지체 5 Medium"/>
+                <a:ea typeface="에이투지체 5 Medium"/>
+              </a:rPr>
+              <a:t>입찰</a:t>
+            </a:r>
+            <a:r>
+              <a:rPr sz="1150" dirty="0">
+                <a:solidFill>
+                  <a:srgbClr val="222222"/>
+                </a:solidFill>
+                <a:latin typeface="에이투지체 5 Medium"/>
+                <a:ea typeface="에이투지체 5 Medium"/>
+              </a:rPr>
+              <a:t> </a:t>
+            </a:r>
+            <a:r>
+              <a:rPr sz="1150" dirty="0" err="1">
+                <a:solidFill>
+                  <a:srgbClr val="222222"/>
+                </a:solidFill>
+                <a:latin typeface="에이투지체 5 Medium"/>
+                <a:ea typeface="에이투지체 5 Medium"/>
+              </a:rPr>
+              <a:t>없이</a:t>
+            </a:r>
+            <a:r>
+              <a:rPr sz="1150" dirty="0">
+                <a:solidFill>
+                  <a:srgbClr val="222222"/>
+                </a:solidFill>
+                <a:latin typeface="에이투지체 5 Medium"/>
+                <a:ea typeface="에이투지체 5 Medium"/>
+              </a:rPr>
+              <a:t> </a:t>
+            </a:r>
+            <a:r>
+              <a:rPr sz="1150" dirty="0" err="1">
+                <a:solidFill>
+                  <a:srgbClr val="222222"/>
+                </a:solidFill>
+                <a:latin typeface="에이투지체 5 Medium"/>
+                <a:ea typeface="에이투지체 5 Medium"/>
+              </a:rPr>
+              <a:t>운영</a:t>
+            </a:r>
+            <a:endParaRPr sz="1150" dirty="0">
+              <a:solidFill>
+                <a:srgbClr val="222222"/>
+              </a:solidFill>
+              <a:latin typeface="에이투지체 5 Medium"/>
+              <a:ea typeface="에이투지체 5 Medium"/>
+            </a:endParaRPr>
           </a:p>
         </p:txBody>
       </p:sp>
@@ -15308,7 +15452,7 @@
                 <a:ea typeface="에이투지체 8 ExtraBold"/>
                 <a:cs typeface="에이투지체 8 ExtraBold"/>
               </a:rPr>
-              <a:t> 2배 </a:t>
+              <a:t> </a:t>
             </a:r>
             <a:r>
               <a:rPr sz="1900" b="0" dirty="0" err="1">
@@ -15574,8 +15718,8 @@
         </p:nvSpPr>
         <p:spPr>
           <a:xfrm>
-            <a:off x="740664" y="5632704"/>
-            <a:ext cx="10671048" cy="347472"/>
+            <a:off x="740664" y="5702565"/>
+            <a:ext cx="10671048" cy="207749"/>
           </a:xfrm>
           <a:prstGeom prst="rect">
             <a:avLst/>
@@ -15589,28 +15733,6 @@
           <a:lstStyle/>
           <a:p>
             <a:pPr algn="l"/>
-            <a:r>
-              <a:rPr sz="1350" b="0" dirty="0" err="1">
-                <a:solidFill>
-                  <a:srgbClr val="004F9F"/>
-                </a:solidFill>
-                <a:latin typeface="에이투지체 6 SemiBold"/>
-                <a:ea typeface="에이투지체 6 SemiBold"/>
-                <a:cs typeface="에이투지체 6 SemiBold"/>
-              </a:rPr>
-              <a:t>매월</a:t>
-            </a:r>
-            <a:r>
-              <a:rPr sz="1350" b="0" dirty="0">
-                <a:solidFill>
-                  <a:srgbClr val="004F9F"/>
-                </a:solidFill>
-                <a:latin typeface="에이투지체 6 SemiBold"/>
-                <a:ea typeface="에이투지체 6 SemiBold"/>
-                <a:cs typeface="에이투지체 6 SemiBold"/>
-              </a:rPr>
-              <a:t> </a:t>
-            </a:r>
             <a:r>
               <a:rPr sz="1350" b="0" dirty="0" err="1">
                 <a:solidFill>
@@ -17943,7 +18065,7 @@
               </a:lnSpc>
             </a:pPr>
             <a:r>
-              <a:rPr sz="1900" b="0">
+              <a:rPr sz="1900" b="0" dirty="0" err="1">
                 <a:solidFill>
                   <a:srgbClr val="FFFFFF"/>
                 </a:solidFill>
@@ -17954,19 +18076,80 @@
                 <a:ea typeface="에이투지체 8 ExtraBold"/>
                 <a:cs typeface="에이투지체 8 ExtraBold"/>
               </a:rPr>
-              <a:t>대표 검색어 3개</a:t>
-            </a:r>
-            <a:r>
-              <a:rPr sz="1900" b="0">
-                <a:solidFill>
-                  <a:srgbClr val="222222"/>
-                </a:solidFill>
+              <a:t>대표</a:t>
+            </a:r>
+            <a:r>
+              <a:rPr sz="1900" b="0" dirty="0">
+                <a:solidFill>
+                  <a:srgbClr val="FFFFFF"/>
+                </a:solidFill>
+                <a:highlight>
+                  <a:srgbClr val="0000FF"/>
+                </a:highlight>
                 <a:latin typeface="에이투지체 8 ExtraBold"/>
                 <a:ea typeface="에이투지체 8 ExtraBold"/>
                 <a:cs typeface="에이투지체 8 ExtraBold"/>
               </a:rPr>
-              <a:t> 모두</a:t>
-            </a:r>
+              <a:t> </a:t>
+            </a:r>
+            <a:r>
+              <a:rPr sz="1900" b="0" dirty="0" err="1">
+                <a:solidFill>
+                  <a:srgbClr val="FFFFFF"/>
+                </a:solidFill>
+                <a:highlight>
+                  <a:srgbClr val="0000FF"/>
+                </a:highlight>
+                <a:latin typeface="에이투지체 8 ExtraBold"/>
+                <a:ea typeface="에이투지체 8 ExtraBold"/>
+                <a:cs typeface="에이투지체 8 ExtraBold"/>
+              </a:rPr>
+              <a:t>검색어</a:t>
+            </a:r>
+            <a:r>
+              <a:rPr sz="1900" b="0" dirty="0">
+                <a:solidFill>
+                  <a:srgbClr val="FFFFFF"/>
+                </a:solidFill>
+                <a:highlight>
+                  <a:srgbClr val="0000FF"/>
+                </a:highlight>
+                <a:latin typeface="에이투지체 8 ExtraBold"/>
+                <a:ea typeface="에이투지체 8 ExtraBold"/>
+                <a:cs typeface="에이투지체 8 ExtraBold"/>
+              </a:rPr>
+              <a:t> 3개</a:t>
+            </a:r>
+            <a:r>
+              <a:rPr sz="1900" b="0" dirty="0">
+                <a:solidFill>
+                  <a:srgbClr val="222222"/>
+                </a:solidFill>
+                <a:latin typeface="에이투지체 8 ExtraBold"/>
+                <a:ea typeface="에이투지체 8 ExtraBold"/>
+                <a:cs typeface="에이투지체 8 ExtraBold"/>
+              </a:rPr>
+              <a:t> </a:t>
+            </a:r>
+            <a:r>
+              <a:rPr sz="1900" b="0" dirty="0" err="1">
+                <a:solidFill>
+                  <a:srgbClr val="222222"/>
+                </a:solidFill>
+                <a:latin typeface="에이투지체 8 ExtraBold"/>
+                <a:ea typeface="에이투지체 8 ExtraBold"/>
+                <a:cs typeface="에이투지체 8 ExtraBold"/>
+              </a:rPr>
+              <a:t>모두</a:t>
+            </a:r>
+            <a:endParaRPr sz="1900" b="0" dirty="0">
+              <a:solidFill>
+                <a:srgbClr val="222222"/>
+              </a:solidFill>
+              <a:latin typeface="에이투지체 8 ExtraBold"/>
+              <a:ea typeface="에이투지체 8 ExtraBold"/>
+              <a:cs typeface="에이투지체 8 ExtraBold"/>
+            </a:endParaRPr>
           </a:p>
           <a:p>
             <a:pPr>
@@ -17975,7 +18158,7 @@
               </a:lnSpc>
             </a:pPr>
             <a:r>
-              <a:rPr sz="1900" b="0">
+              <a:rPr lang="ko-KR" altLang="en-US" sz="1900" b="0" dirty="0">
                 <a:solidFill>
                   <a:srgbClr val="222222"/>
                 </a:solidFill>
@@ -17983,8 +18166,104 @@
                 <a:ea typeface="에이투지체 8 ExtraBold"/>
                 <a:cs typeface="에이투지체 8 ExtraBold"/>
               </a:rPr>
-              <a:t>첫 화면에 두드림 상품이 없습니다</a:t>
-            </a:r>
+              <a:t>검색 결과 </a:t>
+            </a:r>
+            <a:r>
+              <a:rPr sz="1900" b="0" dirty="0">
+                <a:solidFill>
+                  <a:srgbClr val="222222"/>
+                </a:solidFill>
+                <a:latin typeface="에이투지체 8 ExtraBold"/>
+                <a:ea typeface="에이투지체 8 ExtraBold"/>
+                <a:cs typeface="에이투지체 8 ExtraBold"/>
+              </a:rPr>
+              <a:t>첫 </a:t>
+            </a:r>
+            <a:r>
+              <a:rPr lang="ko-KR" altLang="en-US" sz="1900" b="0" dirty="0">
+                <a:solidFill>
+                  <a:srgbClr val="222222"/>
+                </a:solidFill>
+                <a:latin typeface="에이투지체 8 ExtraBold"/>
+                <a:ea typeface="에이투지체 8 ExtraBold"/>
+                <a:cs typeface="에이투지체 8 ExtraBold"/>
+              </a:rPr>
+              <a:t>페이지</a:t>
+            </a:r>
+            <a:r>
+              <a:rPr sz="1900" b="0" dirty="0">
+                <a:solidFill>
+                  <a:srgbClr val="222222"/>
+                </a:solidFill>
+                <a:latin typeface="에이투지체 8 ExtraBold"/>
+                <a:ea typeface="에이투지체 8 ExtraBold"/>
+                <a:cs typeface="에이투지체 8 ExtraBold"/>
+              </a:rPr>
+              <a:t>에 </a:t>
+            </a:r>
+            <a:r>
+              <a:rPr sz="1900" b="0" dirty="0" err="1">
+                <a:solidFill>
+                  <a:srgbClr val="222222"/>
+                </a:solidFill>
+                <a:latin typeface="에이투지체 8 ExtraBold"/>
+                <a:ea typeface="에이투지체 8 ExtraBold"/>
+                <a:cs typeface="에이투지체 8 ExtraBold"/>
+              </a:rPr>
+              <a:t>두드림</a:t>
+            </a:r>
+            <a:r>
+              <a:rPr sz="1900" b="0" dirty="0">
+                <a:solidFill>
+                  <a:srgbClr val="222222"/>
+                </a:solidFill>
+                <a:latin typeface="에이투지체 8 ExtraBold"/>
+                <a:ea typeface="에이투지체 8 ExtraBold"/>
+                <a:cs typeface="에이투지체 8 ExtraBold"/>
+              </a:rPr>
+              <a:t> </a:t>
+            </a:r>
+            <a:r>
+              <a:rPr sz="1900" b="0" dirty="0" err="1">
+                <a:solidFill>
+                  <a:srgbClr val="222222"/>
+                </a:solidFill>
+                <a:latin typeface="에이투지체 8 ExtraBold"/>
+                <a:ea typeface="에이투지체 8 ExtraBold"/>
+                <a:cs typeface="에이투지체 8 ExtraBold"/>
+              </a:rPr>
+              <a:t>상품이</a:t>
+            </a:r>
+            <a:r>
+              <a:rPr sz="1900" b="0" dirty="0">
+                <a:solidFill>
+                  <a:srgbClr val="222222"/>
+                </a:solidFill>
+                <a:latin typeface="에이투지체 8 ExtraBold"/>
+                <a:ea typeface="에이투지체 8 ExtraBold"/>
+                <a:cs typeface="에이투지체 8 ExtraBold"/>
+              </a:rPr>
+              <a:t> </a:t>
+            </a:r>
+            <a:r>
+              <a:rPr sz="1900" b="0" dirty="0" err="1">
+                <a:solidFill>
+                  <a:srgbClr val="222222"/>
+                </a:solidFill>
+                <a:latin typeface="에이투지체 8 ExtraBold"/>
+                <a:ea typeface="에이투지체 8 ExtraBold"/>
+                <a:cs typeface="에이투지체 8 ExtraBold"/>
+              </a:rPr>
+              <a:t>없습니다</a:t>
+            </a:r>
+            <a:endParaRPr sz="1900" b="0" dirty="0">
+              <a:solidFill>
+                <a:srgbClr val="222222"/>
+              </a:solidFill>
+              <a:latin typeface="에이투지체 8 ExtraBold"/>
+              <a:ea typeface="에이투지체 8 ExtraBold"/>
+              <a:cs typeface="에이투지체 8 ExtraBold"/>
+            </a:endParaRPr>
           </a:p>
         </p:txBody>
       </p:sp>
@@ -18200,7 +18479,7 @@
                 <a:ea typeface="에이투지체 6 SemiBold"/>
                 <a:cs typeface="에이투지체 6 SemiBold"/>
               </a:rPr>
-              <a:t>대표 검색어에서는 리뷰 수천~수만 개의 경쟁 상품이 광고와 랭킹 상위에 함께 노출되고 있습니다</a:t>
+              <a:t>대표 검색어는 리뷰가 쌓인 FGO·카무트부터 노출을 넓히고, 목표 ROAS와 예산으로 노출 범위를 조정하겠습니다</a:t>
             </a:r>
           </a:p>
         </p:txBody>

</xml_diff>

<commit_message>
Replace stiff exposure wording with plain marketer phrasing in Coupang slides
Co-Authored-By: Claude Opus 5.5 <noreply@anthropic.com>
Claude-Session: https://claude.ai/code/session_01LNckV4PF1WFWnv5VJ442kU
</commit_message>
<xml_diff>
--- a/쿠팡_오픈마켓_11월_261013_취합본.pptx
+++ b/쿠팡_오픈마켓_11월_261013_취합본.pptx
@@ -5128,7 +5128,7 @@
                 <a:ea typeface="에이투지체 6 SemiBold"/>
                 <a:cs typeface="에이투지체 6 SemiBold"/>
               </a:rPr>
-              <a:t>광고로 넓힐 기반은 확보</a:t>
+              <a:t>광고할 상품은 준비된 상태</a:t>
             </a:r>
           </a:p>
         </p:txBody>
@@ -18479,7 +18479,7 @@
                 <a:ea typeface="에이투지체 6 SemiBold"/>
                 <a:cs typeface="에이투지체 6 SemiBold"/>
               </a:rPr>
-              <a:t>대표 검색어는 리뷰가 쌓인 FGO·카무트부터 노출을 넓히고, 목표 ROAS와 예산으로 노출 범위를 조정하겠습니다</a:t>
+              <a:t>대표 검색어는 리뷰가 많은 FGO·카무트 위주로 광고하고, 목표 ROAS와 예산을 조정해 노출을 늘리겠습니다</a:t>
             </a:r>
           </a:p>
         </p:txBody>
@@ -19353,293 +19353,7 @@
                 <a:ea typeface="에이투지체 6 SemiBold"/>
                 <a:cs typeface="에이투지체 6 SemiBold"/>
               </a:rPr>
-              <a:t>쿠팡에서는</a:t>
-            </a:r>
-            <a:r>
-              <a:rPr sz="1350" b="0" dirty="0">
-                <a:solidFill>
-                  <a:srgbClr val="004F9F"/>
-                </a:solidFill>
-                <a:latin typeface="에이투지체 6 SemiBold"/>
-                <a:ea typeface="에이투지체 6 SemiBold"/>
-                <a:cs typeface="에이투지체 6 SemiBold"/>
-              </a:rPr>
-              <a:t> </a:t>
-            </a:r>
-            <a:r>
-              <a:rPr sz="1350" b="0" dirty="0" err="1">
-                <a:solidFill>
-                  <a:srgbClr val="004F9F"/>
-                </a:solidFill>
-                <a:latin typeface="에이투지체 6 SemiBold"/>
-                <a:ea typeface="에이투지체 6 SemiBold"/>
-                <a:cs typeface="에이투지체 6 SemiBold"/>
-              </a:rPr>
-              <a:t>리뷰가</a:t>
-            </a:r>
-            <a:r>
-              <a:rPr sz="1350" b="0" dirty="0">
-                <a:solidFill>
-                  <a:srgbClr val="004F9F"/>
-                </a:solidFill>
-                <a:latin typeface="에이투지체 6 SemiBold"/>
-                <a:ea typeface="에이투지체 6 SemiBold"/>
-                <a:cs typeface="에이투지체 6 SemiBold"/>
-              </a:rPr>
-              <a:t> </a:t>
-            </a:r>
-            <a:r>
-              <a:rPr sz="1350" b="0" dirty="0" err="1">
-                <a:solidFill>
-                  <a:srgbClr val="004F9F"/>
-                </a:solidFill>
-                <a:latin typeface="에이투지체 6 SemiBold"/>
-                <a:ea typeface="에이투지체 6 SemiBold"/>
-                <a:cs typeface="에이투지체 6 SemiBold"/>
-              </a:rPr>
-              <a:t>쌓인</a:t>
-            </a:r>
-            <a:r>
-              <a:rPr sz="1350" b="0" dirty="0">
-                <a:solidFill>
-                  <a:srgbClr val="004F9F"/>
-                </a:solidFill>
-                <a:latin typeface="에이투지체 6 SemiBold"/>
-                <a:ea typeface="에이투지체 6 SemiBold"/>
-                <a:cs typeface="에이투지체 6 SemiBold"/>
-              </a:rPr>
-              <a:t> </a:t>
-            </a:r>
-            <a:r>
-              <a:rPr sz="1350" b="0" dirty="0" err="1">
-                <a:solidFill>
-                  <a:srgbClr val="004F9F"/>
-                </a:solidFill>
-                <a:latin typeface="에이투지체 6 SemiBold"/>
-                <a:ea typeface="에이투지체 6 SemiBold"/>
-                <a:cs typeface="에이투지체 6 SemiBold"/>
-              </a:rPr>
-              <a:t>로켓</a:t>
-            </a:r>
-            <a:r>
-              <a:rPr sz="1350" b="0" dirty="0">
-                <a:solidFill>
-                  <a:srgbClr val="004F9F"/>
-                </a:solidFill>
-                <a:latin typeface="에이투지체 6 SemiBold"/>
-                <a:ea typeface="에이투지체 6 SemiBold"/>
-                <a:cs typeface="에이투지체 6 SemiBold"/>
-              </a:rPr>
-              <a:t> </a:t>
-            </a:r>
-            <a:r>
-              <a:rPr sz="1350" b="0" dirty="0" err="1">
-                <a:solidFill>
-                  <a:srgbClr val="004F9F"/>
-                </a:solidFill>
-                <a:latin typeface="에이투지체 6 SemiBold"/>
-                <a:ea typeface="에이투지체 6 SemiBold"/>
-                <a:cs typeface="에이투지체 6 SemiBold"/>
-              </a:rPr>
-              <a:t>상품을</a:t>
-            </a:r>
-            <a:r>
-              <a:rPr sz="1350" b="0" dirty="0">
-                <a:solidFill>
-                  <a:srgbClr val="004F9F"/>
-                </a:solidFill>
-                <a:latin typeface="에이투지체 6 SemiBold"/>
-                <a:ea typeface="에이투지체 6 SemiBold"/>
-                <a:cs typeface="에이투지체 6 SemiBold"/>
-              </a:rPr>
-              <a:t> </a:t>
-            </a:r>
-            <a:r>
-              <a:rPr sz="1350" b="0" dirty="0" err="1">
-                <a:solidFill>
-                  <a:srgbClr val="004F9F"/>
-                </a:solidFill>
-                <a:latin typeface="에이투지체 6 SemiBold"/>
-                <a:ea typeface="에이투지체 6 SemiBold"/>
-                <a:cs typeface="에이투지체 6 SemiBold"/>
-              </a:rPr>
-              <a:t>앞세워</a:t>
-            </a:r>
-            <a:r>
-              <a:rPr sz="1350" b="0" dirty="0">
-                <a:solidFill>
-                  <a:srgbClr val="004F9F"/>
-                </a:solidFill>
-                <a:latin typeface="에이투지체 6 SemiBold"/>
-                <a:ea typeface="에이투지체 6 SemiBold"/>
-                <a:cs typeface="에이투지체 6 SemiBold"/>
-              </a:rPr>
-              <a:t> </a:t>
-            </a:r>
-            <a:r>
-              <a:rPr sz="1350" b="0" dirty="0" err="1">
-                <a:solidFill>
-                  <a:srgbClr val="004F9F"/>
-                </a:solidFill>
-                <a:latin typeface="에이투지체 6 SemiBold"/>
-                <a:ea typeface="에이투지체 6 SemiBold"/>
-                <a:cs typeface="에이투지체 6 SemiBold"/>
-              </a:rPr>
-              <a:t>FGO와</a:t>
-            </a:r>
-            <a:r>
-              <a:rPr sz="1350" b="0" dirty="0">
-                <a:solidFill>
-                  <a:srgbClr val="004F9F"/>
-                </a:solidFill>
-                <a:latin typeface="에이투지체 6 SemiBold"/>
-                <a:ea typeface="에이투지체 6 SemiBold"/>
-                <a:cs typeface="에이투지체 6 SemiBold"/>
-              </a:rPr>
-              <a:t> </a:t>
-            </a:r>
-            <a:r>
-              <a:rPr sz="1350" b="0" dirty="0" err="1">
-                <a:solidFill>
-                  <a:srgbClr val="004F9F"/>
-                </a:solidFill>
-                <a:latin typeface="에이투지체 6 SemiBold"/>
-                <a:ea typeface="에이투지체 6 SemiBold"/>
-                <a:cs typeface="에이투지체 6 SemiBold"/>
-              </a:rPr>
-              <a:t>다음</a:t>
-            </a:r>
-            <a:r>
-              <a:rPr sz="1350" b="0" dirty="0">
-                <a:solidFill>
-                  <a:srgbClr val="004F9F"/>
-                </a:solidFill>
-                <a:latin typeface="에이투지체 6 SemiBold"/>
-                <a:ea typeface="에이투지체 6 SemiBold"/>
-                <a:cs typeface="에이투지체 6 SemiBold"/>
-              </a:rPr>
-              <a:t> </a:t>
-            </a:r>
-            <a:r>
-              <a:rPr sz="1350" b="0" dirty="0" err="1">
-                <a:solidFill>
-                  <a:srgbClr val="004F9F"/>
-                </a:solidFill>
-                <a:latin typeface="에이투지체 6 SemiBold"/>
-                <a:ea typeface="에이투지체 6 SemiBold"/>
-                <a:cs typeface="에이투지체 6 SemiBold"/>
-              </a:rPr>
-              <a:t>히어로</a:t>
-            </a:r>
-            <a:r>
-              <a:rPr sz="1350" b="0" dirty="0">
-                <a:solidFill>
-                  <a:srgbClr val="004F9F"/>
-                </a:solidFill>
-                <a:latin typeface="에이투지체 6 SemiBold"/>
-                <a:ea typeface="에이투지체 6 SemiBold"/>
-                <a:cs typeface="에이투지체 6 SemiBold"/>
-              </a:rPr>
-              <a:t> </a:t>
-            </a:r>
-            <a:r>
-              <a:rPr sz="1350" b="0" dirty="0" err="1">
-                <a:solidFill>
-                  <a:srgbClr val="004F9F"/>
-                </a:solidFill>
-                <a:latin typeface="에이투지체 6 SemiBold"/>
-                <a:ea typeface="에이투지체 6 SemiBold"/>
-                <a:cs typeface="에이투지체 6 SemiBold"/>
-              </a:rPr>
-              <a:t>상품의</a:t>
-            </a:r>
-            <a:r>
-              <a:rPr sz="1350" b="0" dirty="0">
-                <a:solidFill>
-                  <a:srgbClr val="004F9F"/>
-                </a:solidFill>
-                <a:latin typeface="에이투지체 6 SemiBold"/>
-                <a:ea typeface="에이투지체 6 SemiBold"/>
-                <a:cs typeface="에이투지체 6 SemiBold"/>
-              </a:rPr>
-              <a:t> </a:t>
-            </a:r>
-            <a:r>
-              <a:rPr sz="1350" b="0" dirty="0" err="1">
-                <a:solidFill>
-                  <a:srgbClr val="004F9F"/>
-                </a:solidFill>
-                <a:latin typeface="에이투지체 6 SemiBold"/>
-                <a:ea typeface="에이투지체 6 SemiBold"/>
-                <a:cs typeface="에이투지체 6 SemiBold"/>
-              </a:rPr>
-              <a:t>검색</a:t>
-            </a:r>
-            <a:r>
-              <a:rPr sz="1350" b="0" dirty="0">
-                <a:solidFill>
-                  <a:srgbClr val="004F9F"/>
-                </a:solidFill>
-                <a:latin typeface="에이투지체 6 SemiBold"/>
-                <a:ea typeface="에이투지체 6 SemiBold"/>
-                <a:cs typeface="에이투지체 6 SemiBold"/>
-              </a:rPr>
-              <a:t> </a:t>
-            </a:r>
-            <a:r>
-              <a:rPr sz="1350" b="0" dirty="0" err="1">
-                <a:solidFill>
-                  <a:srgbClr val="004F9F"/>
-                </a:solidFill>
-                <a:latin typeface="에이투지체 6 SemiBold"/>
-                <a:ea typeface="에이투지체 6 SemiBold"/>
-                <a:cs typeface="에이투지체 6 SemiBold"/>
-              </a:rPr>
-              <a:t>수요를</a:t>
-            </a:r>
-            <a:r>
-              <a:rPr sz="1350" b="0" dirty="0">
-                <a:solidFill>
-                  <a:srgbClr val="004F9F"/>
-                </a:solidFill>
-                <a:latin typeface="에이투지체 6 SemiBold"/>
-                <a:ea typeface="에이투지체 6 SemiBold"/>
-                <a:cs typeface="에이투지체 6 SemiBold"/>
-              </a:rPr>
-              <a:t> </a:t>
-            </a:r>
-            <a:r>
-              <a:rPr sz="1350" b="0" dirty="0" err="1">
-                <a:solidFill>
-                  <a:srgbClr val="004F9F"/>
-                </a:solidFill>
-                <a:latin typeface="에이투지체 6 SemiBold"/>
-                <a:ea typeface="에이투지체 6 SemiBold"/>
-                <a:cs typeface="에이투지체 6 SemiBold"/>
-              </a:rPr>
-              <a:t>넓혀</a:t>
-            </a:r>
-            <a:r>
-              <a:rPr sz="1350" b="0" dirty="0">
-                <a:solidFill>
-                  <a:srgbClr val="004F9F"/>
-                </a:solidFill>
-                <a:latin typeface="에이투지체 6 SemiBold"/>
-                <a:ea typeface="에이투지체 6 SemiBold"/>
-                <a:cs typeface="에이투지체 6 SemiBold"/>
-              </a:rPr>
-              <a:t> </a:t>
-            </a:r>
-            <a:r>
-              <a:rPr sz="1350" b="0" dirty="0" err="1">
-                <a:solidFill>
-                  <a:srgbClr val="004F9F"/>
-                </a:solidFill>
-                <a:latin typeface="에이투지체 6 SemiBold"/>
-                <a:ea typeface="에이투지체 6 SemiBold"/>
-                <a:cs typeface="에이투지체 6 SemiBold"/>
-              </a:rPr>
-              <a:t>가겠습니다</a:t>
+              <a:t>쿠팡에서는 리뷰가 쌓인 로켓 상품 위주로 광고해 FGO와 다음 히어로 상품의 판매를 늘리겠습니다</a:t>
             </a:r>
             <a:endParaRPr sz="1350" b="0" dirty="0">
               <a:solidFill>
@@ -21038,7 +20752,7 @@
                 <a:ea typeface="에이투지체 5 Medium"/>
                 <a:cs typeface="에이투지체 5 Medium"/>
               </a:rPr>
-              <a:t>등록되면 어린이영양제 등 넓은 검색어까지 노출합니다</a:t>
+              <a:t>등록되면 어린이영양제 같은 검색어에도 노출합니다</a:t>
             </a:r>
           </a:p>
         </p:txBody>
@@ -24767,7 +24481,7 @@
                 <a:ea typeface="에이투지체 8 ExtraBold"/>
                 <a:cs typeface="에이투지체 8 ExtraBold"/>
               </a:rPr>
-              <a:t>유형마다 노출 범위와 제외 기준을 다르게 운영합니다</a:t>
+              <a:t>유형마다 제외 기준과 운영 방식을 다르게 가져갑니다</a:t>
             </a:r>
           </a:p>
         </p:txBody>
@@ -25622,7 +25336,7 @@
                 <a:ea typeface="에이투지체 4 Regular"/>
                 <a:cs typeface="에이투지체 4 Regular"/>
               </a:rPr>
-              <a:t>          예산과 목표 ROAS로 노출 범위 조정</a:t>
+              <a:t>          예산과 목표 ROAS로 노출량 조정</a:t>
             </a:r>
           </a:p>
         </p:txBody>

</xml_diff>

<commit_message>
Cut Coupang core tasks to three after removing package slide; reword slide 1 takeaway
Co-Authored-By: Claude Opus 5.5 <noreply@anthropic.com>
Claude-Session: https://claude.ai/code/session_01LNckV4PF1WFWnv5VJ442kU
</commit_message>
<xml_diff>
--- a/쿠팡_오픈마켓_11월_261013_취합본.pptx
+++ b/쿠팡_오픈마켓_11월_261013_취합본.pptx
@@ -4375,150 +4375,7 @@
                 <a:ea typeface="에이투지체 6 SemiBold"/>
                 <a:cs typeface="에이투지체 6 SemiBold"/>
               </a:rPr>
-              <a:t>로켓</a:t>
-            </a:r>
-            <a:r>
-              <a:rPr sz="1350" b="0" dirty="0">
-                <a:solidFill>
-                  <a:srgbClr val="004F9F"/>
-                </a:solidFill>
-                <a:latin typeface="에이투지체 6 SemiBold"/>
-                <a:ea typeface="에이투지체 6 SemiBold"/>
-                <a:cs typeface="에이투지체 6 SemiBold"/>
-              </a:rPr>
-              <a:t> </a:t>
-            </a:r>
-            <a:r>
-              <a:rPr lang="ko-KR" altLang="en-US" sz="1350" b="0" dirty="0">
-                <a:solidFill>
-                  <a:srgbClr val="004F9F"/>
-                </a:solidFill>
-                <a:latin typeface="에이투지체 6 SemiBold"/>
-                <a:ea typeface="에이투지체 6 SemiBold"/>
-                <a:cs typeface="에이투지체 6 SemiBold"/>
-              </a:rPr>
-              <a:t>배송 </a:t>
-            </a:r>
-            <a:r>
-              <a:rPr sz="1350" b="0" dirty="0" err="1">
-                <a:solidFill>
-                  <a:srgbClr val="004F9F"/>
-                </a:solidFill>
-                <a:latin typeface="에이투지체 6 SemiBold"/>
-                <a:ea typeface="에이투지체 6 SemiBold"/>
-                <a:cs typeface="에이투지체 6 SemiBold"/>
-              </a:rPr>
-              <a:t>상품을</a:t>
-            </a:r>
-            <a:r>
-              <a:rPr sz="1350" b="0" dirty="0">
-                <a:solidFill>
-                  <a:srgbClr val="004F9F"/>
-                </a:solidFill>
-                <a:latin typeface="에이투지체 6 SemiBold"/>
-                <a:ea typeface="에이투지체 6 SemiBold"/>
-                <a:cs typeface="에이투지체 6 SemiBold"/>
-              </a:rPr>
-              <a:t> </a:t>
-            </a:r>
-            <a:r>
-              <a:rPr lang="ko-KR" altLang="en-US" sz="1350" dirty="0">
-                <a:solidFill>
-                  <a:srgbClr val="004F9F"/>
-                </a:solidFill>
-                <a:latin typeface="에이투지체 6 SemiBold"/>
-                <a:ea typeface="에이투지체 6 SemiBold"/>
-                <a:cs typeface="에이투지체 6 SemiBold"/>
-              </a:rPr>
-              <a:t>검색 결과에서 원활하게 </a:t>
-            </a:r>
-            <a:r>
-              <a:rPr sz="1350" b="0" dirty="0" err="1">
-                <a:solidFill>
-                  <a:srgbClr val="004F9F"/>
-                </a:solidFill>
-                <a:latin typeface="에이투지체 6 SemiBold"/>
-                <a:ea typeface="에이투지체 6 SemiBold"/>
-                <a:cs typeface="에이투지체 6 SemiBold"/>
-              </a:rPr>
-              <a:t>보이</a:t>
-            </a:r>
-            <a:r>
-              <a:rPr lang="ko-KR" altLang="en-US" sz="1350" b="0" dirty="0">
-                <a:solidFill>
-                  <a:srgbClr val="004F9F"/>
-                </a:solidFill>
-                <a:latin typeface="에이투지체 6 SemiBold"/>
-                <a:ea typeface="에이투지체 6 SemiBold"/>
-                <a:cs typeface="에이투지체 6 SemiBold"/>
-              </a:rPr>
-              <a:t>게 하</a:t>
-            </a:r>
-            <a:r>
-              <a:rPr sz="1350" b="0" dirty="0">
-                <a:solidFill>
-                  <a:srgbClr val="004F9F"/>
-                </a:solidFill>
-                <a:latin typeface="에이투지체 6 SemiBold"/>
-                <a:ea typeface="에이투지체 6 SemiBold"/>
-                <a:cs typeface="에이투지체 6 SemiBold"/>
-              </a:rPr>
-              <a:t>는 </a:t>
-            </a:r>
-            <a:r>
-              <a:rPr sz="1350" b="0" dirty="0" err="1">
-                <a:solidFill>
-                  <a:srgbClr val="004F9F"/>
-                </a:solidFill>
-                <a:latin typeface="에이투지체 6 SemiBold"/>
-                <a:ea typeface="에이투지체 6 SemiBold"/>
-                <a:cs typeface="에이투지체 6 SemiBold"/>
-              </a:rPr>
-              <a:t>것이</a:t>
-            </a:r>
-            <a:r>
-              <a:rPr sz="1350" b="0" dirty="0">
-                <a:solidFill>
-                  <a:srgbClr val="004F9F"/>
-                </a:solidFill>
-                <a:latin typeface="에이투지체 6 SemiBold"/>
-                <a:ea typeface="에이투지체 6 SemiBold"/>
-                <a:cs typeface="에이투지체 6 SemiBold"/>
-              </a:rPr>
-              <a:t> </a:t>
-            </a:r>
-            <a:r>
-              <a:rPr sz="1350" b="0" dirty="0" err="1">
-                <a:solidFill>
-                  <a:srgbClr val="004F9F"/>
-                </a:solidFill>
-                <a:latin typeface="에이투지체 6 SemiBold"/>
-                <a:ea typeface="에이투지체 6 SemiBold"/>
-                <a:cs typeface="에이투지체 6 SemiBold"/>
-              </a:rPr>
-              <a:t>쿠팡의</a:t>
-            </a:r>
-            <a:r>
-              <a:rPr sz="1350" b="0" dirty="0">
-                <a:solidFill>
-                  <a:srgbClr val="004F9F"/>
-                </a:solidFill>
-                <a:latin typeface="에이투지체 6 SemiBold"/>
-                <a:ea typeface="에이투지체 6 SemiBold"/>
-                <a:cs typeface="에이투지체 6 SemiBold"/>
-              </a:rPr>
-              <a:t> </a:t>
-            </a:r>
-            <a:r>
-              <a:rPr sz="1350" b="0" dirty="0" err="1">
-                <a:solidFill>
-                  <a:srgbClr val="004F9F"/>
-                </a:solidFill>
-                <a:latin typeface="에이투지체 6 SemiBold"/>
-                <a:ea typeface="에이투지체 6 SemiBold"/>
-                <a:cs typeface="에이투지체 6 SemiBold"/>
-              </a:rPr>
-              <a:t>과제입니다</a:t>
+              <a:t>로켓 배송 상품이 대표 검색어에서도 보이게 하는 것이 쿠팡의 과제입니다</a:t>
             </a:r>
             <a:endParaRPr sz="1350" b="0" dirty="0">
               <a:solidFill>
@@ -19214,7 +19071,7 @@
                 <a:ea typeface="에이투지체 8 ExtraBold"/>
                 <a:cs typeface="에이투지체 8 ExtraBold"/>
               </a:rPr>
-              <a:t>는 네 가지로 나누어</a:t>
+              <a:t>는 세 가지로 나누어</a:t>
             </a:r>
           </a:p>
           <a:p>
@@ -19634,7 +19491,7 @@
         <p:spPr>
           <a:xfrm>
             <a:off x="548640" y="2395728"/>
-            <a:ext cx="2423160" cy="640080"/>
+            <a:ext cx="2423160" cy="822960"/>
           </a:xfrm>
           <a:prstGeom prst="roundRect">
             <a:avLst>
@@ -19681,7 +19538,7 @@
         <p:spPr>
           <a:xfrm>
             <a:off x="731520" y="2395728"/>
-            <a:ext cx="2148840" cy="640080"/>
+            <a:ext cx="2148840" cy="822960"/>
           </a:xfrm>
           <a:prstGeom prst="rect">
             <a:avLst/>
@@ -19732,7 +19589,7 @@
         <p:spPr>
           <a:xfrm>
             <a:off x="3291840" y="2395728"/>
-            <a:ext cx="3931920" cy="640080"/>
+            <a:ext cx="3931920" cy="822960"/>
           </a:xfrm>
           <a:prstGeom prst="roundRect">
             <a:avLst>
@@ -19779,7 +19636,7 @@
         <p:spPr>
           <a:xfrm>
             <a:off x="3493008" y="2395728"/>
-            <a:ext cx="3611880" cy="640080"/>
+            <a:ext cx="3611880" cy="822960"/>
           </a:xfrm>
           <a:prstGeom prst="rect">
             <a:avLst/>
@@ -19829,7 +19686,7 @@
         </p:nvSpPr>
         <p:spPr>
           <a:xfrm>
-            <a:off x="7543800" y="2468880"/>
+            <a:off x="7543800" y="2560320"/>
             <a:ext cx="2103120" cy="493775"/>
           </a:xfrm>
           <a:prstGeom prst="roundRect">
@@ -19878,7 +19735,7 @@
         </p:nvSpPr>
         <p:spPr>
           <a:xfrm>
-            <a:off x="7635240" y="2468880"/>
+            <a:off x="7635240" y="2560320"/>
             <a:ext cx="1920240" cy="493775"/>
           </a:xfrm>
           <a:prstGeom prst="rect">
@@ -19916,7 +19773,7 @@
         <p:spPr>
           <a:xfrm>
             <a:off x="9966960" y="2395728"/>
-            <a:ext cx="1645920" cy="640080"/>
+            <a:ext cx="1645920" cy="822960"/>
           </a:xfrm>
           <a:prstGeom prst="rect">
             <a:avLst/>
@@ -19952,7 +19809,7 @@
         </p:nvSpPr>
         <p:spPr>
           <a:xfrm rot="5400000">
-            <a:off x="2990088" y="2642616"/>
+            <a:off x="2990088" y="2734056"/>
             <a:ext cx="201168" cy="146304"/>
           </a:xfrm>
           <a:prstGeom prst="triangle">
@@ -19997,7 +19854,7 @@
         </p:nvSpPr>
         <p:spPr>
           <a:xfrm rot="5400000">
-            <a:off x="7242048" y="2642616"/>
+            <a:off x="7242048" y="2734056"/>
             <a:ext cx="201168" cy="146304"/>
           </a:xfrm>
           <a:prstGeom prst="triangle">
@@ -20042,7 +19899,7 @@
         </p:nvSpPr>
         <p:spPr>
           <a:xfrm rot="5400000">
-            <a:off x="9665208" y="2642616"/>
+            <a:off x="9665208" y="2734056"/>
             <a:ext cx="201168" cy="146304"/>
           </a:xfrm>
           <a:prstGeom prst="triangle">
@@ -20087,8 +19944,8 @@
         </p:nvSpPr>
         <p:spPr>
           <a:xfrm>
-            <a:off x="548640" y="3145536"/>
-            <a:ext cx="2423160" cy="640080"/>
+            <a:off x="548640" y="3429000"/>
+            <a:ext cx="2423160" cy="822960"/>
           </a:xfrm>
           <a:prstGeom prst="roundRect">
             <a:avLst>
@@ -20134,8 +19991,8 @@
         </p:nvSpPr>
         <p:spPr>
           <a:xfrm>
-            <a:off x="731520" y="3145536"/>
-            <a:ext cx="2148840" cy="640080"/>
+            <a:off x="731520" y="3429000"/>
+            <a:ext cx="2148840" cy="822960"/>
           </a:xfrm>
           <a:prstGeom prst="rect">
             <a:avLst/>
@@ -20185,8 +20042,8 @@
         </p:nvSpPr>
         <p:spPr>
           <a:xfrm>
-            <a:off x="3291840" y="3145536"/>
-            <a:ext cx="3931920" cy="640080"/>
+            <a:off x="3291840" y="3429000"/>
+            <a:ext cx="3931920" cy="822960"/>
           </a:xfrm>
           <a:prstGeom prst="roundRect">
             <a:avLst>
@@ -20232,8 +20089,8 @@
         </p:nvSpPr>
         <p:spPr>
           <a:xfrm>
-            <a:off x="3493008" y="3145536"/>
-            <a:ext cx="3611880" cy="640080"/>
+            <a:off x="3493008" y="3429000"/>
+            <a:ext cx="3611880" cy="822960"/>
           </a:xfrm>
           <a:prstGeom prst="rect">
             <a:avLst/>
@@ -20283,7 +20140,7 @@
         </p:nvSpPr>
         <p:spPr>
           <a:xfrm>
-            <a:off x="7543800" y="3218688"/>
+            <a:off x="7543800" y="3593592"/>
             <a:ext cx="2103120" cy="493775"/>
           </a:xfrm>
           <a:prstGeom prst="roundRect">
@@ -20332,7 +20189,7 @@
         </p:nvSpPr>
         <p:spPr>
           <a:xfrm>
-            <a:off x="7635240" y="3218688"/>
+            <a:off x="7635240" y="3593592"/>
             <a:ext cx="1920240" cy="493775"/>
           </a:xfrm>
           <a:prstGeom prst="rect">
@@ -20383,8 +20240,8 @@
         </p:nvSpPr>
         <p:spPr>
           <a:xfrm>
-            <a:off x="9966960" y="3145536"/>
-            <a:ext cx="1645920" cy="640080"/>
+            <a:off x="9966960" y="3429000"/>
+            <a:ext cx="1645920" cy="822960"/>
           </a:xfrm>
           <a:prstGeom prst="rect">
             <a:avLst/>
@@ -20434,7 +20291,7 @@
         </p:nvSpPr>
         <p:spPr>
           <a:xfrm rot="5400000">
-            <a:off x="2990088" y="3392424"/>
+            <a:off x="2990088" y="3767328"/>
             <a:ext cx="201168" cy="146304"/>
           </a:xfrm>
           <a:prstGeom prst="triangle">
@@ -20479,7 +20336,7 @@
         </p:nvSpPr>
         <p:spPr>
           <a:xfrm rot="5400000">
-            <a:off x="7242048" y="3392424"/>
+            <a:off x="7242048" y="3767328"/>
             <a:ext cx="201168" cy="146304"/>
           </a:xfrm>
           <a:prstGeom prst="triangle">
@@ -20524,7 +20381,7 @@
         </p:nvSpPr>
         <p:spPr>
           <a:xfrm rot="5400000">
-            <a:off x="9665208" y="3392424"/>
+            <a:off x="9665208" y="3767328"/>
             <a:ext cx="201168" cy="146304"/>
           </a:xfrm>
           <a:prstGeom prst="triangle">
@@ -20563,14 +20420,14 @@
       </p:sp>
       <p:sp>
         <p:nvSpPr>
-          <p:cNvPr id="34" name="Rounded Rectangle 33"/>
+          <p:cNvPr id="44" name="Rounded Rectangle 43"/>
           <p:cNvSpPr/>
           <p:nvPr/>
         </p:nvSpPr>
         <p:spPr>
           <a:xfrm>
-            <a:off x="548640" y="3895344"/>
-            <a:ext cx="2423160" cy="640080"/>
+            <a:off x="548640" y="4462272"/>
+            <a:ext cx="2423160" cy="822960"/>
           </a:xfrm>
           <a:prstGeom prst="roundRect">
             <a:avLst>
@@ -20610,14 +20467,14 @@
       </p:sp>
       <p:sp>
         <p:nvSpPr>
-          <p:cNvPr id="35" name="TextBox 34"/>
-          <p:cNvSpPr txBox="1"/>
-          <p:nvPr/>
-        </p:nvSpPr>
-        <p:spPr>
-          <a:xfrm>
-            <a:off x="731520" y="3895344"/>
-            <a:ext cx="2148840" cy="640080"/>
+          <p:cNvPr id="45" name="TextBox 44"/>
+          <p:cNvSpPr txBox="1"/>
+          <p:nvPr/>
+        </p:nvSpPr>
+        <p:spPr>
+          <a:xfrm>
+            <a:off x="731520" y="4462272"/>
+            <a:ext cx="2148840" cy="822960"/>
           </a:xfrm>
           <a:prstGeom prst="rect">
             <a:avLst/>
@@ -20654,21 +20511,21 @@
                 <a:ea typeface="에이투지체 6 SemiBold"/>
                 <a:cs typeface="에이투지체 6 SemiBold"/>
               </a:rPr>
-              <a:t>성장 패키지 상품</a:t>
-            </a:r>
-          </a:p>
-        </p:txBody>
-      </p:sp>
-      <p:sp>
-        <p:nvSpPr>
-          <p:cNvPr id="36" name="Rounded Rectangle 35"/>
+              <a:t>행사 기간 집중</a:t>
+            </a:r>
+          </a:p>
+        </p:txBody>
+      </p:sp>
+      <p:sp>
+        <p:nvSpPr>
+          <p:cNvPr id="46" name="Rounded Rectangle 45"/>
           <p:cNvSpPr/>
           <p:nvPr/>
         </p:nvSpPr>
         <p:spPr>
           <a:xfrm>
-            <a:off x="3291840" y="3895344"/>
-            <a:ext cx="3931920" cy="640080"/>
+            <a:off x="3291840" y="4462272"/>
+            <a:ext cx="3931920" cy="822960"/>
           </a:xfrm>
           <a:prstGeom prst="roundRect">
             <a:avLst>
@@ -20708,14 +20565,14 @@
       </p:sp>
       <p:sp>
         <p:nvSpPr>
-          <p:cNvPr id="37" name="TextBox 36"/>
-          <p:cNvSpPr txBox="1"/>
-          <p:nvPr/>
-        </p:nvSpPr>
-        <p:spPr>
-          <a:xfrm>
-            <a:off x="3493008" y="3895344"/>
-            <a:ext cx="3611880" cy="640080"/>
+          <p:cNvPr id="47" name="TextBox 46"/>
+          <p:cNvSpPr txBox="1"/>
+          <p:nvPr/>
+        </p:nvSpPr>
+        <p:spPr>
+          <a:xfrm>
+            <a:off x="3493008" y="4462272"/>
+            <a:ext cx="3611880" cy="822960"/>
           </a:xfrm>
           <a:prstGeom prst="rect">
             <a:avLst/>
@@ -20738,7 +20595,7 @@
                 <a:ea typeface="에이투지체 5 Medium"/>
                 <a:cs typeface="에이투지체 5 Medium"/>
               </a:rPr>
-              <a:t>FGO 세트 상품 등록을 두드림에 제안하고</a:t>
+              <a:t>상시 캠페인을 유지한 채</a:t>
             </a:r>
           </a:p>
           <a:p>
@@ -20752,20 +20609,20 @@
                 <a:ea typeface="에이투지체 5 Medium"/>
                 <a:cs typeface="에이투지체 5 Medium"/>
               </a:rPr>
-              <a:t>등록되면 어린이영양제 같은 검색어에도 노출합니다</a:t>
-            </a:r>
-          </a:p>
-        </p:txBody>
-      </p:sp>
-      <p:sp>
-        <p:nvSpPr>
-          <p:cNvPr id="38" name="Rounded Rectangle 37"/>
+              <a:t>블프 기간 예산과 목표 ROAS만 조정합니다</a:t>
+            </a:r>
+          </a:p>
+        </p:txBody>
+      </p:sp>
+      <p:sp>
+        <p:nvSpPr>
+          <p:cNvPr id="48" name="Rounded Rectangle 47"/>
           <p:cNvSpPr/>
           <p:nvPr/>
         </p:nvSpPr>
         <p:spPr>
           <a:xfrm>
-            <a:off x="7543800" y="3968496"/>
+            <a:off x="7543800" y="4626864"/>
             <a:ext cx="2103120" cy="493775"/>
           </a:xfrm>
           <a:prstGeom prst="roundRect">
@@ -20808,13 +20665,13 @@
       </p:sp>
       <p:sp>
         <p:nvSpPr>
-          <p:cNvPr id="39" name="TextBox 38"/>
-          <p:cNvSpPr txBox="1"/>
-          <p:nvPr/>
-        </p:nvSpPr>
-        <p:spPr>
-          <a:xfrm>
-            <a:off x="7635240" y="3968496"/>
+          <p:cNvPr id="49" name="TextBox 48"/>
+          <p:cNvSpPr txBox="1"/>
+          <p:nvPr/>
+        </p:nvSpPr>
+        <p:spPr>
+          <a:xfrm>
+            <a:off x="7635240" y="4626864"/>
             <a:ext cx="1920240" cy="493775"/>
           </a:xfrm>
           <a:prstGeom prst="rect">
@@ -20838,85 +20695,57 @@
                 <a:ea typeface="에이투지체 6 SemiBold"/>
                 <a:cs typeface="에이투지체 6 SemiBold"/>
               </a:rPr>
-              <a:t>매출 최적화 A</a:t>
-            </a:r>
-          </a:p>
+              <a:t>기존 캠페인 유지</a:t>
+            </a:r>
+          </a:p>
+        </p:txBody>
+      </p:sp>
+      <p:sp>
+        <p:nvSpPr>
+          <p:cNvPr id="50" name="TextBox 49"/>
+          <p:cNvSpPr txBox="1"/>
+          <p:nvPr/>
+        </p:nvSpPr>
+        <p:spPr>
+          <a:xfrm>
+            <a:off x="9966960" y="4462272"/>
+            <a:ext cx="1645920" cy="822960"/>
+          </a:xfrm>
+          <a:prstGeom prst="rect">
+            <a:avLst/>
+          </a:prstGeom>
+          <a:noFill/>
+        </p:spPr>
+        <p:txBody>
+          <a:bodyPr wrap="square" lIns="0" tIns="0" rIns="0" bIns="0" anchor="ctr">
+            <a:spAutoFit/>
+          </a:bodyPr>
+          <a:lstStyle/>
           <a:p>
             <a:pPr algn="ctr"/>
             <a:r>
-              <a:rPr sz="1050" b="0">
-                <a:solidFill>
-                  <a:srgbClr val="004F9F"/>
+              <a:rPr sz="1100" b="0">
+                <a:solidFill>
+                  <a:srgbClr val="222222"/>
                 </a:solidFill>
                 <a:latin typeface="에이투지체 6 SemiBold"/>
                 <a:ea typeface="에이투지체 6 SemiBold"/>
                 <a:cs typeface="에이투지체 6 SemiBold"/>
               </a:rPr>
-              <a:t>키성장 캠페인</a:t>
-            </a:r>
-          </a:p>
-        </p:txBody>
-      </p:sp>
-      <p:sp>
-        <p:nvSpPr>
-          <p:cNvPr id="40" name="TextBox 39"/>
-          <p:cNvSpPr txBox="1"/>
-          <p:nvPr/>
-        </p:nvSpPr>
-        <p:spPr>
-          <a:xfrm>
-            <a:off x="9966960" y="3895344"/>
-            <a:ext cx="1645920" cy="640080"/>
-          </a:xfrm>
-          <a:prstGeom prst="rect">
-            <a:avLst/>
-          </a:prstGeom>
-          <a:noFill/>
-        </p:spPr>
-        <p:txBody>
-          <a:bodyPr wrap="square" lIns="0" tIns="0" rIns="0" bIns="0" anchor="ctr">
-            <a:spAutoFit/>
-          </a:bodyPr>
-          <a:lstStyle/>
-          <a:p>
-            <a:pPr algn="ctr"/>
-            <a:r>
-              <a:rPr sz="1100" b="0">
-                <a:solidFill>
-                  <a:srgbClr val="222222"/>
-                </a:solidFill>
-                <a:latin typeface="에이투지체 6 SemiBold"/>
-                <a:ea typeface="에이투지체 6 SemiBold"/>
-                <a:cs typeface="에이투지체 6 SemiBold"/>
-              </a:rPr>
-              <a:t>세트 매출</a:t>
-            </a:r>
-          </a:p>
-          <a:p>
-            <a:pPr algn="ctr"/>
-            <a:r>
-              <a:rPr sz="1100" b="0">
-                <a:solidFill>
-                  <a:srgbClr val="222222"/>
-                </a:solidFill>
-                <a:latin typeface="에이투지체 6 SemiBold"/>
-                <a:ea typeface="에이투지체 6 SemiBold"/>
-                <a:cs typeface="에이투지체 6 SemiBold"/>
-              </a:rPr>
-              <a:t>FGO 외 매출 비중</a:t>
-            </a:r>
-          </a:p>
-        </p:txBody>
-      </p:sp>
-      <p:sp>
-        <p:nvSpPr>
-          <p:cNvPr id="41" name="Isosceles Triangle 40"/>
+              <a:t>행사 기간 ROAS</a:t>
+            </a:r>
+          </a:p>
+        </p:txBody>
+      </p:sp>
+      <p:sp>
+        <p:nvSpPr>
+          <p:cNvPr id="51" name="Isosceles Triangle 50"/>
           <p:cNvSpPr/>
           <p:nvPr/>
         </p:nvSpPr>
         <p:spPr>
           <a:xfrm rot="5400000">
-            <a:off x="2990088" y="4142231"/>
+            <a:off x="2990088" y="4800600"/>
             <a:ext cx="201168" cy="146304"/>
           </a:xfrm>
           <a:prstGeom prst="triangle">
@@ -20955,13 +20784,13 @@
       </p:sp>
       <p:sp>
         <p:nvSpPr>
-          <p:cNvPr id="42" name="Isosceles Triangle 41"/>
+          <p:cNvPr id="52" name="Isosceles Triangle 51"/>
           <p:cNvSpPr/>
           <p:nvPr/>
         </p:nvSpPr>
         <p:spPr>
           <a:xfrm rot="5400000">
-            <a:off x="7242048" y="4142231"/>
+            <a:off x="7242048" y="4800600"/>
             <a:ext cx="201168" cy="146304"/>
           </a:xfrm>
           <a:prstGeom prst="triangle">
@@ -21000,467 +20829,13 @@
       </p:sp>
       <p:sp>
         <p:nvSpPr>
-          <p:cNvPr id="43" name="Isosceles Triangle 42"/>
-          <p:cNvSpPr/>
-          <p:nvPr/>
-        </p:nvSpPr>
-        <p:spPr>
-          <a:xfrm rot="5400000">
-            <a:off x="9665208" y="4142231"/>
-            <a:ext cx="201168" cy="146304"/>
-          </a:xfrm>
-          <a:prstGeom prst="triangle">
-            <a:avLst/>
-          </a:prstGeom>
-          <a:solidFill>
-            <a:srgbClr val="004F9F"/>
-          </a:solidFill>
-          <a:ln>
-            <a:noFill/>
-          </a:ln>
-          <a:effectLst/>
-        </p:spPr>
-        <p:style>
-          <a:lnRef idx="1">
-            <a:schemeClr val="accent1"/>
-          </a:lnRef>
-          <a:fillRef idx="3">
-            <a:schemeClr val="accent1"/>
-          </a:fillRef>
-          <a:effectRef idx="2">
-            <a:schemeClr val="accent1"/>
-          </a:effectRef>
-          <a:fontRef idx="minor">
-            <a:schemeClr val="lt1"/>
-          </a:fontRef>
-        </p:style>
-        <p:txBody>
-          <a:bodyPr rtlCol="0" anchor="ctr"/>
-          <a:lstStyle/>
-          <a:p>
-            <a:pPr algn="ctr"/>
-            <a:endParaRPr/>
-          </a:p>
-        </p:txBody>
-      </p:sp>
-      <p:sp>
-        <p:nvSpPr>
-          <p:cNvPr id="44" name="Rounded Rectangle 43"/>
-          <p:cNvSpPr/>
-          <p:nvPr/>
-        </p:nvSpPr>
-        <p:spPr>
-          <a:xfrm>
-            <a:off x="548640" y="4645152"/>
-            <a:ext cx="2423160" cy="640080"/>
-          </a:xfrm>
-          <a:prstGeom prst="roundRect">
-            <a:avLst>
-              <a:gd name="adj" fmla="val 11428"/>
-            </a:avLst>
-          </a:prstGeom>
-          <a:solidFill>
-            <a:srgbClr val="EAF2FB"/>
-          </a:solidFill>
-          <a:ln>
-            <a:noFill/>
-          </a:ln>
-          <a:effectLst/>
-        </p:spPr>
-        <p:style>
-          <a:lnRef idx="1">
-            <a:schemeClr val="accent1"/>
-          </a:lnRef>
-          <a:fillRef idx="3">
-            <a:schemeClr val="accent1"/>
-          </a:fillRef>
-          <a:effectRef idx="2">
-            <a:schemeClr val="accent1"/>
-          </a:effectRef>
-          <a:fontRef idx="minor">
-            <a:schemeClr val="lt1"/>
-          </a:fontRef>
-        </p:style>
-        <p:txBody>
-          <a:bodyPr rtlCol="0" anchor="ctr"/>
-          <a:lstStyle/>
-          <a:p>
-            <a:pPr algn="ctr"/>
-            <a:endParaRPr/>
-          </a:p>
-        </p:txBody>
-      </p:sp>
-      <p:sp>
-        <p:nvSpPr>
-          <p:cNvPr id="45" name="TextBox 44"/>
-          <p:cNvSpPr txBox="1"/>
-          <p:nvPr/>
-        </p:nvSpPr>
-        <p:spPr>
-          <a:xfrm>
-            <a:off x="731520" y="4645152"/>
-            <a:ext cx="2148840" cy="640080"/>
-          </a:xfrm>
-          <a:prstGeom prst="rect">
-            <a:avLst/>
-          </a:prstGeom>
-          <a:noFill/>
-        </p:spPr>
-        <p:txBody>
-          <a:bodyPr wrap="square" lIns="0" tIns="0" rIns="0" bIns="0" anchor="ctr">
-            <a:spAutoFit/>
-          </a:bodyPr>
-          <a:lstStyle/>
-          <a:p>
-            <a:pPr algn="l"/>
-            <a:r>
-              <a:rPr sz="1050" b="0">
-                <a:solidFill>
-                  <a:srgbClr val="004F9F"/>
-                </a:solidFill>
-                <a:latin typeface="에이투지체 6 SemiBold"/>
-                <a:ea typeface="에이투지체 6 SemiBold"/>
-                <a:cs typeface="에이투지체 6 SemiBold"/>
-              </a:rPr>
-              <a:t>04</a:t>
-            </a:r>
-          </a:p>
-          <a:p>
-            <a:pPr algn="l"/>
-            <a:r>
-              <a:rPr sz="1300" b="0">
-                <a:solidFill>
-                  <a:srgbClr val="222222"/>
-                </a:solidFill>
-                <a:latin typeface="에이투지체 6 SemiBold"/>
-                <a:ea typeface="에이투지체 6 SemiBold"/>
-                <a:cs typeface="에이투지체 6 SemiBold"/>
-              </a:rPr>
-              <a:t>행사 기간 집중</a:t>
-            </a:r>
-          </a:p>
-        </p:txBody>
-      </p:sp>
-      <p:sp>
-        <p:nvSpPr>
-          <p:cNvPr id="46" name="Rounded Rectangle 45"/>
-          <p:cNvSpPr/>
-          <p:nvPr/>
-        </p:nvSpPr>
-        <p:spPr>
-          <a:xfrm>
-            <a:off x="3291840" y="4645152"/>
-            <a:ext cx="3931920" cy="640080"/>
-          </a:xfrm>
-          <a:prstGeom prst="roundRect">
-            <a:avLst>
-              <a:gd name="adj" fmla="val 11428"/>
-            </a:avLst>
-          </a:prstGeom>
-          <a:solidFill>
-            <a:srgbClr val="F5F5F5"/>
-          </a:solidFill>
-          <a:ln>
-            <a:noFill/>
-          </a:ln>
-          <a:effectLst/>
-        </p:spPr>
-        <p:style>
-          <a:lnRef idx="1">
-            <a:schemeClr val="accent1"/>
-          </a:lnRef>
-          <a:fillRef idx="3">
-            <a:schemeClr val="accent1"/>
-          </a:fillRef>
-          <a:effectRef idx="2">
-            <a:schemeClr val="accent1"/>
-          </a:effectRef>
-          <a:fontRef idx="minor">
-            <a:schemeClr val="lt1"/>
-          </a:fontRef>
-        </p:style>
-        <p:txBody>
-          <a:bodyPr rtlCol="0" anchor="ctr"/>
-          <a:lstStyle/>
-          <a:p>
-            <a:pPr algn="ctr"/>
-            <a:endParaRPr/>
-          </a:p>
-        </p:txBody>
-      </p:sp>
-      <p:sp>
-        <p:nvSpPr>
-          <p:cNvPr id="47" name="TextBox 46"/>
-          <p:cNvSpPr txBox="1"/>
-          <p:nvPr/>
-        </p:nvSpPr>
-        <p:spPr>
-          <a:xfrm>
-            <a:off x="3493008" y="4645152"/>
-            <a:ext cx="3611880" cy="640080"/>
-          </a:xfrm>
-          <a:prstGeom prst="rect">
-            <a:avLst/>
-          </a:prstGeom>
-          <a:noFill/>
-        </p:spPr>
-        <p:txBody>
-          <a:bodyPr wrap="square" lIns="0" tIns="0" rIns="0" bIns="0" anchor="ctr">
-            <a:spAutoFit/>
-          </a:bodyPr>
-          <a:lstStyle/>
-          <a:p>
-            <a:pPr algn="l"/>
-            <a:r>
-              <a:rPr sz="1100" b="0">
-                <a:solidFill>
-                  <a:srgbClr val="222222"/>
-                </a:solidFill>
-                <a:latin typeface="에이투지체 5 Medium"/>
-                <a:ea typeface="에이투지체 5 Medium"/>
-                <a:cs typeface="에이투지체 5 Medium"/>
-              </a:rPr>
-              <a:t>상시 캠페인을 유지한 채</a:t>
-            </a:r>
-          </a:p>
-          <a:p>
-            <a:pPr algn="l"/>
-            <a:r>
-              <a:rPr sz="1100" b="0">
-                <a:solidFill>
-                  <a:srgbClr val="222222"/>
-                </a:solidFill>
-                <a:latin typeface="에이투지체 5 Medium"/>
-                <a:ea typeface="에이투지체 5 Medium"/>
-                <a:cs typeface="에이투지체 5 Medium"/>
-              </a:rPr>
-              <a:t>블프 기간 예산과 목표 ROAS만 조정합니다</a:t>
-            </a:r>
-          </a:p>
-        </p:txBody>
-      </p:sp>
-      <p:sp>
-        <p:nvSpPr>
-          <p:cNvPr id="48" name="Rounded Rectangle 47"/>
-          <p:cNvSpPr/>
-          <p:nvPr/>
-        </p:nvSpPr>
-        <p:spPr>
-          <a:xfrm>
-            <a:off x="7543800" y="4718304"/>
-            <a:ext cx="2103120" cy="493775"/>
-          </a:xfrm>
-          <a:prstGeom prst="roundRect">
-            <a:avLst>
-              <a:gd name="adj" fmla="val 14814"/>
-            </a:avLst>
-          </a:prstGeom>
-          <a:solidFill>
-            <a:srgbClr val="FFFFFF"/>
-          </a:solidFill>
-          <a:ln w="9525">
-            <a:solidFill>
-              <a:srgbClr val="004F9F"/>
-            </a:solidFill>
-          </a:ln>
-          <a:effectLst/>
-        </p:spPr>
-        <p:style>
-          <a:lnRef idx="1">
-            <a:schemeClr val="accent1"/>
-          </a:lnRef>
-          <a:fillRef idx="3">
-            <a:schemeClr val="accent1"/>
-          </a:fillRef>
-          <a:effectRef idx="2">
-            <a:schemeClr val="accent1"/>
-          </a:effectRef>
-          <a:fontRef idx="minor">
-            <a:schemeClr val="lt1"/>
-          </a:fontRef>
-        </p:style>
-        <p:txBody>
-          <a:bodyPr rtlCol="0" anchor="ctr"/>
-          <a:lstStyle/>
-          <a:p>
-            <a:pPr algn="ctr"/>
-            <a:endParaRPr/>
-          </a:p>
-        </p:txBody>
-      </p:sp>
-      <p:sp>
-        <p:nvSpPr>
-          <p:cNvPr id="49" name="TextBox 48"/>
-          <p:cNvSpPr txBox="1"/>
-          <p:nvPr/>
-        </p:nvSpPr>
-        <p:spPr>
-          <a:xfrm>
-            <a:off x="7635240" y="4718304"/>
-            <a:ext cx="1920240" cy="493775"/>
-          </a:xfrm>
-          <a:prstGeom prst="rect">
-            <a:avLst/>
-          </a:prstGeom>
-          <a:noFill/>
-        </p:spPr>
-        <p:txBody>
-          <a:bodyPr wrap="square" lIns="0" tIns="0" rIns="0" bIns="0" anchor="ctr">
-            <a:spAutoFit/>
-          </a:bodyPr>
-          <a:lstStyle/>
-          <a:p>
-            <a:pPr algn="ctr"/>
-            <a:r>
-              <a:rPr sz="1050" b="0">
-                <a:solidFill>
-                  <a:srgbClr val="004F9F"/>
-                </a:solidFill>
-                <a:latin typeface="에이투지체 6 SemiBold"/>
-                <a:ea typeface="에이투지체 6 SemiBold"/>
-                <a:cs typeface="에이투지체 6 SemiBold"/>
-              </a:rPr>
-              <a:t>기존 캠페인 유지</a:t>
-            </a:r>
-          </a:p>
-        </p:txBody>
-      </p:sp>
-      <p:sp>
-        <p:nvSpPr>
-          <p:cNvPr id="50" name="TextBox 49"/>
-          <p:cNvSpPr txBox="1"/>
-          <p:nvPr/>
-        </p:nvSpPr>
-        <p:spPr>
-          <a:xfrm>
-            <a:off x="9966960" y="4645152"/>
-            <a:ext cx="1645920" cy="640080"/>
-          </a:xfrm>
-          <a:prstGeom prst="rect">
-            <a:avLst/>
-          </a:prstGeom>
-          <a:noFill/>
-        </p:spPr>
-        <p:txBody>
-          <a:bodyPr wrap="square" lIns="0" tIns="0" rIns="0" bIns="0" anchor="ctr">
-            <a:spAutoFit/>
-          </a:bodyPr>
-          <a:lstStyle/>
-          <a:p>
-            <a:pPr algn="ctr"/>
-            <a:r>
-              <a:rPr sz="1100" b="0">
-                <a:solidFill>
-                  <a:srgbClr val="222222"/>
-                </a:solidFill>
-                <a:latin typeface="에이투지체 6 SemiBold"/>
-                <a:ea typeface="에이투지체 6 SemiBold"/>
-                <a:cs typeface="에이투지체 6 SemiBold"/>
-              </a:rPr>
-              <a:t>행사 기간 ROAS</a:t>
-            </a:r>
-          </a:p>
-        </p:txBody>
-      </p:sp>
-      <p:sp>
-        <p:nvSpPr>
-          <p:cNvPr id="51" name="Isosceles Triangle 50"/>
-          <p:cNvSpPr/>
-          <p:nvPr/>
-        </p:nvSpPr>
-        <p:spPr>
-          <a:xfrm rot="5400000">
-            <a:off x="2990088" y="4892040"/>
-            <a:ext cx="201168" cy="146304"/>
-          </a:xfrm>
-          <a:prstGeom prst="triangle">
-            <a:avLst/>
-          </a:prstGeom>
-          <a:solidFill>
-            <a:srgbClr val="004F9F"/>
-          </a:solidFill>
-          <a:ln>
-            <a:noFill/>
-          </a:ln>
-          <a:effectLst/>
-        </p:spPr>
-        <p:style>
-          <a:lnRef idx="1">
-            <a:schemeClr val="accent1"/>
-          </a:lnRef>
-          <a:fillRef idx="3">
-            <a:schemeClr val="accent1"/>
-          </a:fillRef>
-          <a:effectRef idx="2">
-            <a:schemeClr val="accent1"/>
-          </a:effectRef>
-          <a:fontRef idx="minor">
-            <a:schemeClr val="lt1"/>
-          </a:fontRef>
-        </p:style>
-        <p:txBody>
-          <a:bodyPr rtlCol="0" anchor="ctr"/>
-          <a:lstStyle/>
-          <a:p>
-            <a:pPr algn="ctr"/>
-            <a:endParaRPr/>
-          </a:p>
-        </p:txBody>
-      </p:sp>
-      <p:sp>
-        <p:nvSpPr>
-          <p:cNvPr id="52" name="Isosceles Triangle 51"/>
-          <p:cNvSpPr/>
-          <p:nvPr/>
-        </p:nvSpPr>
-        <p:spPr>
-          <a:xfrm rot="5400000">
-            <a:off x="7242048" y="4892040"/>
-            <a:ext cx="201168" cy="146304"/>
-          </a:xfrm>
-          <a:prstGeom prst="triangle">
-            <a:avLst/>
-          </a:prstGeom>
-          <a:solidFill>
-            <a:srgbClr val="004F9F"/>
-          </a:solidFill>
-          <a:ln>
-            <a:noFill/>
-          </a:ln>
-          <a:effectLst/>
-        </p:spPr>
-        <p:style>
-          <a:lnRef idx="1">
-            <a:schemeClr val="accent1"/>
-          </a:lnRef>
-          <a:fillRef idx="3">
-            <a:schemeClr val="accent1"/>
-          </a:fillRef>
-          <a:effectRef idx="2">
-            <a:schemeClr val="accent1"/>
-          </a:effectRef>
-          <a:fontRef idx="minor">
-            <a:schemeClr val="lt1"/>
-          </a:fontRef>
-        </p:style>
-        <p:txBody>
-          <a:bodyPr rtlCol="0" anchor="ctr"/>
-          <a:lstStyle/>
-          <a:p>
-            <a:pPr algn="ctr"/>
-            <a:endParaRPr/>
-          </a:p>
-        </p:txBody>
-      </p:sp>
-      <p:sp>
-        <p:nvSpPr>
           <p:cNvPr id="53" name="Isosceles Triangle 52"/>
           <p:cNvSpPr/>
           <p:nvPr/>
         </p:nvSpPr>
         <p:spPr>
           <a:xfrm rot="5400000">
-            <a:off x="9665208" y="4892040"/>
+            <a:off x="9665208" y="4800600"/>
             <a:ext cx="201168" cy="146304"/>
           </a:xfrm>
           <a:prstGeom prst="triangle">

</xml_diff>

<commit_message>
Remove remaining growth-package mention from Gmarket add-on slide
Co-Authored-By: Claude Opus 5.5 <noreply@anthropic.com>
Claude-Session: https://claude.ai/code/session_01LNckV4PF1WFWnv5VJ442kU
</commit_message>
<xml_diff>
--- a/쿠팡_오픈마켓_11월_261013_취합본.pptx
+++ b/쿠팡_오픈마켓_11월_261013_취합본.pptx
@@ -8307,25 +8307,7 @@
                 <a:ea typeface="에이투지체 4 Regular"/>
                 <a:cs typeface="에이투지체 4 Regular"/>
               </a:rPr>
-              <a:t>상단에 성장 패키지 (FGO + 칼마디, FGO + 칼마디 + 철분)</a:t>
-            </a:r>
-          </a:p>
-          <a:p>
-            <a:pPr algn="l">
-              <a:spcAft>
-                <a:spcPts val="600"/>
-              </a:spcAft>
-            </a:pPr>
-            <a:r>
-              <a:rPr sz="1100" b="0">
-                <a:solidFill>
-                  <a:srgbClr val="222222"/>
-                </a:solidFill>
-                <a:latin typeface="에이투지체 4 Regular"/>
-                <a:ea typeface="에이투지체 4 Regular"/>
-                <a:cs typeface="에이투지체 4 Regular"/>
-              </a:rPr>
-              <a:t>      상품마다 대표 구성 1개씩, 다양한 상품이 보이게</a:t>
+              <a:t>상품마다 대표 구성 1개씩, 다양한 상품이 보이게</a:t>
             </a:r>
           </a:p>
           <a:p>

</xml_diff>

<commit_message>
Match Coupang core tasks to detail slides: two tasks plus event note bar
Co-Authored-By: Claude Opus 5.5 <noreply@anthropic.com>
Claude-Session: https://claude.ai/code/session_01LNckV4PF1WFWnv5VJ442kU
</commit_message>
<xml_diff>
--- a/쿠팡_오픈마켓_11월_261013_취합본.pptx
+++ b/쿠팡_오픈마켓_11월_261013_취합본.pptx
@@ -19053,7 +19053,7 @@
                 <a:ea typeface="에이투지체 8 ExtraBold"/>
                 <a:cs typeface="에이투지체 8 ExtraBold"/>
               </a:rPr>
-              <a:t>는 세 가지로 나누어</a:t>
+              <a:t>는 두 가지로 나누어</a:t>
             </a:r>
           </a:p>
           <a:p>
@@ -19473,7 +19473,7 @@
         <p:spPr>
           <a:xfrm>
             <a:off x="548640" y="2395728"/>
-            <a:ext cx="2423160" cy="822960"/>
+            <a:ext cx="2423160" cy="1097280"/>
           </a:xfrm>
           <a:prstGeom prst="roundRect">
             <a:avLst>
@@ -19520,7 +19520,7 @@
         <p:spPr>
           <a:xfrm>
             <a:off x="731520" y="2395728"/>
-            <a:ext cx="2148840" cy="822960"/>
+            <a:ext cx="2148840" cy="1097280"/>
           </a:xfrm>
           <a:prstGeom prst="rect">
             <a:avLst/>
@@ -19571,7 +19571,7 @@
         <p:spPr>
           <a:xfrm>
             <a:off x="3291840" y="2395728"/>
-            <a:ext cx="3931920" cy="822960"/>
+            <a:ext cx="3931920" cy="1097280"/>
           </a:xfrm>
           <a:prstGeom prst="roundRect">
             <a:avLst>
@@ -19618,7 +19618,7 @@
         <p:spPr>
           <a:xfrm>
             <a:off x="3493008" y="2395728"/>
-            <a:ext cx="3611880" cy="822960"/>
+            <a:ext cx="3611880" cy="1097280"/>
           </a:xfrm>
           <a:prstGeom prst="rect">
             <a:avLst/>
@@ -19668,7 +19668,7 @@
         </p:nvSpPr>
         <p:spPr>
           <a:xfrm>
-            <a:off x="7543800" y="2560320"/>
+            <a:off x="7543800" y="2697480"/>
             <a:ext cx="2103120" cy="493775"/>
           </a:xfrm>
           <a:prstGeom prst="roundRect">
@@ -19717,7 +19717,7 @@
         </p:nvSpPr>
         <p:spPr>
           <a:xfrm>
-            <a:off x="7635240" y="2560320"/>
+            <a:off x="7635240" y="2697480"/>
             <a:ext cx="1920240" cy="493775"/>
           </a:xfrm>
           <a:prstGeom prst="rect">
@@ -19755,7 +19755,7 @@
         <p:spPr>
           <a:xfrm>
             <a:off x="9966960" y="2395728"/>
-            <a:ext cx="1645920" cy="822960"/>
+            <a:ext cx="1645920" cy="1097280"/>
           </a:xfrm>
           <a:prstGeom prst="rect">
             <a:avLst/>
@@ -19791,7 +19791,7 @@
         </p:nvSpPr>
         <p:spPr>
           <a:xfrm rot="5400000">
-            <a:off x="2990088" y="2734056"/>
+            <a:off x="2990088" y="2871216"/>
             <a:ext cx="201168" cy="146304"/>
           </a:xfrm>
           <a:prstGeom prst="triangle">
@@ -19836,7 +19836,7 @@
         </p:nvSpPr>
         <p:spPr>
           <a:xfrm rot="5400000">
-            <a:off x="7242048" y="2734056"/>
+            <a:off x="7242048" y="2871216"/>
             <a:ext cx="201168" cy="146304"/>
           </a:xfrm>
           <a:prstGeom prst="triangle">
@@ -19881,7 +19881,7 @@
         </p:nvSpPr>
         <p:spPr>
           <a:xfrm rot="5400000">
-            <a:off x="9665208" y="2734056"/>
+            <a:off x="9665208" y="2871216"/>
             <a:ext cx="201168" cy="146304"/>
           </a:xfrm>
           <a:prstGeom prst="triangle">
@@ -19926,8 +19926,8 @@
         </p:nvSpPr>
         <p:spPr>
           <a:xfrm>
-            <a:off x="548640" y="3429000"/>
-            <a:ext cx="2423160" cy="822960"/>
+            <a:off x="548640" y="3721608"/>
+            <a:ext cx="2423160" cy="1097280"/>
           </a:xfrm>
           <a:prstGeom prst="roundRect">
             <a:avLst>
@@ -19973,8 +19973,8 @@
         </p:nvSpPr>
         <p:spPr>
           <a:xfrm>
-            <a:off x="731520" y="3429000"/>
-            <a:ext cx="2148840" cy="822960"/>
+            <a:off x="731520" y="3721608"/>
+            <a:ext cx="2148840" cy="1097280"/>
           </a:xfrm>
           <a:prstGeom prst="rect">
             <a:avLst/>
@@ -20024,8 +20024,8 @@
         </p:nvSpPr>
         <p:spPr>
           <a:xfrm>
-            <a:off x="3291840" y="3429000"/>
-            <a:ext cx="3931920" cy="822960"/>
+            <a:off x="3291840" y="3721608"/>
+            <a:ext cx="3931920" cy="1097280"/>
           </a:xfrm>
           <a:prstGeom prst="roundRect">
             <a:avLst>
@@ -20071,8 +20071,8 @@
         </p:nvSpPr>
         <p:spPr>
           <a:xfrm>
-            <a:off x="3493008" y="3429000"/>
-            <a:ext cx="3611880" cy="822960"/>
+            <a:off x="3493008" y="3721608"/>
+            <a:ext cx="3611880" cy="1097280"/>
           </a:xfrm>
           <a:prstGeom prst="rect">
             <a:avLst/>
@@ -20122,7 +20122,7 @@
         </p:nvSpPr>
         <p:spPr>
           <a:xfrm>
-            <a:off x="7543800" y="3593592"/>
+            <a:off x="7543800" y="4023360"/>
             <a:ext cx="2103120" cy="493775"/>
           </a:xfrm>
           <a:prstGeom prst="roundRect">
@@ -20171,7 +20171,7 @@
         </p:nvSpPr>
         <p:spPr>
           <a:xfrm>
-            <a:off x="7635240" y="3593592"/>
+            <a:off x="7635240" y="4023360"/>
             <a:ext cx="1920240" cy="493775"/>
           </a:xfrm>
           <a:prstGeom prst="rect">
@@ -20222,8 +20222,8 @@
         </p:nvSpPr>
         <p:spPr>
           <a:xfrm>
-            <a:off x="9966960" y="3429000"/>
-            <a:ext cx="1645920" cy="822960"/>
+            <a:off x="9966960" y="3721608"/>
+            <a:ext cx="1645920" cy="1097280"/>
           </a:xfrm>
           <a:prstGeom prst="rect">
             <a:avLst/>
@@ -20273,7 +20273,7 @@
         </p:nvSpPr>
         <p:spPr>
           <a:xfrm rot="5400000">
-            <a:off x="2990088" y="3767328"/>
+            <a:off x="2990088" y="4197096"/>
             <a:ext cx="201168" cy="146304"/>
           </a:xfrm>
           <a:prstGeom prst="triangle">
@@ -20318,7 +20318,7 @@
         </p:nvSpPr>
         <p:spPr>
           <a:xfrm rot="5400000">
-            <a:off x="7242048" y="3767328"/>
+            <a:off x="7242048" y="4197096"/>
             <a:ext cx="201168" cy="146304"/>
           </a:xfrm>
           <a:prstGeom prst="triangle">
@@ -20363,7 +20363,7 @@
         </p:nvSpPr>
         <p:spPr>
           <a:xfrm rot="5400000">
-            <a:off x="9665208" y="3767328"/>
+            <a:off x="9665208" y="4197096"/>
             <a:ext cx="201168" cy="146304"/>
           </a:xfrm>
           <a:prstGeom prst="triangle">
@@ -20402,116 +20402,18 @@
       </p:sp>
       <p:sp>
         <p:nvSpPr>
-          <p:cNvPr id="44" name="Rounded Rectangle 43"/>
+          <p:cNvPr id="34" name="Event Note Bar"/>
           <p:cNvSpPr/>
           <p:nvPr/>
         </p:nvSpPr>
         <p:spPr>
           <a:xfrm>
-            <a:off x="548640" y="4462272"/>
-            <a:ext cx="2423160" cy="822960"/>
+            <a:off x="548640" y="5102352"/>
+            <a:ext cx="11064240" cy="365760"/>
           </a:xfrm>
           <a:prstGeom prst="roundRect">
             <a:avLst>
-              <a:gd name="adj" fmla="val 11428"/>
-            </a:avLst>
-          </a:prstGeom>
-          <a:solidFill>
-            <a:srgbClr val="EAF2FB"/>
-          </a:solidFill>
-          <a:ln>
-            <a:noFill/>
-          </a:ln>
-          <a:effectLst/>
-        </p:spPr>
-        <p:style>
-          <a:lnRef idx="1">
-            <a:schemeClr val="accent1"/>
-          </a:lnRef>
-          <a:fillRef idx="3">
-            <a:schemeClr val="accent1"/>
-          </a:fillRef>
-          <a:effectRef idx="2">
-            <a:schemeClr val="accent1"/>
-          </a:effectRef>
-          <a:fontRef idx="minor">
-            <a:schemeClr val="lt1"/>
-          </a:fontRef>
-        </p:style>
-        <p:txBody>
-          <a:bodyPr rtlCol="0" anchor="ctr"/>
-          <a:lstStyle/>
-          <a:p>
-            <a:pPr algn="ctr"/>
-            <a:endParaRPr/>
-          </a:p>
-        </p:txBody>
-      </p:sp>
-      <p:sp>
-        <p:nvSpPr>
-          <p:cNvPr id="45" name="TextBox 44"/>
-          <p:cNvSpPr txBox="1"/>
-          <p:nvPr/>
-        </p:nvSpPr>
-        <p:spPr>
-          <a:xfrm>
-            <a:off x="731520" y="4462272"/>
-            <a:ext cx="2148840" cy="822960"/>
-          </a:xfrm>
-          <a:prstGeom prst="rect">
-            <a:avLst/>
-          </a:prstGeom>
-          <a:noFill/>
-        </p:spPr>
-        <p:txBody>
-          <a:bodyPr wrap="square" lIns="0" tIns="0" rIns="0" bIns="0" anchor="ctr">
-            <a:spAutoFit/>
-          </a:bodyPr>
-          <a:lstStyle/>
-          <a:p>
-            <a:pPr algn="l"/>
-            <a:r>
-              <a:rPr sz="1050" b="0">
-                <a:solidFill>
-                  <a:srgbClr val="004F9F"/>
-                </a:solidFill>
-                <a:latin typeface="에이투지체 6 SemiBold"/>
-                <a:ea typeface="에이투지체 6 SemiBold"/>
-                <a:cs typeface="에이투지체 6 SemiBold"/>
-              </a:rPr>
-              <a:t>03</a:t>
-            </a:r>
-          </a:p>
-          <a:p>
-            <a:pPr algn="l"/>
-            <a:r>
-              <a:rPr sz="1300" b="0">
-                <a:solidFill>
-                  <a:srgbClr val="222222"/>
-                </a:solidFill>
-                <a:latin typeface="에이투지체 6 SemiBold"/>
-                <a:ea typeface="에이투지체 6 SemiBold"/>
-                <a:cs typeface="에이투지체 6 SemiBold"/>
-              </a:rPr>
-              <a:t>행사 기간 집중</a:t>
-            </a:r>
-          </a:p>
-        </p:txBody>
-      </p:sp>
-      <p:sp>
-        <p:nvSpPr>
-          <p:cNvPr id="46" name="Rounded Rectangle 45"/>
-          <p:cNvSpPr/>
-          <p:nvPr/>
-        </p:nvSpPr>
-        <p:spPr>
-          <a:xfrm>
-            <a:off x="3291840" y="4462272"/>
-            <a:ext cx="3931920" cy="822960"/>
-          </a:xfrm>
-          <a:prstGeom prst="roundRect">
-            <a:avLst>
-              <a:gd name="adj" fmla="val 11428"/>
+              <a:gd name="adj" fmla="val 20000"/>
             </a:avLst>
           </a:prstGeom>
           <a:solidFill>
@@ -20547,14 +20449,14 @@
       </p:sp>
       <p:sp>
         <p:nvSpPr>
-          <p:cNvPr id="47" name="TextBox 46"/>
-          <p:cNvSpPr txBox="1"/>
-          <p:nvPr/>
-        </p:nvSpPr>
-        <p:spPr>
-          <a:xfrm>
-            <a:off x="3493008" y="4462272"/>
-            <a:ext cx="3611880" cy="822960"/>
+          <p:cNvPr id="35" name="Event Note Text"/>
+          <p:cNvSpPr txBox="1"/>
+          <p:nvPr/>
+        </p:nvSpPr>
+        <p:spPr>
+          <a:xfrm>
+            <a:off x="731520" y="5102352"/>
+            <a:ext cx="10698480" cy="365760"/>
           </a:xfrm>
           <a:prstGeom prst="rect">
             <a:avLst/>
@@ -20569,7 +20471,18 @@
           <a:p>
             <a:pPr algn="l"/>
             <a:r>
-              <a:rPr sz="1100" b="0">
+              <a:rPr sz="1150" b="0">
+                <a:solidFill>
+                  <a:srgbClr val="004F9F"/>
+                </a:solidFill>
+                <a:latin typeface="에이투지체 6 SemiBold"/>
+                <a:ea typeface="에이투지체 6 SemiBold"/>
+                <a:cs typeface="에이투지체 6 SemiBold"/>
+              </a:rPr>
+              <a:t>행사 기간  </a:t>
+            </a:r>
+            <a:r>
+              <a:rPr sz="1150" b="0">
                 <a:solidFill>
                   <a:srgbClr val="222222"/>
                 </a:solidFill>
@@ -20577,280 +20490,8 @@
                 <a:ea typeface="에이투지체 5 Medium"/>
                 <a:cs typeface="에이투지체 5 Medium"/>
               </a:rPr>
-              <a:t>상시 캠페인을 유지한 채</a:t>
-            </a:r>
-          </a:p>
-          <a:p>
-            <a:pPr algn="l"/>
-            <a:r>
-              <a:rPr sz="1100" b="0">
-                <a:solidFill>
-                  <a:srgbClr val="222222"/>
-                </a:solidFill>
-                <a:latin typeface="에이투지체 5 Medium"/>
-                <a:ea typeface="에이투지체 5 Medium"/>
-                <a:cs typeface="에이투지체 5 Medium"/>
-              </a:rPr>
-              <a:t>블프 기간 예산과 목표 ROAS만 조정합니다</a:t>
-            </a:r>
-          </a:p>
-        </p:txBody>
-      </p:sp>
-      <p:sp>
-        <p:nvSpPr>
-          <p:cNvPr id="48" name="Rounded Rectangle 47"/>
-          <p:cNvSpPr/>
-          <p:nvPr/>
-        </p:nvSpPr>
-        <p:spPr>
-          <a:xfrm>
-            <a:off x="7543800" y="4626864"/>
-            <a:ext cx="2103120" cy="493775"/>
-          </a:xfrm>
-          <a:prstGeom prst="roundRect">
-            <a:avLst>
-              <a:gd name="adj" fmla="val 14814"/>
-            </a:avLst>
-          </a:prstGeom>
-          <a:solidFill>
-            <a:srgbClr val="FFFFFF"/>
-          </a:solidFill>
-          <a:ln w="9525">
-            <a:solidFill>
-              <a:srgbClr val="004F9F"/>
-            </a:solidFill>
-          </a:ln>
-          <a:effectLst/>
-        </p:spPr>
-        <p:style>
-          <a:lnRef idx="1">
-            <a:schemeClr val="accent1"/>
-          </a:lnRef>
-          <a:fillRef idx="3">
-            <a:schemeClr val="accent1"/>
-          </a:fillRef>
-          <a:effectRef idx="2">
-            <a:schemeClr val="accent1"/>
-          </a:effectRef>
-          <a:fontRef idx="minor">
-            <a:schemeClr val="lt1"/>
-          </a:fontRef>
-        </p:style>
-        <p:txBody>
-          <a:bodyPr rtlCol="0" anchor="ctr"/>
-          <a:lstStyle/>
-          <a:p>
-            <a:pPr algn="ctr"/>
-            <a:endParaRPr/>
-          </a:p>
-        </p:txBody>
-      </p:sp>
-      <p:sp>
-        <p:nvSpPr>
-          <p:cNvPr id="49" name="TextBox 48"/>
-          <p:cNvSpPr txBox="1"/>
-          <p:nvPr/>
-        </p:nvSpPr>
-        <p:spPr>
-          <a:xfrm>
-            <a:off x="7635240" y="4626864"/>
-            <a:ext cx="1920240" cy="493775"/>
-          </a:xfrm>
-          <a:prstGeom prst="rect">
-            <a:avLst/>
-          </a:prstGeom>
-          <a:noFill/>
-        </p:spPr>
-        <p:txBody>
-          <a:bodyPr wrap="square" lIns="0" tIns="0" rIns="0" bIns="0" anchor="ctr">
-            <a:spAutoFit/>
-          </a:bodyPr>
-          <a:lstStyle/>
-          <a:p>
-            <a:pPr algn="ctr"/>
-            <a:r>
-              <a:rPr sz="1050" b="0">
-                <a:solidFill>
-                  <a:srgbClr val="004F9F"/>
-                </a:solidFill>
-                <a:latin typeface="에이투지체 6 SemiBold"/>
-                <a:ea typeface="에이투지체 6 SemiBold"/>
-                <a:cs typeface="에이투지체 6 SemiBold"/>
-              </a:rPr>
-              <a:t>기존 캠페인 유지</a:t>
-            </a:r>
-          </a:p>
-        </p:txBody>
-      </p:sp>
-      <p:sp>
-        <p:nvSpPr>
-          <p:cNvPr id="50" name="TextBox 49"/>
-          <p:cNvSpPr txBox="1"/>
-          <p:nvPr/>
-        </p:nvSpPr>
-        <p:spPr>
-          <a:xfrm>
-            <a:off x="9966960" y="4462272"/>
-            <a:ext cx="1645920" cy="822960"/>
-          </a:xfrm>
-          <a:prstGeom prst="rect">
-            <a:avLst/>
-          </a:prstGeom>
-          <a:noFill/>
-        </p:spPr>
-        <p:txBody>
-          <a:bodyPr wrap="square" lIns="0" tIns="0" rIns="0" bIns="0" anchor="ctr">
-            <a:spAutoFit/>
-          </a:bodyPr>
-          <a:lstStyle/>
-          <a:p>
-            <a:pPr algn="ctr"/>
-            <a:r>
-              <a:rPr sz="1100" b="0">
-                <a:solidFill>
-                  <a:srgbClr val="222222"/>
-                </a:solidFill>
-                <a:latin typeface="에이투지체 6 SemiBold"/>
-                <a:ea typeface="에이투지체 6 SemiBold"/>
-                <a:cs typeface="에이투지체 6 SemiBold"/>
-              </a:rPr>
-              <a:t>행사 기간 ROAS</a:t>
-            </a:r>
-          </a:p>
-        </p:txBody>
-      </p:sp>
-      <p:sp>
-        <p:nvSpPr>
-          <p:cNvPr id="51" name="Isosceles Triangle 50"/>
-          <p:cNvSpPr/>
-          <p:nvPr/>
-        </p:nvSpPr>
-        <p:spPr>
-          <a:xfrm rot="5400000">
-            <a:off x="2990088" y="4800600"/>
-            <a:ext cx="201168" cy="146304"/>
-          </a:xfrm>
-          <a:prstGeom prst="triangle">
-            <a:avLst/>
-          </a:prstGeom>
-          <a:solidFill>
-            <a:srgbClr val="004F9F"/>
-          </a:solidFill>
-          <a:ln>
-            <a:noFill/>
-          </a:ln>
-          <a:effectLst/>
-        </p:spPr>
-        <p:style>
-          <a:lnRef idx="1">
-            <a:schemeClr val="accent1"/>
-          </a:lnRef>
-          <a:fillRef idx="3">
-            <a:schemeClr val="accent1"/>
-          </a:fillRef>
-          <a:effectRef idx="2">
-            <a:schemeClr val="accent1"/>
-          </a:effectRef>
-          <a:fontRef idx="minor">
-            <a:schemeClr val="lt1"/>
-          </a:fontRef>
-        </p:style>
-        <p:txBody>
-          <a:bodyPr rtlCol="0" anchor="ctr"/>
-          <a:lstStyle/>
-          <a:p>
-            <a:pPr algn="ctr"/>
-            <a:endParaRPr/>
-          </a:p>
-        </p:txBody>
-      </p:sp>
-      <p:sp>
-        <p:nvSpPr>
-          <p:cNvPr id="52" name="Isosceles Triangle 51"/>
-          <p:cNvSpPr/>
-          <p:nvPr/>
-        </p:nvSpPr>
-        <p:spPr>
-          <a:xfrm rot="5400000">
-            <a:off x="7242048" y="4800600"/>
-            <a:ext cx="201168" cy="146304"/>
-          </a:xfrm>
-          <a:prstGeom prst="triangle">
-            <a:avLst/>
-          </a:prstGeom>
-          <a:solidFill>
-            <a:srgbClr val="004F9F"/>
-          </a:solidFill>
-          <a:ln>
-            <a:noFill/>
-          </a:ln>
-          <a:effectLst/>
-        </p:spPr>
-        <p:style>
-          <a:lnRef idx="1">
-            <a:schemeClr val="accent1"/>
-          </a:lnRef>
-          <a:fillRef idx="3">
-            <a:schemeClr val="accent1"/>
-          </a:fillRef>
-          <a:effectRef idx="2">
-            <a:schemeClr val="accent1"/>
-          </a:effectRef>
-          <a:fontRef idx="minor">
-            <a:schemeClr val="lt1"/>
-          </a:fontRef>
-        </p:style>
-        <p:txBody>
-          <a:bodyPr rtlCol="0" anchor="ctr"/>
-          <a:lstStyle/>
-          <a:p>
-            <a:pPr algn="ctr"/>
-            <a:endParaRPr/>
-          </a:p>
-        </p:txBody>
-      </p:sp>
-      <p:sp>
-        <p:nvSpPr>
-          <p:cNvPr id="53" name="Isosceles Triangle 52"/>
-          <p:cNvSpPr/>
-          <p:nvPr/>
-        </p:nvSpPr>
-        <p:spPr>
-          <a:xfrm rot="5400000">
-            <a:off x="9665208" y="4800600"/>
-            <a:ext cx="201168" cy="146304"/>
-          </a:xfrm>
-          <a:prstGeom prst="triangle">
-            <a:avLst/>
-          </a:prstGeom>
-          <a:solidFill>
-            <a:srgbClr val="004F9F"/>
-          </a:solidFill>
-          <a:ln>
-            <a:noFill/>
-          </a:ln>
-          <a:effectLst/>
-        </p:spPr>
-        <p:style>
-          <a:lnRef idx="1">
-            <a:schemeClr val="accent1"/>
-          </a:lnRef>
-          <a:fillRef idx="3">
-            <a:schemeClr val="accent1"/>
-          </a:fillRef>
-          <a:effectRef idx="2">
-            <a:schemeClr val="accent1"/>
-          </a:effectRef>
-          <a:fontRef idx="minor">
-            <a:schemeClr val="lt1"/>
-          </a:fontRef>
-        </p:style>
-        <p:txBody>
-          <a:bodyPr rtlCol="0" anchor="ctr"/>
-          <a:lstStyle/>
-          <a:p>
-            <a:pPr algn="ctr"/>
-            <a:endParaRPr/>
+              <a:t>상시 캠페인을 그대로 두고 블프 기간 예산과 목표 ROAS만 조정합니다</a:t>
+            </a:r>
           </a:p>
         </p:txBody>
       </p:sp>

</xml_diff>

<commit_message>
Replace reseller headline on 11st diagnosis with official-store visibility
Co-Authored-By: Claude Opus 5.5 <noreply@anthropic.com>
Claude-Session: https://claude.ai/code/session_01LNckV4PF1WFWnv5VJ442kU
</commit_message>
<xml_diff>
--- a/쿠팡_오픈마켓_11월_261013_취합본.pptx
+++ b/쿠팡_오픈마켓_11월_261013_취합본.pptx
@@ -8682,7 +8682,7 @@
                 <a:ea typeface="에이투지체 8 ExtraBold"/>
                 <a:cs typeface="에이투지체 8 ExtraBold"/>
               </a:rPr>
-              <a:t>리셀러</a:t>
+              <a:t>미노출</a:t>
             </a:r>
           </a:p>
         </p:txBody>
@@ -8719,51 +8719,7 @@
                 <a:ea typeface="에이투지체 6 SemiBold"/>
                 <a:cs typeface="에이투지체 6 SemiBold"/>
               </a:rPr>
-              <a:t>아이클타임</a:t>
-            </a:r>
-            <a:r>
-              <a:rPr sz="1150" b="0" dirty="0">
-                <a:solidFill>
-                  <a:srgbClr val="5C5C5C"/>
-                </a:solidFill>
-                <a:latin typeface="에이투지체 6 SemiBold"/>
-                <a:ea typeface="에이투지체 6 SemiBold"/>
-                <a:cs typeface="에이투지체 6 SemiBold"/>
-              </a:rPr>
-              <a:t> </a:t>
-            </a:r>
-            <a:r>
-              <a:rPr sz="1150" b="0" dirty="0" err="1">
-                <a:solidFill>
-                  <a:srgbClr val="5C5C5C"/>
-                </a:solidFill>
-                <a:latin typeface="에이투지체 6 SemiBold"/>
-                <a:ea typeface="에이투지체 6 SemiBold"/>
-                <a:cs typeface="에이투지체 6 SemiBold"/>
-              </a:rPr>
-              <a:t>광고</a:t>
-            </a:r>
-            <a:r>
-              <a:rPr sz="1150" b="0" dirty="0">
-                <a:solidFill>
-                  <a:srgbClr val="5C5C5C"/>
-                </a:solidFill>
-                <a:latin typeface="에이투지체 6 SemiBold"/>
-                <a:ea typeface="에이투지체 6 SemiBold"/>
-                <a:cs typeface="에이투지체 6 SemiBold"/>
-              </a:rPr>
-              <a:t> </a:t>
-            </a:r>
-            <a:r>
-              <a:rPr lang="ko-KR" altLang="en-US" sz="1150" b="0" dirty="0">
-                <a:solidFill>
-                  <a:srgbClr val="5C5C5C"/>
-                </a:solidFill>
-                <a:latin typeface="에이투지체 6 SemiBold"/>
-                <a:ea typeface="에이투지체 6 SemiBold"/>
-                <a:cs typeface="에이투지체 6 SemiBold"/>
-              </a:rPr>
-              <a:t>검색 결과</a:t>
+              <a:t>아이클타임 검색 · 공식 스토어</a:t>
             </a:r>
             <a:endParaRPr sz="1150" b="0" dirty="0">
               <a:solidFill>
@@ -8808,7 +8764,7 @@
                 <a:ea typeface="에이투지체 6 SemiBold"/>
                 <a:cs typeface="에이투지체 6 SemiBold"/>
               </a:rPr>
-              <a:t>브랜드 검색어도 공식 스토어 미노출</a:t>
+              <a:t>브랜드 검색 결과는 다른 판매처 중심</a:t>
             </a:r>
           </a:p>
         </p:txBody>
@@ -8845,7 +8801,7 @@
                 <a:ea typeface="에이투지체 4 Regular"/>
                 <a:cs typeface="에이투지체 4 Regular"/>
               </a:rPr>
-              <a:t>광고 5개: 고려은단 2, 리셀러 3</a:t>
+              <a:t>광고 5개: 고려은단 2, 다른 판매처 3</a:t>
             </a:r>
           </a:p>
           <a:p>

</xml_diff>

<commit_message>
Reframe 11st slides as pre-launch with competitor context and start plan
Co-Authored-By: Claude Opus 5.5 <noreply@anthropic.com>
Claude-Session: https://claude.ai/code/session_01LNckV4PF1WFWnv5VJ442kU
</commit_message>
<xml_diff>
--- a/쿠팡_오픈마켓_11월_261013_취합본.pptx
+++ b/쿠팡_오픈마켓_11월_261013_취합본.pptx
@@ -7964,7 +7964,7 @@
                 <a:ea typeface="에이투지체 8 ExtraBold"/>
                 <a:cs typeface="에이투지체 8 ExtraBold"/>
               </a:rPr>
-              <a:t>11번가 주요 검색어의 광고에는</a:t>
+              <a:t>11번가는 광고 시작 전 단계라</a:t>
             </a:r>
           </a:p>
           <a:p>
@@ -7982,7 +7982,7 @@
                 <a:ea typeface="에이투지체 8 ExtraBold"/>
                 <a:cs typeface="에이투지체 8 ExtraBold"/>
               </a:rPr>
-              <a:t>경쟁사와 다른 판매처 상품이 노출되고 있습니다</a:t>
+              <a:t>경쟁 상황을 보고 브랜드 검색어부터 시작합니다</a:t>
             </a:r>
           </a:p>
         </p:txBody>
@@ -8017,7 +8017,7 @@
                 <a:ea typeface="에이투지체 5 Medium"/>
                 <a:cs typeface="에이투지체 5 Medium"/>
               </a:rPr>
-              <a:t>11번가 현황 진단</a:t>
+              <a:t>11번가 시작 전 점검</a:t>
             </a:r>
           </a:p>
         </p:txBody>
@@ -8103,7 +8103,7 @@
                 <a:ea typeface="에이투지체 6 SemiBold"/>
                 <a:cs typeface="에이투지체 6 SemiBold"/>
               </a:rPr>
-              <a:t>11번가는 공식 스토어 대표 상품부터 브랜드 검색어에서 보이게 하겠습니다</a:t>
+              <a:t>11번가는 브랜드 검색어와 대표 상품 1~2개로 광고를 시작하고, 성과를 보며 키워드를 늘리겠습니다</a:t>
             </a:r>
           </a:p>
         </p:txBody>
@@ -8335,7 +8335,7 @@
                 <a:ea typeface="에이투지체 8 ExtraBold"/>
                 <a:cs typeface="에이투지체 8 ExtraBold"/>
               </a:rPr>
-              <a:t>21개 중 0</a:t>
+              <a:t>광고 21개</a:t>
             </a:r>
           </a:p>
         </p:txBody>
@@ -8372,51 +8372,7 @@
                 <a:ea typeface="에이투지체 6 SemiBold"/>
                 <a:cs typeface="에이투지체 6 SemiBold"/>
               </a:rPr>
-              <a:t>키성장영양제</a:t>
-            </a:r>
-            <a:r>
-              <a:rPr sz="1150" b="0" dirty="0">
-                <a:solidFill>
-                  <a:srgbClr val="5C5C5C"/>
-                </a:solidFill>
-                <a:latin typeface="에이투지체 6 SemiBold"/>
-                <a:ea typeface="에이투지체 6 SemiBold"/>
-                <a:cs typeface="에이투지체 6 SemiBold"/>
-              </a:rPr>
-              <a:t> </a:t>
-            </a:r>
-            <a:r>
-              <a:rPr sz="1150" b="0" dirty="0" err="1">
-                <a:solidFill>
-                  <a:srgbClr val="5C5C5C"/>
-                </a:solidFill>
-                <a:latin typeface="에이투지체 6 SemiBold"/>
-                <a:ea typeface="에이투지체 6 SemiBold"/>
-                <a:cs typeface="에이투지체 6 SemiBold"/>
-              </a:rPr>
-              <a:t>광고</a:t>
-            </a:r>
-            <a:r>
-              <a:rPr sz="1150" b="0" dirty="0">
-                <a:solidFill>
-                  <a:srgbClr val="5C5C5C"/>
-                </a:solidFill>
-                <a:latin typeface="에이투지체 6 SemiBold"/>
-                <a:ea typeface="에이투지체 6 SemiBold"/>
-                <a:cs typeface="에이투지체 6 SemiBold"/>
-              </a:rPr>
-              <a:t> </a:t>
-            </a:r>
-            <a:r>
-              <a:rPr lang="ko-KR" altLang="en-US" sz="1150" dirty="0">
-                <a:solidFill>
-                  <a:srgbClr val="5C5C5C"/>
-                </a:solidFill>
-                <a:latin typeface="에이투지체 6 SemiBold"/>
-                <a:ea typeface="에이투지체 6 SemiBold"/>
-                <a:cs typeface="에이투지체 6 SemiBold"/>
-              </a:rPr>
-              <a:t>검색 결과</a:t>
+              <a:t>키성장영양제 검색 결과</a:t>
             </a:r>
             <a:endParaRPr sz="1150" b="0" dirty="0">
               <a:solidFill>
@@ -8461,7 +8417,7 @@
                 <a:ea typeface="에이투지체 6 SemiBold"/>
                 <a:cs typeface="에이투지체 6 SemiBold"/>
               </a:rPr>
-              <a:t>대표 검색어 광고 전부 경쟁사</a:t>
+              <a:t>대표 검색어는 경쟁사가 광고 중</a:t>
             </a:r>
           </a:p>
         </p:txBody>
@@ -8598,7 +8554,7 @@
                 <a:ea typeface="에이투지체 6 SemiBold"/>
                 <a:cs typeface="에이투지체 6 SemiBold"/>
               </a:rPr>
-              <a:t>카테고리 검색 수요가 경쟁 상품에 집중</a:t>
+              <a:t>대표 검색어는 롱테일부터 테스트</a:t>
             </a:r>
           </a:p>
         </p:txBody>
@@ -8682,7 +8638,7 @@
                 <a:ea typeface="에이투지체 8 ExtraBold"/>
                 <a:cs typeface="에이투지체 8 ExtraBold"/>
               </a:rPr>
-              <a:t>미노출</a:t>
+              <a:t>판매처 상품</a:t>
             </a:r>
           </a:p>
         </p:txBody>
@@ -8719,7 +8675,7 @@
                 <a:ea typeface="에이투지체 6 SemiBold"/>
                 <a:cs typeface="에이투지체 6 SemiBold"/>
               </a:rPr>
-              <a:t>아이클타임 검색 · 공식 스토어</a:t>
+              <a:t>아이클타임 검색 결과</a:t>
             </a:r>
             <a:endParaRPr sz="1150" b="0" dirty="0">
               <a:solidFill>
@@ -8901,7 +8857,7 @@
                 <a:ea typeface="에이투지체 6 SemiBold"/>
                 <a:cs typeface="에이투지체 6 SemiBold"/>
               </a:rPr>
-              <a:t>브랜드 검색어부터 정비</a:t>
+              <a:t>브랜드 검색어 광고부터 시작</a:t>
             </a:r>
           </a:p>
         </p:txBody>
@@ -24320,7 +24276,7 @@
                 <a:ea typeface="에이투지체 8 ExtraBold"/>
                 <a:cs typeface="에이투지체 8 ExtraBold"/>
               </a:rPr>
-              <a:t>11번가는 광고 영역에 보이지 않습니다</a:t>
+              <a:t>11번가는 아직 광고 시작 전입니다</a:t>
             </a:r>
           </a:p>
         </p:txBody>
@@ -25775,7 +25731,7 @@
                 <a:ea typeface="에이투지체 8 ExtraBold"/>
                 <a:cs typeface="에이투지체 8 ExtraBold"/>
               </a:rPr>
-              <a:t>미노출</a:t>
+              <a:t>시작 전</a:t>
             </a:r>
           </a:p>
         </p:txBody>
@@ -25812,7 +25768,7 @@
                 <a:ea typeface="에이투지체 6 SemiBold"/>
                 <a:cs typeface="에이투지체 6 SemiBold"/>
               </a:rPr>
-              <a:t>11번가 주요 검색어 3개</a:t>
+              <a:t>11번가 광고</a:t>
             </a:r>
           </a:p>
         </p:txBody>
@@ -25849,7 +25805,7 @@
                 <a:ea typeface="에이투지체 6 SemiBold"/>
                 <a:cs typeface="에이투지체 6 SemiBold"/>
               </a:rPr>
-              <a:t>11번가 광고는 경쟁사 상품</a:t>
+              <a:t>공식 스토어만 등록된 상태</a:t>
             </a:r>
           </a:p>
         </p:txBody>
@@ -25996,95 +25952,7 @@
                 <a:ea typeface="에이투지체 4 Regular"/>
                 <a:cs typeface="에이투지체 4 Regular"/>
               </a:rPr>
-              <a:t>아이클타임</a:t>
-            </a:r>
-            <a:r>
-              <a:rPr sz="1300" b="0" dirty="0">
-                <a:solidFill>
-                  <a:srgbClr val="5C5C5C"/>
-                </a:solidFill>
-                <a:latin typeface="에이투지체 4 Regular"/>
-                <a:ea typeface="에이투지체 4 Regular"/>
-                <a:cs typeface="에이투지체 4 Regular"/>
-              </a:rPr>
-              <a:t> </a:t>
-            </a:r>
-            <a:r>
-              <a:rPr sz="1300" b="0" dirty="0" err="1">
-                <a:solidFill>
-                  <a:srgbClr val="5C5C5C"/>
-                </a:solidFill>
-                <a:latin typeface="에이투지체 4 Regular"/>
-                <a:ea typeface="에이투지체 4 Regular"/>
-                <a:cs typeface="에이투지체 4 Regular"/>
-              </a:rPr>
-              <a:t>검색</a:t>
-            </a:r>
-            <a:r>
-              <a:rPr sz="1300" b="0" dirty="0">
-                <a:solidFill>
-                  <a:srgbClr val="5C5C5C"/>
-                </a:solidFill>
-                <a:latin typeface="에이투지체 4 Regular"/>
-                <a:ea typeface="에이투지체 4 Regular"/>
-                <a:cs typeface="에이투지체 4 Regular"/>
-              </a:rPr>
-              <a:t> </a:t>
-            </a:r>
-            <a:r>
-              <a:rPr sz="1300" b="0" dirty="0" err="1">
-                <a:solidFill>
-                  <a:srgbClr val="5C5C5C"/>
-                </a:solidFill>
-                <a:latin typeface="에이투지체 4 Regular"/>
-                <a:ea typeface="에이투지체 4 Regular"/>
-                <a:cs typeface="에이투지체 4 Regular"/>
-              </a:rPr>
-              <a:t>결과</a:t>
-            </a:r>
-            <a:r>
-              <a:rPr sz="1300" b="0" dirty="0">
-                <a:solidFill>
-                  <a:srgbClr val="5C5C5C"/>
-                </a:solidFill>
-                <a:latin typeface="에이투지체 4 Regular"/>
-                <a:ea typeface="에이투지체 4 Regular"/>
-                <a:cs typeface="에이투지체 4 Regular"/>
-              </a:rPr>
-              <a:t> </a:t>
-            </a:r>
-            <a:r>
-              <a:rPr sz="1300" b="0" dirty="0" err="1">
-                <a:solidFill>
-                  <a:srgbClr val="5C5C5C"/>
-                </a:solidFill>
-                <a:latin typeface="에이투지체 4 Regular"/>
-                <a:ea typeface="에이투지체 4 Regular"/>
-                <a:cs typeface="에이투지체 4 Regular"/>
-              </a:rPr>
-              <a:t>광고는</a:t>
-            </a:r>
-            <a:r>
-              <a:rPr sz="1300" b="0" dirty="0">
-                <a:solidFill>
-                  <a:srgbClr val="5C5C5C"/>
-                </a:solidFill>
-                <a:latin typeface="에이투지체 4 Regular"/>
-                <a:ea typeface="에이투지체 4 Regular"/>
-                <a:cs typeface="에이투지체 4 Regular"/>
-              </a:rPr>
-              <a:t> </a:t>
-            </a:r>
-            <a:r>
-              <a:rPr sz="1300" b="0" dirty="0" err="1">
-                <a:solidFill>
-                  <a:srgbClr val="5C5C5C"/>
-                </a:solidFill>
-                <a:latin typeface="에이투지체 4 Regular"/>
-                <a:ea typeface="에이투지체 4 Regular"/>
-                <a:cs typeface="에이투지체 4 Regular"/>
-              </a:rPr>
-              <a:t>리셀러</a:t>
+              <a:t>아이클타임 검색 결과 광고는 다른 판매처</a:t>
             </a:r>
             <a:endParaRPr sz="1300" b="0" dirty="0">
               <a:solidFill>

</xml_diff>

<commit_message>
Add Gmarket ad-type legend bar to core-task slide
Co-Authored-By: Claude Opus 5.5 <noreply@anthropic.com>
Claude-Session: https://claude.ai/code/session_01LNckV4PF1WFWnv5VJ442kU
</commit_message>
<xml_diff>
--- a/쿠팡_오픈마켓_11월_261013_취합본.pptx
+++ b/쿠팡_오픈마켓_11월_261013_취합본.pptx
@@ -8394,7 +8394,7 @@
         <p:spPr>
           <a:xfrm>
             <a:off x="548640" y="2395728"/>
-            <a:ext cx="2423160" cy="822960"/>
+            <a:ext cx="2423160" cy="731520"/>
           </a:xfrm>
           <a:prstGeom prst="roundRect">
             <a:avLst>
@@ -8441,7 +8441,7 @@
         <p:spPr>
           <a:xfrm>
             <a:off x="731520" y="2395728"/>
-            <a:ext cx="2148840" cy="822960"/>
+            <a:ext cx="2148840" cy="731520"/>
           </a:xfrm>
           <a:prstGeom prst="rect">
             <a:avLst/>
@@ -8492,7 +8492,7 @@
         <p:spPr>
           <a:xfrm>
             <a:off x="3291840" y="2395728"/>
-            <a:ext cx="3931920" cy="822960"/>
+            <a:ext cx="3931920" cy="731520"/>
           </a:xfrm>
           <a:prstGeom prst="roundRect">
             <a:avLst>
@@ -8539,7 +8539,7 @@
         <p:spPr>
           <a:xfrm>
             <a:off x="3493008" y="2395728"/>
-            <a:ext cx="3611880" cy="822960"/>
+            <a:ext cx="3611880" cy="731520"/>
           </a:xfrm>
           <a:prstGeom prst="rect">
             <a:avLst/>
@@ -8589,7 +8589,7 @@
         </p:nvSpPr>
         <p:spPr>
           <a:xfrm>
-            <a:off x="7543800" y="2560320"/>
+            <a:off x="7543800" y="2514600"/>
             <a:ext cx="2103120" cy="493775"/>
           </a:xfrm>
           <a:prstGeom prst="roundRect">
@@ -8638,7 +8638,7 @@
         </p:nvSpPr>
         <p:spPr>
           <a:xfrm>
-            <a:off x="7635240" y="2560320"/>
+            <a:off x="7635240" y="2514600"/>
             <a:ext cx="1920240" cy="493775"/>
           </a:xfrm>
           <a:prstGeom prst="rect">
@@ -8690,7 +8690,7 @@
         <p:spPr>
           <a:xfrm>
             <a:off x="9966960" y="2395728"/>
-            <a:ext cx="1645920" cy="822960"/>
+            <a:ext cx="1645920" cy="731520"/>
           </a:xfrm>
           <a:prstGeom prst="rect">
             <a:avLst/>
@@ -8740,7 +8740,7 @@
         </p:nvSpPr>
         <p:spPr>
           <a:xfrm rot="5400000">
-            <a:off x="2990088" y="2734056"/>
+            <a:off x="2990088" y="2688336"/>
             <a:ext cx="201168" cy="146304"/>
           </a:xfrm>
           <a:prstGeom prst="triangle">
@@ -8785,7 +8785,7 @@
         </p:nvSpPr>
         <p:spPr>
           <a:xfrm rot="5400000">
-            <a:off x="7242048" y="2734056"/>
+            <a:off x="7242048" y="2688336"/>
             <a:ext cx="201168" cy="146304"/>
           </a:xfrm>
           <a:prstGeom prst="triangle">
@@ -8830,7 +8830,7 @@
         </p:nvSpPr>
         <p:spPr>
           <a:xfrm rot="5400000">
-            <a:off x="9665208" y="2734056"/>
+            <a:off x="9665208" y="2688336"/>
             <a:ext cx="201168" cy="146304"/>
           </a:xfrm>
           <a:prstGeom prst="triangle">
@@ -8875,8 +8875,8 @@
         </p:nvSpPr>
         <p:spPr>
           <a:xfrm>
-            <a:off x="548640" y="3429000"/>
-            <a:ext cx="2423160" cy="822960"/>
+            <a:off x="548640" y="3273552"/>
+            <a:ext cx="2423160" cy="731520"/>
           </a:xfrm>
           <a:prstGeom prst="roundRect">
             <a:avLst>
@@ -8922,8 +8922,8 @@
         </p:nvSpPr>
         <p:spPr>
           <a:xfrm>
-            <a:off x="731520" y="3429000"/>
-            <a:ext cx="2148840" cy="822960"/>
+            <a:off x="731520" y="3273552"/>
+            <a:ext cx="2148840" cy="731520"/>
           </a:xfrm>
           <a:prstGeom prst="rect">
             <a:avLst/>
@@ -8973,8 +8973,8 @@
         </p:nvSpPr>
         <p:spPr>
           <a:xfrm>
-            <a:off x="3291840" y="3429000"/>
-            <a:ext cx="3931920" cy="822960"/>
+            <a:off x="3291840" y="3273552"/>
+            <a:ext cx="3931920" cy="731520"/>
           </a:xfrm>
           <a:prstGeom prst="roundRect">
             <a:avLst>
@@ -9020,8 +9020,8 @@
         </p:nvSpPr>
         <p:spPr>
           <a:xfrm>
-            <a:off x="3493008" y="3429000"/>
-            <a:ext cx="3611880" cy="822960"/>
+            <a:off x="3493008" y="3273552"/>
+            <a:ext cx="3611880" cy="731520"/>
           </a:xfrm>
           <a:prstGeom prst="rect">
             <a:avLst/>
@@ -9071,7 +9071,7 @@
         </p:nvSpPr>
         <p:spPr>
           <a:xfrm>
-            <a:off x="7543800" y="3593592"/>
+            <a:off x="7543800" y="3392424"/>
             <a:ext cx="2103120" cy="493775"/>
           </a:xfrm>
           <a:prstGeom prst="roundRect">
@@ -9120,7 +9120,7 @@
         </p:nvSpPr>
         <p:spPr>
           <a:xfrm>
-            <a:off x="7635240" y="3593592"/>
+            <a:off x="7635240" y="3392424"/>
             <a:ext cx="1920240" cy="493775"/>
           </a:xfrm>
           <a:prstGeom prst="rect">
@@ -9171,8 +9171,8 @@
         </p:nvSpPr>
         <p:spPr>
           <a:xfrm>
-            <a:off x="9966960" y="3429000"/>
-            <a:ext cx="1645920" cy="822960"/>
+            <a:off x="9966960" y="3273552"/>
+            <a:ext cx="1645920" cy="731520"/>
           </a:xfrm>
           <a:prstGeom prst="rect">
             <a:avLst/>
@@ -9222,7 +9222,7 @@
         </p:nvSpPr>
         <p:spPr>
           <a:xfrm rot="5400000">
-            <a:off x="2990088" y="3767328"/>
+            <a:off x="2990088" y="3566160"/>
             <a:ext cx="201168" cy="146304"/>
           </a:xfrm>
           <a:prstGeom prst="triangle">
@@ -9267,7 +9267,7 @@
         </p:nvSpPr>
         <p:spPr>
           <a:xfrm rot="5400000">
-            <a:off x="7242048" y="3767328"/>
+            <a:off x="7242048" y="3566160"/>
             <a:ext cx="201168" cy="146304"/>
           </a:xfrm>
           <a:prstGeom prst="triangle">
@@ -9312,7 +9312,7 @@
         </p:nvSpPr>
         <p:spPr>
           <a:xfrm rot="5400000">
-            <a:off x="9665208" y="3767328"/>
+            <a:off x="9665208" y="3566160"/>
             <a:ext cx="201168" cy="146304"/>
           </a:xfrm>
           <a:prstGeom prst="triangle">
@@ -9357,8 +9357,8 @@
         </p:nvSpPr>
         <p:spPr>
           <a:xfrm>
-            <a:off x="548640" y="4462272"/>
-            <a:ext cx="2423160" cy="822960"/>
+            <a:off x="548640" y="4151376"/>
+            <a:ext cx="2423160" cy="731520"/>
           </a:xfrm>
           <a:prstGeom prst="roundRect">
             <a:avLst>
@@ -9404,8 +9404,8 @@
         </p:nvSpPr>
         <p:spPr>
           <a:xfrm>
-            <a:off x="731520" y="4462272"/>
-            <a:ext cx="2148840" cy="822960"/>
+            <a:off x="731520" y="4151376"/>
+            <a:ext cx="2148840" cy="731520"/>
           </a:xfrm>
           <a:prstGeom prst="rect">
             <a:avLst/>
@@ -9455,8 +9455,8 @@
         </p:nvSpPr>
         <p:spPr>
           <a:xfrm>
-            <a:off x="3291840" y="4462272"/>
-            <a:ext cx="3931920" cy="822960"/>
+            <a:off x="3291840" y="4151376"/>
+            <a:ext cx="3931920" cy="731520"/>
           </a:xfrm>
           <a:prstGeom prst="roundRect">
             <a:avLst>
@@ -9502,8 +9502,8 @@
         </p:nvSpPr>
         <p:spPr>
           <a:xfrm>
-            <a:off x="3493008" y="4462272"/>
-            <a:ext cx="3611880" cy="822960"/>
+            <a:off x="3493008" y="4151376"/>
+            <a:ext cx="3611880" cy="731520"/>
           </a:xfrm>
           <a:prstGeom prst="rect">
             <a:avLst/>
@@ -9553,7 +9553,7 @@
         </p:nvSpPr>
         <p:spPr>
           <a:xfrm>
-            <a:off x="7543800" y="4626864"/>
+            <a:off x="7543800" y="4270248"/>
             <a:ext cx="2103120" cy="493775"/>
           </a:xfrm>
           <a:prstGeom prst="roundRect">
@@ -9602,7 +9602,7 @@
         </p:nvSpPr>
         <p:spPr>
           <a:xfrm>
-            <a:off x="7635240" y="4626864"/>
+            <a:off x="7635240" y="4270248"/>
             <a:ext cx="1920240" cy="493775"/>
           </a:xfrm>
           <a:prstGeom prst="rect">
@@ -9653,8 +9653,8 @@
         </p:nvSpPr>
         <p:spPr>
           <a:xfrm>
-            <a:off x="9966960" y="4462272"/>
-            <a:ext cx="1645920" cy="822960"/>
+            <a:off x="9966960" y="4151376"/>
+            <a:ext cx="1645920" cy="731520"/>
           </a:xfrm>
           <a:prstGeom prst="rect">
             <a:avLst/>
@@ -9704,7 +9704,7 @@
         </p:nvSpPr>
         <p:spPr>
           <a:xfrm rot="5400000">
-            <a:off x="2990088" y="4800600"/>
+            <a:off x="2990088" y="4443984"/>
             <a:ext cx="201168" cy="146304"/>
           </a:xfrm>
           <a:prstGeom prst="triangle">
@@ -9749,7 +9749,7 @@
         </p:nvSpPr>
         <p:spPr>
           <a:xfrm rot="5400000">
-            <a:off x="7242048" y="4800600"/>
+            <a:off x="7242048" y="4443984"/>
             <a:ext cx="201168" cy="146304"/>
           </a:xfrm>
           <a:prstGeom prst="triangle">
@@ -9794,7 +9794,7 @@
         </p:nvSpPr>
         <p:spPr>
           <a:xfrm rot="5400000">
-            <a:off x="9665208" y="4800600"/>
+            <a:off x="9665208" y="4443984"/>
             <a:ext cx="201168" cy="146304"/>
           </a:xfrm>
           <a:prstGeom prst="triangle">
@@ -9828,6 +9828,101 @@
           <a:p>
             <a:pPr algn="ctr"/>
             <a:endParaRPr/>
+          </a:p>
+        </p:txBody>
+      </p:sp>
+      <p:sp>
+        <p:nvSpPr>
+          <p:cNvPr id="44" name="Type Note Bar"/>
+          <p:cNvSpPr/>
+          <p:nvPr/>
+        </p:nvSpPr>
+        <p:spPr>
+          <a:xfrm>
+            <a:off x="548640" y="5102352"/>
+            <a:ext cx="11064240" cy="365760"/>
+          </a:xfrm>
+          <a:prstGeom prst="roundRect">
+            <a:avLst>
+              <a:gd name="adj" fmla="val 20000"/>
+            </a:avLst>
+          </a:prstGeom>
+          <a:solidFill>
+            <a:srgbClr val="F5F5F5"/>
+          </a:solidFill>
+          <a:ln>
+            <a:noFill/>
+          </a:ln>
+          <a:effectLst/>
+        </p:spPr>
+        <p:style>
+          <a:lnRef idx="1">
+            <a:schemeClr val="accent1"/>
+          </a:lnRef>
+          <a:fillRef idx="3">
+            <a:schemeClr val="accent1"/>
+          </a:fillRef>
+          <a:effectRef idx="2">
+            <a:schemeClr val="accent1"/>
+          </a:effectRef>
+          <a:fontRef idx="minor">
+            <a:schemeClr val="lt1"/>
+          </a:fontRef>
+        </p:style>
+        <p:txBody>
+          <a:bodyPr rtlCol="0" anchor="ctr"/>
+          <a:lstStyle/>
+          <a:p>
+            <a:pPr algn="ctr"/>
+            <a:endParaRPr/>
+          </a:p>
+        </p:txBody>
+      </p:sp>
+      <p:sp>
+        <p:nvSpPr>
+          <p:cNvPr id="45" name="Type Note Text"/>
+          <p:cNvSpPr txBox="1"/>
+          <p:nvPr/>
+        </p:nvSpPr>
+        <p:spPr>
+          <a:xfrm>
+            <a:off x="731520" y="5102352"/>
+            <a:ext cx="10698480" cy="365760"/>
+          </a:xfrm>
+          <a:prstGeom prst="rect">
+            <a:avLst/>
+          </a:prstGeom>
+          <a:noFill/>
+        </p:spPr>
+        <p:txBody>
+          <a:bodyPr wrap="square" lIns="0" tIns="0" rIns="0" bIns="0" anchor="ctr">
+            <a:spAutoFit/>
+          </a:bodyPr>
+          <a:lstStyle/>
+          <a:p>
+            <a:pPr algn="l"/>
+            <a:r>
+              <a:rPr sz="1150" b="0">
+                <a:solidFill>
+                  <a:srgbClr val="004F9F"/>
+                </a:solidFill>
+                <a:latin typeface="에이투지체 6 SemiBold"/>
+                <a:ea typeface="에이투지체 6 SemiBold"/>
+                <a:cs typeface="에이투지체 6 SemiBold"/>
+              </a:rPr>
+              <a:t>운영형  </a:t>
+            </a:r>
+            <a:r>
+              <a:rPr sz="1150" b="0">
+                <a:solidFill>
+                  <a:srgbClr val="222222"/>
+                </a:solidFill>
+                <a:latin typeface="에이투지체 5 Medium"/>
+                <a:ea typeface="에이투지체 5 Medium"/>
+                <a:cs typeface="에이투지체 5 Medium"/>
+              </a:rPr>
+              <a:t>통합: 상품·입찰 모두 AI  /  집중: 상품 선택, 입찰 AI  /  직접: 상품·키워드·입찰가 직접 설정</a:t>
+            </a:r>
           </a:p>
         </p:txBody>
       </p:sp>

</xml_diff>

<commit_message>
Drop own-brand search angle on Coupang, renumber tasks to new order, reapply 11st consolidation
Co-Authored-By: Claude Opus 5.5 <noreply@anthropic.com>
Claude-Session: https://claude.ai/code/session_01LNckV4PF1WFWnv5VJ442kU
</commit_message>
<xml_diff>
--- a/쿠팡_오픈마켓_11월_261013_취합본.pptx
+++ b/쿠팡_오픈마켓_11월_261013_취합본.pptx
@@ -5459,7 +5459,7 @@
                 <a:ea typeface="에이투지체 8 ExtraBold"/>
                 <a:cs typeface="에이투지체 8 ExtraBold"/>
               </a:rPr>
-              <a:t>경쟁사 광고</a:t>
+              <a:t>미노출</a:t>
             </a:r>
           </a:p>
         </p:txBody>
@@ -5496,73 +5496,7 @@
                 <a:ea typeface="에이투지체 6 SemiBold"/>
                 <a:cs typeface="에이투지체 6 SemiBold"/>
               </a:rPr>
-              <a:t>자사</a:t>
-            </a:r>
-            <a:r>
-              <a:rPr sz="1150" b="0" dirty="0">
-                <a:solidFill>
-                  <a:srgbClr val="C9DAEE"/>
-                </a:solidFill>
-                <a:latin typeface="에이투지체 6 SemiBold"/>
-                <a:ea typeface="에이투지체 6 SemiBold"/>
-                <a:cs typeface="에이투지체 6 SemiBold"/>
-              </a:rPr>
-              <a:t> </a:t>
-            </a:r>
-            <a:r>
-              <a:rPr sz="1150" b="0" dirty="0" err="1">
-                <a:solidFill>
-                  <a:srgbClr val="C9DAEE"/>
-                </a:solidFill>
-                <a:latin typeface="에이투지체 6 SemiBold"/>
-                <a:ea typeface="에이투지체 6 SemiBold"/>
-                <a:cs typeface="에이투지체 6 SemiBold"/>
-              </a:rPr>
-              <a:t>브랜드</a:t>
-            </a:r>
-            <a:r>
-              <a:rPr sz="1150" b="0" dirty="0">
-                <a:solidFill>
-                  <a:srgbClr val="C9DAEE"/>
-                </a:solidFill>
-                <a:latin typeface="에이투지체 6 SemiBold"/>
-                <a:ea typeface="에이투지체 6 SemiBold"/>
-                <a:cs typeface="에이투지체 6 SemiBold"/>
-              </a:rPr>
-              <a:t> </a:t>
-            </a:r>
-            <a:r>
-              <a:rPr lang="ko-KR" altLang="en-US" sz="1150" dirty="0">
-                <a:solidFill>
-                  <a:srgbClr val="C9DAEE"/>
-                </a:solidFill>
-                <a:latin typeface="에이투지체 6 SemiBold"/>
-                <a:ea typeface="에이투지체 6 SemiBold"/>
-                <a:cs typeface="에이투지체 6 SemiBold"/>
-              </a:rPr>
-              <a:t>키워드</a:t>
-            </a:r>
-            <a:r>
-              <a:rPr sz="1150" b="0" dirty="0">
-                <a:solidFill>
-                  <a:srgbClr val="C9DAEE"/>
-                </a:solidFill>
-                <a:latin typeface="에이투지체 6 SemiBold"/>
-                <a:ea typeface="에이투지체 6 SemiBold"/>
-                <a:cs typeface="에이투지체 6 SemiBold"/>
-              </a:rPr>
-              <a:t> </a:t>
-            </a:r>
-            <a:r>
-              <a:rPr lang="ko-KR" altLang="en-US" sz="1150" b="0" dirty="0">
-                <a:solidFill>
-                  <a:srgbClr val="C9DAEE"/>
-                </a:solidFill>
-                <a:latin typeface="에이투지체 6 SemiBold"/>
-                <a:ea typeface="에이투지체 6 SemiBold"/>
-                <a:cs typeface="에이투지체 6 SemiBold"/>
-              </a:rPr>
-              <a:t>검색 결과</a:t>
+              <a:t>경쟁사 브랜드 검색 결과</a:t>
             </a:r>
             <a:endParaRPr sz="1150" b="0" dirty="0">
               <a:solidFill>
@@ -5607,95 +5541,7 @@
                 <a:ea typeface="에이투지체 6 SemiBold"/>
                 <a:cs typeface="에이투지체 6 SemiBold"/>
               </a:rPr>
-              <a:t>브랜드</a:t>
-            </a:r>
-            <a:r>
-              <a:rPr sz="1575" b="0" dirty="0">
-                <a:solidFill>
-                  <a:srgbClr val="222222"/>
-                </a:solidFill>
-                <a:latin typeface="에이투지체 6 SemiBold"/>
-                <a:ea typeface="에이투지체 6 SemiBold"/>
-                <a:cs typeface="에이투지체 6 SemiBold"/>
-              </a:rPr>
-              <a:t> </a:t>
-            </a:r>
-            <a:r>
-              <a:rPr sz="1575" b="0" dirty="0" err="1">
-                <a:solidFill>
-                  <a:srgbClr val="222222"/>
-                </a:solidFill>
-                <a:latin typeface="에이투지체 6 SemiBold"/>
-                <a:ea typeface="에이투지체 6 SemiBold"/>
-                <a:cs typeface="에이투지체 6 SemiBold"/>
-              </a:rPr>
-              <a:t>검색어에</a:t>
-            </a:r>
-            <a:r>
-              <a:rPr sz="1575" b="0" dirty="0">
-                <a:solidFill>
-                  <a:srgbClr val="222222"/>
-                </a:solidFill>
-                <a:latin typeface="에이투지체 6 SemiBold"/>
-                <a:ea typeface="에이투지체 6 SemiBold"/>
-                <a:cs typeface="에이투지체 6 SemiBold"/>
-              </a:rPr>
-              <a:t> </a:t>
-            </a:r>
-            <a:r>
-              <a:rPr sz="1575" b="0" dirty="0" err="1">
-                <a:solidFill>
-                  <a:srgbClr val="222222"/>
-                </a:solidFill>
-                <a:latin typeface="에이투지체 6 SemiBold"/>
-                <a:ea typeface="에이투지체 6 SemiBold"/>
-                <a:cs typeface="에이투지체 6 SemiBold"/>
-              </a:rPr>
-              <a:t>경쟁사</a:t>
-            </a:r>
-            <a:r>
-              <a:rPr sz="1575" b="0" dirty="0">
-                <a:solidFill>
-                  <a:srgbClr val="222222"/>
-                </a:solidFill>
-                <a:latin typeface="에이투지체 6 SemiBold"/>
-                <a:ea typeface="에이투지체 6 SemiBold"/>
-                <a:cs typeface="에이투지체 6 SemiBold"/>
-              </a:rPr>
-              <a:t> </a:t>
-            </a:r>
-            <a:r>
-              <a:rPr sz="1575" b="0" dirty="0" err="1">
-                <a:solidFill>
-                  <a:srgbClr val="222222"/>
-                </a:solidFill>
-                <a:latin typeface="에이투지체 6 SemiBold"/>
-                <a:ea typeface="에이투지체 6 SemiBold"/>
-                <a:cs typeface="에이투지체 6 SemiBold"/>
-              </a:rPr>
-              <a:t>광고</a:t>
-            </a:r>
-            <a:r>
-              <a:rPr sz="1575" b="0" dirty="0">
-                <a:solidFill>
-                  <a:srgbClr val="222222"/>
-                </a:solidFill>
-                <a:latin typeface="에이투지체 6 SemiBold"/>
-                <a:ea typeface="에이투지체 6 SemiBold"/>
-                <a:cs typeface="에이투지체 6 SemiBold"/>
-              </a:rPr>
-              <a:t> </a:t>
-            </a:r>
-            <a:r>
-              <a:rPr sz="1575" b="0" dirty="0" err="1">
-                <a:solidFill>
-                  <a:srgbClr val="222222"/>
-                </a:solidFill>
-                <a:latin typeface="에이투지체 6 SemiBold"/>
-                <a:ea typeface="에이투지체 6 SemiBold"/>
-                <a:cs typeface="에이투지체 6 SemiBold"/>
-              </a:rPr>
-              <a:t>노출</a:t>
+              <a:t>경쟁사 브랜드 검색에 두드림 없음</a:t>
             </a:r>
             <a:endParaRPr sz="1575" b="0" dirty="0">
               <a:solidFill>
@@ -5738,8 +5584,10 @@
                 <a:latin typeface="에이투지체 4 Regular"/>
                 <a:ea typeface="에이투지체 4 Regular"/>
               </a:rPr>
-              <a:t>아이클타임</a:t>
-            </a:r>
+              <a:t>키움정, 하우투키 검색 결과에</a:t>
+            </a:r>
+          </a:p>
+          <a:p>
             <a:r>
               <a:rPr lang="ko-KR" altLang="ko-KR" sz="1300" dirty="0">
                 <a:solidFill>
@@ -5748,7 +5596,7 @@
                 <a:latin typeface="에이투지체 4 Regular"/>
                 <a:ea typeface="에이투지체 4 Regular"/>
               </a:rPr>
-              <a:t> 검색 첫 줄에 경쟁사가 광고</a:t>
+              <a:t>두드림 상품 노출 없음</a:t>
             </a:r>
           </a:p>
           <a:p>
@@ -5760,19 +5608,7 @@
                 <a:latin typeface="에이투지체 4 Regular"/>
                 <a:ea typeface="에이투지체 4 Regular"/>
               </a:rPr>
-              <a:t>반대로 경쟁사 브랜드 검색 결과에는</a:t>
-            </a:r>
-          </a:p>
-          <a:p>
-            <a:r>
-              <a:rPr lang="ko-KR" altLang="ko-KR" sz="1300" dirty="0">
-                <a:solidFill>
-                  <a:srgbClr val="5C5C5C"/>
-                </a:solidFill>
-                <a:latin typeface="에이투지체 4 Regular"/>
-                <a:ea typeface="에이투지체 4 Regular"/>
-              </a:rPr>
-              <a:t>두드림 노출 없음</a:t>
+              <a:t>경쟁사 상품만 노출</a:t>
             </a:r>
             <a:br>
               <a:rPr lang="ko-KR" altLang="ko-KR" sz="1300" dirty="0">
@@ -14273,147 +14109,7 @@
                 <a:ea typeface="에이투지체 8 ExtraBold"/>
                 <a:cs typeface="에이투지체 8 ExtraBold"/>
               </a:rPr>
-              <a:t>아이클타임</a:t>
-            </a:r>
-            <a:r>
-              <a:rPr sz="1900" b="0" dirty="0">
-                <a:solidFill>
-                  <a:srgbClr val="FFFFFF"/>
-                </a:solidFill>
-                <a:highlight>
-                  <a:srgbClr val="0000FF"/>
-                </a:highlight>
-                <a:latin typeface="에이투지체 8 ExtraBold"/>
-                <a:ea typeface="에이투지체 8 ExtraBold"/>
-                <a:cs typeface="에이투지체 8 ExtraBold"/>
-              </a:rPr>
-              <a:t> </a:t>
-            </a:r>
-            <a:r>
-              <a:rPr sz="1900" b="0" dirty="0" err="1">
-                <a:solidFill>
-                  <a:srgbClr val="FFFFFF"/>
-                </a:solidFill>
-                <a:highlight>
-                  <a:srgbClr val="0000FF"/>
-                </a:highlight>
-                <a:latin typeface="에이투지체 8 ExtraBold"/>
-                <a:ea typeface="에이투지체 8 ExtraBold"/>
-                <a:cs typeface="에이투지체 8 ExtraBold"/>
-              </a:rPr>
-              <a:t>검색</a:t>
-            </a:r>
-            <a:r>
-              <a:rPr sz="1900" b="0" dirty="0">
-                <a:solidFill>
-                  <a:srgbClr val="FFFFFF"/>
-                </a:solidFill>
-                <a:highlight>
-                  <a:srgbClr val="0000FF"/>
-                </a:highlight>
-                <a:latin typeface="에이투지체 8 ExtraBold"/>
-                <a:ea typeface="에이투지체 8 ExtraBold"/>
-                <a:cs typeface="에이투지체 8 ExtraBold"/>
-              </a:rPr>
-              <a:t> </a:t>
-            </a:r>
-            <a:r>
-              <a:rPr sz="1900" b="0" dirty="0" err="1">
-                <a:solidFill>
-                  <a:srgbClr val="FFFFFF"/>
-                </a:solidFill>
-                <a:highlight>
-                  <a:srgbClr val="0000FF"/>
-                </a:highlight>
-                <a:latin typeface="에이투지체 8 ExtraBold"/>
-                <a:ea typeface="에이투지체 8 ExtraBold"/>
-                <a:cs typeface="에이투지체 8 ExtraBold"/>
-              </a:rPr>
-              <a:t>결과에</a:t>
-            </a:r>
-            <a:r>
-              <a:rPr sz="1900" b="0" dirty="0">
-                <a:solidFill>
-                  <a:srgbClr val="FFFFFF"/>
-                </a:solidFill>
-                <a:highlight>
-                  <a:srgbClr val="0000FF"/>
-                </a:highlight>
-                <a:latin typeface="에이투지체 8 ExtraBold"/>
-                <a:ea typeface="에이투지체 8 ExtraBold"/>
-                <a:cs typeface="에이투지체 8 ExtraBold"/>
-              </a:rPr>
-              <a:t> </a:t>
-            </a:r>
-            <a:r>
-              <a:rPr sz="1900" b="0" dirty="0" err="1">
-                <a:solidFill>
-                  <a:srgbClr val="FFFFFF"/>
-                </a:solidFill>
-                <a:highlight>
-                  <a:srgbClr val="0000FF"/>
-                </a:highlight>
-                <a:latin typeface="에이투지체 8 ExtraBold"/>
-                <a:ea typeface="에이투지체 8 ExtraBold"/>
-                <a:cs typeface="에이투지체 8 ExtraBold"/>
-              </a:rPr>
-              <a:t>경쟁사</a:t>
-            </a:r>
-            <a:r>
-              <a:rPr sz="1900" b="0" dirty="0">
-                <a:solidFill>
-                  <a:srgbClr val="FFFFFF"/>
-                </a:solidFill>
-                <a:highlight>
-                  <a:srgbClr val="0000FF"/>
-                </a:highlight>
-                <a:latin typeface="에이투지체 8 ExtraBold"/>
-                <a:ea typeface="에이투지체 8 ExtraBold"/>
-                <a:cs typeface="에이투지체 8 ExtraBold"/>
-              </a:rPr>
-              <a:t> </a:t>
-            </a:r>
-            <a:r>
-              <a:rPr sz="1900" b="0" dirty="0" err="1">
-                <a:solidFill>
-                  <a:srgbClr val="FFFFFF"/>
-                </a:solidFill>
-                <a:highlight>
-                  <a:srgbClr val="0000FF"/>
-                </a:highlight>
-                <a:latin typeface="에이투지체 8 ExtraBold"/>
-                <a:ea typeface="에이투지체 8 ExtraBold"/>
-                <a:cs typeface="에이투지체 8 ExtraBold"/>
-              </a:rPr>
-              <a:t>광고가</a:t>
-            </a:r>
-            <a:r>
-              <a:rPr sz="1900" b="0" dirty="0">
-                <a:solidFill>
-                  <a:srgbClr val="FFFFFF"/>
-                </a:solidFill>
-                <a:highlight>
-                  <a:srgbClr val="0000FF"/>
-                </a:highlight>
-                <a:latin typeface="에이투지체 8 ExtraBold"/>
-                <a:ea typeface="에이투지체 8 ExtraBold"/>
-                <a:cs typeface="에이투지체 8 ExtraBold"/>
-              </a:rPr>
-              <a:t> </a:t>
-            </a:r>
-            <a:r>
-              <a:rPr sz="1900" b="0" dirty="0" err="1">
-                <a:solidFill>
-                  <a:srgbClr val="FFFFFF"/>
-                </a:solidFill>
-                <a:highlight>
-                  <a:srgbClr val="0000FF"/>
-                </a:highlight>
-                <a:latin typeface="에이투지체 8 ExtraBold"/>
-                <a:ea typeface="에이투지체 8 ExtraBold"/>
-                <a:cs typeface="에이투지체 8 ExtraBold"/>
-              </a:rPr>
-              <a:t>나오고</a:t>
+              <a:t>경쟁사 브랜드 검색 결과에는</a:t>
             </a:r>
             <a:endParaRPr sz="1900" b="0" dirty="0">
               <a:solidFill>
@@ -14442,139 +14138,7 @@
                 <a:ea typeface="에이투지체 8 ExtraBold"/>
                 <a:cs typeface="에이투지체 8 ExtraBold"/>
               </a:rPr>
-              <a:t>경쟁사</a:t>
-            </a:r>
-            <a:r>
-              <a:rPr sz="1900" b="0" dirty="0">
-                <a:solidFill>
-                  <a:srgbClr val="222222"/>
-                </a:solidFill>
-                <a:latin typeface="에이투지체 8 ExtraBold"/>
-                <a:ea typeface="에이투지체 8 ExtraBold"/>
-                <a:cs typeface="에이투지체 8 ExtraBold"/>
-              </a:rPr>
-              <a:t> </a:t>
-            </a:r>
-            <a:r>
-              <a:rPr sz="1900" b="0" dirty="0" err="1">
-                <a:solidFill>
-                  <a:srgbClr val="222222"/>
-                </a:solidFill>
-                <a:latin typeface="에이투지체 8 ExtraBold"/>
-                <a:ea typeface="에이투지체 8 ExtraBold"/>
-                <a:cs typeface="에이투지체 8 ExtraBold"/>
-              </a:rPr>
-              <a:t>브랜드</a:t>
-            </a:r>
-            <a:r>
-              <a:rPr sz="1900" b="0" dirty="0">
-                <a:solidFill>
-                  <a:srgbClr val="222222"/>
-                </a:solidFill>
-                <a:latin typeface="에이투지체 8 ExtraBold"/>
-                <a:ea typeface="에이투지체 8 ExtraBold"/>
-                <a:cs typeface="에이투지체 8 ExtraBold"/>
-              </a:rPr>
-              <a:t> </a:t>
-            </a:r>
-            <a:r>
-              <a:rPr sz="1900" b="0" dirty="0" err="1">
-                <a:solidFill>
-                  <a:srgbClr val="222222"/>
-                </a:solidFill>
-                <a:latin typeface="에이투지체 8 ExtraBold"/>
-                <a:ea typeface="에이투지체 8 ExtraBold"/>
-                <a:cs typeface="에이투지체 8 ExtraBold"/>
-              </a:rPr>
-              <a:t>검색</a:t>
-            </a:r>
-            <a:r>
-              <a:rPr sz="1900" b="0" dirty="0">
-                <a:solidFill>
-                  <a:srgbClr val="222222"/>
-                </a:solidFill>
-                <a:latin typeface="에이투지체 8 ExtraBold"/>
-                <a:ea typeface="에이투지체 8 ExtraBold"/>
-                <a:cs typeface="에이투지체 8 ExtraBold"/>
-              </a:rPr>
-              <a:t> </a:t>
-            </a:r>
-            <a:r>
-              <a:rPr sz="1900" b="0" dirty="0" err="1">
-                <a:solidFill>
-                  <a:srgbClr val="222222"/>
-                </a:solidFill>
-                <a:latin typeface="에이투지체 8 ExtraBold"/>
-                <a:ea typeface="에이투지체 8 ExtraBold"/>
-                <a:cs typeface="에이투지체 8 ExtraBold"/>
-              </a:rPr>
-              <a:t>결과에는</a:t>
-            </a:r>
-            <a:r>
-              <a:rPr sz="1900" b="0" dirty="0">
-                <a:solidFill>
-                  <a:srgbClr val="222222"/>
-                </a:solidFill>
-                <a:latin typeface="에이투지체 8 ExtraBold"/>
-                <a:ea typeface="에이투지체 8 ExtraBold"/>
-                <a:cs typeface="에이투지체 8 ExtraBold"/>
-              </a:rPr>
-              <a:t> </a:t>
-            </a:r>
-            <a:r>
-              <a:rPr sz="1900" b="0" dirty="0" err="1">
-                <a:solidFill>
-                  <a:srgbClr val="222222"/>
-                </a:solidFill>
-                <a:latin typeface="에이투지체 8 ExtraBold"/>
-                <a:ea typeface="에이투지체 8 ExtraBold"/>
-                <a:cs typeface="에이투지체 8 ExtraBold"/>
-              </a:rPr>
-              <a:t>두드림</a:t>
-            </a:r>
-            <a:r>
-              <a:rPr sz="1900" b="0" dirty="0">
-                <a:solidFill>
-                  <a:srgbClr val="222222"/>
-                </a:solidFill>
-                <a:latin typeface="에이투지체 8 ExtraBold"/>
-                <a:ea typeface="에이투지체 8 ExtraBold"/>
-                <a:cs typeface="에이투지체 8 ExtraBold"/>
-              </a:rPr>
-              <a:t> </a:t>
-            </a:r>
-            <a:r>
-              <a:rPr sz="1900" b="0" dirty="0" err="1">
-                <a:solidFill>
-                  <a:srgbClr val="222222"/>
-                </a:solidFill>
-                <a:latin typeface="에이투지체 8 ExtraBold"/>
-                <a:ea typeface="에이투지체 8 ExtraBold"/>
-                <a:cs typeface="에이투지체 8 ExtraBold"/>
-              </a:rPr>
-              <a:t>상품이</a:t>
-            </a:r>
-            <a:r>
-              <a:rPr sz="1900" b="0" dirty="0">
-                <a:solidFill>
-                  <a:srgbClr val="222222"/>
-                </a:solidFill>
-                <a:latin typeface="에이투지체 8 ExtraBold"/>
-                <a:ea typeface="에이투지체 8 ExtraBold"/>
-                <a:cs typeface="에이투지체 8 ExtraBold"/>
-              </a:rPr>
-              <a:t> </a:t>
-            </a:r>
-            <a:r>
-              <a:rPr sz="1900" b="0" dirty="0" err="1">
-                <a:solidFill>
-                  <a:srgbClr val="222222"/>
-                </a:solidFill>
-                <a:latin typeface="에이투지체 8 ExtraBold"/>
-                <a:ea typeface="에이투지체 8 ExtraBold"/>
-                <a:cs typeface="에이투지체 8 ExtraBold"/>
-              </a:rPr>
-              <a:t>없습니다</a:t>
+              <a:t>두드림 상품이 없습니다</a:t>
             </a:r>
             <a:endParaRPr sz="1900" b="0" dirty="0">
               <a:solidFill>
@@ -14617,95 +14181,7 @@
                 <a:ea typeface="에이투지체 5 Medium"/>
                 <a:cs typeface="에이투지체 5 Medium"/>
               </a:rPr>
-              <a:t>쿠팡</a:t>
-            </a:r>
-            <a:r>
-              <a:rPr sz="1100" b="0" dirty="0">
-                <a:solidFill>
-                  <a:srgbClr val="5C5C5C"/>
-                </a:solidFill>
-                <a:latin typeface="에이투지체 5 Medium"/>
-                <a:ea typeface="에이투지체 5 Medium"/>
-                <a:cs typeface="에이투지체 5 Medium"/>
-              </a:rPr>
-              <a:t> </a:t>
-            </a:r>
-            <a:r>
-              <a:rPr sz="1100" b="0" dirty="0" err="1">
-                <a:solidFill>
-                  <a:srgbClr val="5C5C5C"/>
-                </a:solidFill>
-                <a:latin typeface="에이투지체 5 Medium"/>
-                <a:ea typeface="에이투지체 5 Medium"/>
-                <a:cs typeface="에이투지체 5 Medium"/>
-              </a:rPr>
-              <a:t>현황</a:t>
-            </a:r>
-            <a:r>
-              <a:rPr sz="1100" b="0" dirty="0">
-                <a:solidFill>
-                  <a:srgbClr val="5C5C5C"/>
-                </a:solidFill>
-                <a:latin typeface="에이투지체 5 Medium"/>
-                <a:ea typeface="에이투지체 5 Medium"/>
-                <a:cs typeface="에이투지체 5 Medium"/>
-              </a:rPr>
-              <a:t> </a:t>
-            </a:r>
-            <a:r>
-              <a:rPr sz="1100" b="0" dirty="0" err="1">
-                <a:solidFill>
-                  <a:srgbClr val="5C5C5C"/>
-                </a:solidFill>
-                <a:latin typeface="에이투지체 5 Medium"/>
-                <a:ea typeface="에이투지체 5 Medium"/>
-                <a:cs typeface="에이투지체 5 Medium"/>
-              </a:rPr>
-              <a:t>진단</a:t>
-            </a:r>
-            <a:r>
-              <a:rPr sz="1100" b="0" dirty="0">
-                <a:solidFill>
-                  <a:srgbClr val="5C5C5C"/>
-                </a:solidFill>
-                <a:latin typeface="에이투지체 5 Medium"/>
-                <a:ea typeface="에이투지체 5 Medium"/>
-                <a:cs typeface="에이투지체 5 Medium"/>
-              </a:rPr>
-              <a:t> ②  </a:t>
-            </a:r>
-            <a:r>
-              <a:rPr sz="1100" b="0" dirty="0" err="1">
-                <a:solidFill>
-                  <a:srgbClr val="5C5C5C"/>
-                </a:solidFill>
-                <a:latin typeface="에이투지체 5 Medium"/>
-                <a:ea typeface="에이투지체 5 Medium"/>
-                <a:cs typeface="에이투지체 5 Medium"/>
-              </a:rPr>
-              <a:t>브랜드</a:t>
-            </a:r>
-            <a:r>
-              <a:rPr sz="1100" b="0" dirty="0">
-                <a:solidFill>
-                  <a:srgbClr val="5C5C5C"/>
-                </a:solidFill>
-                <a:latin typeface="에이투지체 5 Medium"/>
-                <a:ea typeface="에이투지체 5 Medium"/>
-                <a:cs typeface="에이투지체 5 Medium"/>
-              </a:rPr>
-              <a:t> </a:t>
-            </a:r>
-            <a:r>
-              <a:rPr sz="1100" b="0" dirty="0" err="1">
-                <a:solidFill>
-                  <a:srgbClr val="5C5C5C"/>
-                </a:solidFill>
-                <a:latin typeface="에이투지체 5 Medium"/>
-                <a:ea typeface="에이투지체 5 Medium"/>
-                <a:cs typeface="에이투지체 5 Medium"/>
-              </a:rPr>
-              <a:t>검색어</a:t>
+              <a:t>쿠팡 현황 진단 ②  경쟁사 브랜드 검색어</a:t>
             </a:r>
             <a:endParaRPr sz="1100" b="0" dirty="0">
               <a:solidFill>
@@ -14799,7 +14275,7 @@
                 <a:ea typeface="에이투지체 6 SemiBold"/>
                 <a:cs typeface="에이투지체 6 SemiBold"/>
               </a:rPr>
-              <a:t>브랜드 검색어 광고를 유지하면서, 경쟁사 브랜드 검색어도 제외하지 않고 성과를 보겠습니다</a:t>
+              <a:t>경쟁사 브랜드 검색어는 제외하지 않고 노출해 전환 성과를 확인하겠습니다</a:t>
             </a:r>
           </a:p>
         </p:txBody>
@@ -14961,7 +14437,7 @@
         <p:spPr>
           <a:xfrm>
             <a:off x="548640" y="1993392"/>
-            <a:ext cx="5760720" cy="292608"/>
+            <a:ext cx="4593355" cy="292608"/>
           </a:xfrm>
           <a:prstGeom prst="rect">
             <a:avLst/>
@@ -14984,7 +14460,7 @@
                 <a:ea typeface="에이투지체 8 ExtraBold"/>
                 <a:cs typeface="에이투지체 8 ExtraBold"/>
               </a:rPr>
-              <a:t>자사 브랜드  </a:t>
+              <a:t>"키움정" 검색  </a:t>
             </a:r>
             <a:r>
               <a:rPr sz="1250" b="0">
@@ -14995,40 +14471,11 @@
                 <a:ea typeface="에이투지체 6 SemiBold"/>
                 <a:cs typeface="에이투지체 6 SemiBold"/>
               </a:rPr>
-              <a:t>"아이클타임" 검색 결과, 첫 줄에 키움정 광고</a:t>
-            </a:r>
-          </a:p>
-        </p:txBody>
-      </p:sp>
-      <p:pic>
-        <p:nvPicPr>
-          <p:cNvPr id="12" name="Picture 11" descr="aicle.png"/>
-          <p:cNvPicPr>
-            <a:picLocks noChangeAspect="1"/>
-          </p:cNvPicPr>
-          <p:nvPr/>
-        </p:nvPicPr>
-        <p:blipFill>
-          <a:blip r:embed="rId2"/>
-          <a:stretch>
-            <a:fillRect/>
-          </a:stretch>
-        </p:blipFill>
-        <p:spPr>
-          <a:xfrm>
-            <a:off x="548640" y="2331720"/>
-            <a:ext cx="5760720" cy="3174136"/>
-          </a:xfrm>
-          <a:prstGeom prst="rect">
-            <a:avLst/>
-          </a:prstGeom>
-          <a:ln w="9525">
-            <a:solidFill>
-              <a:srgbClr val="DDDDDD"/>
-            </a:solidFill>
-          </a:ln>
-        </p:spPr>
-      </p:pic>
+              <a:t>첫 화면 전부 키움정</a:t>
+            </a:r>
+          </a:p>
+        </p:txBody>
+      </p:sp>
       <p:sp>
         <p:nvSpPr>
           <p:cNvPr id="13" name="TextBox 12"/>
@@ -15037,8 +14484,8 @@
         </p:nvSpPr>
         <p:spPr>
           <a:xfrm>
-            <a:off x="6583680" y="1993392"/>
-            <a:ext cx="5029200" cy="292608"/>
+            <a:off x="6980723" y="1993392"/>
+            <a:ext cx="4632157" cy="292608"/>
           </a:xfrm>
           <a:prstGeom prst="rect">
             <a:avLst/>
@@ -15061,7 +14508,7 @@
                 <a:ea typeface="에이투지체 8 ExtraBold"/>
                 <a:cs typeface="에이투지체 8 ExtraBold"/>
               </a:rPr>
-              <a:t>경쟁사 브랜드  </a:t>
+              <a:t>"하우투키" 검색  </a:t>
             </a:r>
             <a:r>
               <a:rPr sz="1250" b="0">
@@ -15072,7 +14519,7 @@
                 <a:ea typeface="에이투지체 6 SemiBold"/>
                 <a:cs typeface="에이투지체 6 SemiBold"/>
               </a:rPr>
-              <a:t>두드림 노출 없음</a:t>
+              <a:t>젬, 키앤이거 광고 노출</a:t>
             </a:r>
           </a:p>
         </p:txBody>
@@ -15093,8 +14540,8 @@
         </p:blipFill>
         <p:spPr>
           <a:xfrm>
-            <a:off x="6583680" y="2331720"/>
-            <a:ext cx="2697480" cy="1503566"/>
+            <a:off x="548640" y="2331720"/>
+            <a:ext cx="4593355" cy="2560320"/>
           </a:xfrm>
           <a:prstGeom prst="rect">
             <a:avLst/>
@@ -15106,80 +14553,6 @@
           </a:ln>
         </p:spPr>
       </p:pic>
-      <p:sp>
-        <p:nvSpPr>
-          <p:cNvPr id="15" name="TextBox 14"/>
-          <p:cNvSpPr txBox="1"/>
-          <p:nvPr/>
-        </p:nvSpPr>
-        <p:spPr>
-          <a:xfrm>
-            <a:off x="9464040" y="2606039"/>
-            <a:ext cx="2148840" cy="320040"/>
-          </a:xfrm>
-          <a:prstGeom prst="rect">
-            <a:avLst/>
-          </a:prstGeom>
-          <a:noFill/>
-        </p:spPr>
-        <p:txBody>
-          <a:bodyPr wrap="square" lIns="0" tIns="0" rIns="0" bIns="0" anchor="t">
-            <a:spAutoFit/>
-          </a:bodyPr>
-          <a:lstStyle/>
-          <a:p>
-            <a:pPr algn="l"/>
-            <a:r>
-              <a:rPr sz="1250" b="0">
-                <a:solidFill>
-                  <a:srgbClr val="222222"/>
-                </a:solidFill>
-                <a:latin typeface="에이투지체 8 ExtraBold"/>
-                <a:ea typeface="에이투지체 8 ExtraBold"/>
-                <a:cs typeface="에이투지체 8 ExtraBold"/>
-              </a:rPr>
-              <a:t>"키움정" 검색</a:t>
-            </a:r>
-          </a:p>
-        </p:txBody>
-      </p:sp>
-      <p:sp>
-        <p:nvSpPr>
-          <p:cNvPr id="16" name="TextBox 15"/>
-          <p:cNvSpPr txBox="1"/>
-          <p:nvPr/>
-        </p:nvSpPr>
-        <p:spPr>
-          <a:xfrm>
-            <a:off x="9464040" y="2953512"/>
-            <a:ext cx="2148840" cy="548640"/>
-          </a:xfrm>
-          <a:prstGeom prst="rect">
-            <a:avLst/>
-          </a:prstGeom>
-          <a:noFill/>
-        </p:spPr>
-        <p:txBody>
-          <a:bodyPr wrap="square" lIns="0" tIns="0" rIns="0" bIns="0" anchor="t">
-            <a:spAutoFit/>
-          </a:bodyPr>
-          <a:lstStyle/>
-          <a:p>
-            <a:pPr algn="l"/>
-            <a:r>
-              <a:rPr sz="1150" b="0">
-                <a:solidFill>
-                  <a:srgbClr val="5C5C5C"/>
-                </a:solidFill>
-                <a:latin typeface="에이투지체 4 Regular"/>
-                <a:ea typeface="에이투지체 4 Regular"/>
-                <a:cs typeface="에이투지체 4 Regular"/>
-              </a:rPr>
-              <a:t>첫 화면 전부 키움정</a:t>
-            </a:r>
-          </a:p>
-        </p:txBody>
-      </p:sp>
       <p:pic>
         <p:nvPicPr>
           <p:cNvPr id="17" name="Picture 16" descr="howtoki.png"/>
@@ -15196,8 +14569,8 @@
         </p:blipFill>
         <p:spPr>
           <a:xfrm>
-            <a:off x="6583680" y="3931920"/>
-            <a:ext cx="2697480" cy="1490971"/>
+            <a:off x="6980723" y="2331720"/>
+            <a:ext cx="4632157" cy="2560320"/>
           </a:xfrm>
           <a:prstGeom prst="rect">
             <a:avLst/>
@@ -15209,80 +14582,6 @@
           </a:ln>
         </p:spPr>
       </p:pic>
-      <p:sp>
-        <p:nvSpPr>
-          <p:cNvPr id="18" name="TextBox 17"/>
-          <p:cNvSpPr txBox="1"/>
-          <p:nvPr/>
-        </p:nvSpPr>
-        <p:spPr>
-          <a:xfrm>
-            <a:off x="9464040" y="4206240"/>
-            <a:ext cx="2148840" cy="320040"/>
-          </a:xfrm>
-          <a:prstGeom prst="rect">
-            <a:avLst/>
-          </a:prstGeom>
-          <a:noFill/>
-        </p:spPr>
-        <p:txBody>
-          <a:bodyPr wrap="square" lIns="0" tIns="0" rIns="0" bIns="0" anchor="t">
-            <a:spAutoFit/>
-          </a:bodyPr>
-          <a:lstStyle/>
-          <a:p>
-            <a:pPr algn="l"/>
-            <a:r>
-              <a:rPr sz="1250" b="0">
-                <a:solidFill>
-                  <a:srgbClr val="222222"/>
-                </a:solidFill>
-                <a:latin typeface="에이투지체 8 ExtraBold"/>
-                <a:ea typeface="에이투지체 8 ExtraBold"/>
-                <a:cs typeface="에이투지체 8 ExtraBold"/>
-              </a:rPr>
-              <a:t>"하우투키" 검색</a:t>
-            </a:r>
-          </a:p>
-        </p:txBody>
-      </p:sp>
-      <p:sp>
-        <p:nvSpPr>
-          <p:cNvPr id="19" name="TextBox 18"/>
-          <p:cNvSpPr txBox="1"/>
-          <p:nvPr/>
-        </p:nvSpPr>
-        <p:spPr>
-          <a:xfrm>
-            <a:off x="9464040" y="4553712"/>
-            <a:ext cx="2148840" cy="548640"/>
-          </a:xfrm>
-          <a:prstGeom prst="rect">
-            <a:avLst/>
-          </a:prstGeom>
-          <a:noFill/>
-        </p:spPr>
-        <p:txBody>
-          <a:bodyPr wrap="square" lIns="0" tIns="0" rIns="0" bIns="0" anchor="t">
-            <a:spAutoFit/>
-          </a:bodyPr>
-          <a:lstStyle/>
-          <a:p>
-            <a:pPr algn="l"/>
-            <a:r>
-              <a:rPr sz="1150" b="0">
-                <a:solidFill>
-                  <a:srgbClr val="5C5C5C"/>
-                </a:solidFill>
-                <a:latin typeface="에이투지체 4 Regular"/>
-                <a:ea typeface="에이투지체 4 Regular"/>
-                <a:cs typeface="에이투지체 4 Regular"/>
-              </a:rPr>
-              <a:t>젬, 키앤이거 광고 노출</a:t>
-            </a:r>
-          </a:p>
-        </p:txBody>
-      </p:sp>
     </p:spTree>
   </p:cSld>
   <p:clrMapOvr>
@@ -16560,7 +15859,7 @@
                 <a:ea typeface="에이투지체 5 Medium"/>
                 <a:cs typeface="에이투지체 5 Medium"/>
               </a:rPr>
-              <a:t>쿠팡 핵심과제 2  검색어 노출 확대</a:t>
+              <a:t>쿠팡 핵심과제 1  검색어 노출 확대</a:t>
             </a:r>
           </a:p>
         </p:txBody>
@@ -16985,7 +16284,7 @@
                 <a:ea typeface="에이투지체 4 Regular"/>
                 <a:cs typeface="에이투지체 4 Regular"/>
               </a:rPr>
-              <a:t>아이클타임 첫 줄에 키움정 광고</a:t>
+              <a:t>두드림 상품이 상단에 노출</a:t>
             </a:r>
           </a:p>
         </p:txBody>
@@ -18038,7 +17337,7 @@
                 <a:ea typeface="에이투지체 5 Medium"/>
                 <a:cs typeface="에이투지체 5 Medium"/>
               </a:rPr>
-              <a:t>쿠팡 핵심과제 1  매출 최적화 캠페인의 입찰 방식</a:t>
+              <a:t>쿠팡 핵심과제 2  매출 최적화 캠페인의 입찰 방식</a:t>
             </a:r>
           </a:p>
         </p:txBody>
@@ -19072,7 +18371,7 @@
                 <a:ea typeface="에이투지체 5 Medium"/>
                 <a:cs typeface="에이투지체 5 Medium"/>
               </a:rPr>
-              <a:t>쿠팡 핵심과제 1  객단가 기준 캠페인 구성</a:t>
+              <a:t>쿠팡 핵심과제 2  객단가 기준 캠페인 구성</a:t>
             </a:r>
             <a:endParaRPr lang="ko-KR" sz="1100" dirty="0"/>
           </a:p>
@@ -21273,7 +20572,7 @@
         </p:nvSpPr>
         <p:spPr>
           <a:xfrm>
-            <a:off x="548640" y="2395728"/>
+            <a:off x="594360" y="3758185"/>
             <a:ext cx="2423160" cy="1097280"/>
           </a:xfrm>
           <a:prstGeom prst="roundRect">
@@ -21320,8 +20619,8 @@
         </p:nvSpPr>
         <p:spPr>
           <a:xfrm>
-            <a:off x="731520" y="2395728"/>
-            <a:ext cx="2148840" cy="1097280"/>
+            <a:off x="777240" y="4126006"/>
+            <a:ext cx="2148840" cy="361637"/>
           </a:xfrm>
           <a:prstGeom prst="rect">
             <a:avLst/>
@@ -21336,7 +20635,7 @@
           <a:p>
             <a:pPr algn="l"/>
             <a:r>
-              <a:rPr sz="1050" b="0">
+              <a:rPr sz="1050" b="0" dirty="0">
                 <a:solidFill>
                   <a:srgbClr val="FFFFFF"/>
                 </a:solidFill>
@@ -21344,13 +20643,10 @@
                 <a:ea typeface="에이투지체 6 SemiBold"/>
                 <a:cs typeface="에이투지체 6 SemiBold"/>
               </a:rPr>
-              <a:t>01</a:t>
-            </a:r>
-          </a:p>
-          <a:p>
-            <a:pPr algn="l"/>
-            <a:r>
-              <a:rPr sz="1300" b="0">
+              <a:t>0</a:t>
+            </a:r>
+            <a:r>
+              <a:rPr lang="en-US" sz="1050" b="0" dirty="0">
                 <a:solidFill>
                   <a:srgbClr val="FFFFFF"/>
                 </a:solidFill>
@@ -21358,8 +20654,82 @@
                 <a:ea typeface="에이투지체 6 SemiBold"/>
                 <a:cs typeface="에이투지체 6 SemiBold"/>
               </a:rPr>
-              <a:t>캠페인 구조 정리</a:t>
-            </a:r>
+              <a:t>2</a:t>
+            </a:r>
+            <a:endParaRPr sz="1050" b="0" dirty="0">
+              <a:solidFill>
+                <a:srgbClr val="FFFFFF"/>
+              </a:solidFill>
+              <a:latin typeface="에이투지체 6 SemiBold"/>
+              <a:ea typeface="에이투지체 6 SemiBold"/>
+              <a:cs typeface="에이투지체 6 SemiBold"/>
+            </a:endParaRPr>
+          </a:p>
+          <a:p>
+            <a:pPr algn="l"/>
+            <a:r>
+              <a:rPr sz="1300" b="0" dirty="0" err="1">
+                <a:solidFill>
+                  <a:srgbClr val="FFFFFF"/>
+                </a:solidFill>
+                <a:latin typeface="에이투지체 6 SemiBold"/>
+                <a:ea typeface="에이투지체 6 SemiBold"/>
+                <a:cs typeface="에이투지체 6 SemiBold"/>
+              </a:rPr>
+              <a:t>캠페인</a:t>
+            </a:r>
+            <a:r>
+              <a:rPr sz="1300" b="0" dirty="0">
+                <a:solidFill>
+                  <a:srgbClr val="FFFFFF"/>
+                </a:solidFill>
+                <a:latin typeface="에이투지체 6 SemiBold"/>
+                <a:ea typeface="에이투지체 6 SemiBold"/>
+                <a:cs typeface="에이투지체 6 SemiBold"/>
+              </a:rPr>
+              <a:t> </a:t>
+            </a:r>
+            <a:r>
+              <a:rPr sz="1300" b="0" dirty="0" err="1">
+                <a:solidFill>
+                  <a:srgbClr val="FFFFFF"/>
+                </a:solidFill>
+                <a:latin typeface="에이투지체 6 SemiBold"/>
+                <a:ea typeface="에이투지체 6 SemiBold"/>
+                <a:cs typeface="에이투지체 6 SemiBold"/>
+              </a:rPr>
+              <a:t>구조</a:t>
+            </a:r>
+            <a:r>
+              <a:rPr sz="1300" b="0" dirty="0">
+                <a:solidFill>
+                  <a:srgbClr val="FFFFFF"/>
+                </a:solidFill>
+                <a:latin typeface="에이투지체 6 SemiBold"/>
+                <a:ea typeface="에이투지체 6 SemiBold"/>
+                <a:cs typeface="에이투지체 6 SemiBold"/>
+              </a:rPr>
+              <a:t> </a:t>
+            </a:r>
+            <a:r>
+              <a:rPr sz="1300" b="0" dirty="0" err="1">
+                <a:solidFill>
+                  <a:srgbClr val="FFFFFF"/>
+                </a:solidFill>
+                <a:latin typeface="에이투지체 6 SemiBold"/>
+                <a:ea typeface="에이투지체 6 SemiBold"/>
+                <a:cs typeface="에이투지체 6 SemiBold"/>
+              </a:rPr>
+              <a:t>정리</a:t>
+            </a:r>
+            <a:endParaRPr sz="1300" b="0" dirty="0">
+              <a:solidFill>
+                <a:srgbClr val="FFFFFF"/>
+              </a:solidFill>
+              <a:latin typeface="에이투지체 6 SemiBold"/>
+              <a:ea typeface="에이투지체 6 SemiBold"/>
+              <a:cs typeface="에이투지체 6 SemiBold"/>
+            </a:endParaRPr>
           </a:p>
         </p:txBody>
       </p:sp>
@@ -21371,7 +20741,7 @@
         </p:nvSpPr>
         <p:spPr>
           <a:xfrm>
-            <a:off x="3291840" y="2395728"/>
+            <a:off x="3337560" y="3758185"/>
             <a:ext cx="3931920" cy="1097280"/>
           </a:xfrm>
           <a:prstGeom prst="roundRect">
@@ -21418,7 +20788,7 @@
         </p:nvSpPr>
         <p:spPr>
           <a:xfrm>
-            <a:off x="3493008" y="2395728"/>
+            <a:off x="3538728" y="3758185"/>
             <a:ext cx="3611880" cy="1097280"/>
           </a:xfrm>
           <a:prstGeom prst="rect">
@@ -21469,7 +20839,7 @@
         </p:nvSpPr>
         <p:spPr>
           <a:xfrm>
-            <a:off x="7543800" y="2697480"/>
+            <a:off x="7589520" y="4059937"/>
             <a:ext cx="2103120" cy="493775"/>
           </a:xfrm>
           <a:prstGeom prst="roundRect">
@@ -21518,7 +20888,7 @@
         </p:nvSpPr>
         <p:spPr>
           <a:xfrm>
-            <a:off x="7635240" y="2697480"/>
+            <a:off x="7680960" y="4059937"/>
             <a:ext cx="1920240" cy="493775"/>
           </a:xfrm>
           <a:prstGeom prst="rect">
@@ -21555,7 +20925,7 @@
         </p:nvSpPr>
         <p:spPr>
           <a:xfrm>
-            <a:off x="9966960" y="2395728"/>
+            <a:off x="10012680" y="3758185"/>
             <a:ext cx="1645920" cy="1097280"/>
           </a:xfrm>
           <a:prstGeom prst="rect">
@@ -21592,7 +20962,7 @@
         </p:nvSpPr>
         <p:spPr>
           <a:xfrm rot="5400000">
-            <a:off x="2990088" y="2871216"/>
+            <a:off x="3035808" y="4233673"/>
             <a:ext cx="201168" cy="146304"/>
           </a:xfrm>
           <a:prstGeom prst="triangle">
@@ -21637,7 +21007,7 @@
         </p:nvSpPr>
         <p:spPr>
           <a:xfrm rot="5400000">
-            <a:off x="7242048" y="2871216"/>
+            <a:off x="7287768" y="4233673"/>
             <a:ext cx="201168" cy="146304"/>
           </a:xfrm>
           <a:prstGeom prst="triangle">
@@ -21682,7 +21052,7 @@
         </p:nvSpPr>
         <p:spPr>
           <a:xfrm rot="5400000">
-            <a:off x="9665208" y="2871216"/>
+            <a:off x="9710928" y="4233673"/>
             <a:ext cx="201168" cy="146304"/>
           </a:xfrm>
           <a:prstGeom prst="triangle">
@@ -21721,13 +21091,114 @@
       </p:sp>
       <p:sp>
         <p:nvSpPr>
-          <p:cNvPr id="24" name="Rounded Rectangle 23"/>
+          <p:cNvPr id="34" name="Event Note Bar"/>
           <p:cNvSpPr/>
           <p:nvPr/>
         </p:nvSpPr>
         <p:spPr>
           <a:xfrm>
-            <a:off x="548640" y="3721608"/>
+            <a:off x="548640" y="5102352"/>
+            <a:ext cx="11064240" cy="365760"/>
+          </a:xfrm>
+          <a:prstGeom prst="roundRect">
+            <a:avLst>
+              <a:gd name="adj" fmla="val 20000"/>
+            </a:avLst>
+          </a:prstGeom>
+          <a:solidFill>
+            <a:srgbClr val="F5F5F5"/>
+          </a:solidFill>
+          <a:ln>
+            <a:noFill/>
+          </a:ln>
+          <a:effectLst/>
+        </p:spPr>
+        <p:style>
+          <a:lnRef idx="1">
+            <a:schemeClr val="accent1"/>
+          </a:lnRef>
+          <a:fillRef idx="3">
+            <a:schemeClr val="accent1"/>
+          </a:fillRef>
+          <a:effectRef idx="2">
+            <a:schemeClr val="accent1"/>
+          </a:effectRef>
+          <a:fontRef idx="minor">
+            <a:schemeClr val="lt1"/>
+          </a:fontRef>
+        </p:style>
+        <p:txBody>
+          <a:bodyPr rtlCol="0" anchor="ctr"/>
+          <a:lstStyle/>
+          <a:p>
+            <a:pPr algn="ctr"/>
+            <a:endParaRPr/>
+          </a:p>
+        </p:txBody>
+      </p:sp>
+      <p:sp>
+        <p:nvSpPr>
+          <p:cNvPr id="35" name="Event Note Text"/>
+          <p:cNvSpPr txBox="1"/>
+          <p:nvPr/>
+        </p:nvSpPr>
+        <p:spPr>
+          <a:xfrm>
+            <a:off x="731520" y="5102352"/>
+            <a:ext cx="10698480" cy="365760"/>
+          </a:xfrm>
+          <a:prstGeom prst="rect">
+            <a:avLst/>
+          </a:prstGeom>
+          <a:noFill/>
+        </p:spPr>
+        <p:txBody>
+          <a:bodyPr wrap="square" lIns="0" tIns="0" rIns="0" bIns="0" anchor="ctr">
+            <a:spAutoFit/>
+          </a:bodyPr>
+          <a:lstStyle/>
+          <a:p>
+            <a:pPr algn="l"/>
+            <a:r>
+              <a:rPr sz="1150" b="0">
+                <a:solidFill>
+                  <a:srgbClr val="004F9F"/>
+                </a:solidFill>
+                <a:latin typeface="에이투지체 6 SemiBold"/>
+                <a:ea typeface="에이투지체 6 SemiBold"/>
+                <a:cs typeface="에이투지체 6 SemiBold"/>
+              </a:rPr>
+              <a:t>행사 기간  </a:t>
+            </a:r>
+            <a:r>
+              <a:rPr sz="1150" b="0">
+                <a:solidFill>
+                  <a:srgbClr val="222222"/>
+                </a:solidFill>
+                <a:latin typeface="에이투지체 5 Medium"/>
+                <a:ea typeface="에이투지체 5 Medium"/>
+                <a:cs typeface="에이투지체 5 Medium"/>
+              </a:rPr>
+              <a:t>상시 캠페인을 그대로 두고 블프 기간 예산과 목표 ROAS만 조정합니다</a:t>
+            </a:r>
+          </a:p>
+        </p:txBody>
+      </p:sp>
+      <p:sp>
+        <p:nvSpPr>
+          <p:cNvPr id="37" name="Rounded Rectangle 23">
+            <a:extLst>
+              <a:ext uri="{FF2B5EF4-FFF2-40B4-BE49-F238E27FC236}">
+                <a16:creationId xmlns:a16="http://schemas.microsoft.com/office/drawing/2014/main" id="{3FC9EB3B-D101-DA6C-F6F0-E354BB2AED16}"/>
+              </a:ext>
+            </a:extLst>
+          </p:cNvPr>
+          <p:cNvSpPr/>
+          <p:nvPr/>
+        </p:nvSpPr>
+        <p:spPr>
+          <a:xfrm>
+            <a:off x="548640" y="2414017"/>
             <a:ext cx="2423160" cy="1097280"/>
           </a:xfrm>
           <a:prstGeom prst="roundRect">
@@ -21768,14 +21239,20 @@
       </p:sp>
       <p:sp>
         <p:nvSpPr>
-          <p:cNvPr id="25" name="TextBox 24"/>
-          <p:cNvSpPr txBox="1"/>
-          <p:nvPr/>
-        </p:nvSpPr>
-        <p:spPr>
-          <a:xfrm>
-            <a:off x="731520" y="3721608"/>
-            <a:ext cx="2148840" cy="1097280"/>
+          <p:cNvPr id="39" name="TextBox 38">
+            <a:extLst>
+              <a:ext uri="{FF2B5EF4-FFF2-40B4-BE49-F238E27FC236}">
+                <a16:creationId xmlns:a16="http://schemas.microsoft.com/office/drawing/2014/main" id="{14594F48-2017-BA7F-C773-9CCCA0978617}"/>
+              </a:ext>
+            </a:extLst>
+          </p:cNvPr>
+          <p:cNvSpPr txBox="1"/>
+          <p:nvPr/>
+        </p:nvSpPr>
+        <p:spPr>
+          <a:xfrm>
+            <a:off x="731520" y="2781838"/>
+            <a:ext cx="2148840" cy="361637"/>
           </a:xfrm>
           <a:prstGeom prst="rect">
             <a:avLst/>
@@ -21790,7 +21267,7 @@
           <a:p>
             <a:pPr algn="l"/>
             <a:r>
-              <a:rPr sz="1050" b="0">
+              <a:rPr sz="1050" b="0" dirty="0">
                 <a:solidFill>
                   <a:srgbClr val="004F9F"/>
                 </a:solidFill>
@@ -21798,34 +21275,111 @@
                 <a:ea typeface="에이투지체 6 SemiBold"/>
                 <a:cs typeface="에이투지체 6 SemiBold"/>
               </a:rPr>
-              <a:t>02</a:t>
-            </a:r>
-          </a:p>
-          <a:p>
-            <a:pPr algn="l"/>
-            <a:r>
-              <a:rPr sz="1300" b="0">
-                <a:solidFill>
-                  <a:srgbClr val="222222"/>
+              <a:t>0</a:t>
+            </a:r>
+            <a:r>
+              <a:rPr lang="en-US" sz="1050" b="0" dirty="0">
+                <a:solidFill>
+                  <a:srgbClr val="004F9F"/>
                 </a:solidFill>
                 <a:latin typeface="에이투지체 6 SemiBold"/>
                 <a:ea typeface="에이투지체 6 SemiBold"/>
                 <a:cs typeface="에이투지체 6 SemiBold"/>
               </a:rPr>
-              <a:t>검색어 노출 확대</a:t>
-            </a:r>
-          </a:p>
-        </p:txBody>
-      </p:sp>
-      <p:sp>
-        <p:nvSpPr>
-          <p:cNvPr id="26" name="Rounded Rectangle 25"/>
+              <a:t>1</a:t>
+            </a:r>
+            <a:endParaRPr sz="1050" b="0" dirty="0">
+              <a:solidFill>
+                <a:srgbClr val="004F9F"/>
+              </a:solidFill>
+              <a:latin typeface="에이투지체 6 SemiBold"/>
+              <a:ea typeface="에이투지체 6 SemiBold"/>
+              <a:cs typeface="에이투지체 6 SemiBold"/>
+            </a:endParaRPr>
+          </a:p>
+          <a:p>
+            <a:pPr algn="l"/>
+            <a:r>
+              <a:rPr sz="1300" b="0" dirty="0" err="1">
+                <a:solidFill>
+                  <a:srgbClr val="222222"/>
+                </a:solidFill>
+                <a:latin typeface="에이투지체 6 SemiBold"/>
+                <a:ea typeface="에이투지체 6 SemiBold"/>
+                <a:cs typeface="에이투지체 6 SemiBold"/>
+              </a:rPr>
+              <a:t>검색어</a:t>
+            </a:r>
+            <a:r>
+              <a:rPr sz="1300" b="0" dirty="0">
+                <a:solidFill>
+                  <a:srgbClr val="222222"/>
+                </a:solidFill>
+                <a:latin typeface="에이투지체 6 SemiBold"/>
+                <a:ea typeface="에이투지체 6 SemiBold"/>
+                <a:cs typeface="에이투지체 6 SemiBold"/>
+              </a:rPr>
+              <a:t> </a:t>
+            </a:r>
+            <a:r>
+              <a:rPr sz="1300" b="0" dirty="0" err="1">
+                <a:solidFill>
+                  <a:srgbClr val="222222"/>
+                </a:solidFill>
+                <a:latin typeface="에이투지체 6 SemiBold"/>
+                <a:ea typeface="에이투지체 6 SemiBold"/>
+                <a:cs typeface="에이투지체 6 SemiBold"/>
+              </a:rPr>
+              <a:t>노출</a:t>
+            </a:r>
+            <a:r>
+              <a:rPr sz="1300" b="0" dirty="0">
+                <a:solidFill>
+                  <a:srgbClr val="222222"/>
+                </a:solidFill>
+                <a:latin typeface="에이투지체 6 SemiBold"/>
+                <a:ea typeface="에이투지체 6 SemiBold"/>
+                <a:cs typeface="에이투지체 6 SemiBold"/>
+              </a:rPr>
+              <a:t> </a:t>
+            </a:r>
+            <a:r>
+              <a:rPr sz="1300" b="0" dirty="0" err="1">
+                <a:solidFill>
+                  <a:srgbClr val="222222"/>
+                </a:solidFill>
+                <a:latin typeface="에이투지체 6 SemiBold"/>
+                <a:ea typeface="에이투지체 6 SemiBold"/>
+                <a:cs typeface="에이투지체 6 SemiBold"/>
+              </a:rPr>
+              <a:t>확대</a:t>
+            </a:r>
+            <a:endParaRPr sz="1300" b="0" dirty="0">
+              <a:solidFill>
+                <a:srgbClr val="222222"/>
+              </a:solidFill>
+              <a:latin typeface="에이투지체 6 SemiBold"/>
+              <a:ea typeface="에이투지체 6 SemiBold"/>
+              <a:cs typeface="에이투지체 6 SemiBold"/>
+            </a:endParaRPr>
+          </a:p>
+        </p:txBody>
+      </p:sp>
+      <p:sp>
+        <p:nvSpPr>
+          <p:cNvPr id="41" name="Rounded Rectangle 25">
+            <a:extLst>
+              <a:ext uri="{FF2B5EF4-FFF2-40B4-BE49-F238E27FC236}">
+                <a16:creationId xmlns:a16="http://schemas.microsoft.com/office/drawing/2014/main" id="{5F8F59D9-7B3C-91EB-17C2-3BFB090BB546}"/>
+              </a:ext>
+            </a:extLst>
+          </p:cNvPr>
           <p:cNvSpPr/>
           <p:nvPr/>
         </p:nvSpPr>
         <p:spPr>
           <a:xfrm>
-            <a:off x="3291840" y="3721608"/>
+            <a:off x="3291840" y="2414017"/>
             <a:ext cx="3931920" cy="1097280"/>
           </a:xfrm>
           <a:prstGeom prst="roundRect">
@@ -21866,13 +21420,19 @@
       </p:sp>
       <p:sp>
         <p:nvSpPr>
-          <p:cNvPr id="27" name="TextBox 26"/>
-          <p:cNvSpPr txBox="1"/>
-          <p:nvPr/>
-        </p:nvSpPr>
-        <p:spPr>
-          <a:xfrm>
-            <a:off x="3493008" y="3721608"/>
+          <p:cNvPr id="43" name="TextBox 42">
+            <a:extLst>
+              <a:ext uri="{FF2B5EF4-FFF2-40B4-BE49-F238E27FC236}">
+                <a16:creationId xmlns:a16="http://schemas.microsoft.com/office/drawing/2014/main" id="{2D3EF5A2-BC28-2E2C-85CA-52C369286843}"/>
+              </a:ext>
+            </a:extLst>
+          </p:cNvPr>
+          <p:cNvSpPr txBox="1"/>
+          <p:nvPr/>
+        </p:nvSpPr>
+        <p:spPr>
+          <a:xfrm>
+            <a:off x="3493008" y="2414017"/>
             <a:ext cx="3611880" cy="1097280"/>
           </a:xfrm>
           <a:prstGeom prst="rect">
@@ -21917,13 +21477,19 @@
       </p:sp>
       <p:sp>
         <p:nvSpPr>
-          <p:cNvPr id="28" name="Rounded Rectangle 27"/>
+          <p:cNvPr id="45" name="Rounded Rectangle 27">
+            <a:extLst>
+              <a:ext uri="{FF2B5EF4-FFF2-40B4-BE49-F238E27FC236}">
+                <a16:creationId xmlns:a16="http://schemas.microsoft.com/office/drawing/2014/main" id="{FACD7F63-F59D-FA34-F7BE-C860A4BCDD3B}"/>
+              </a:ext>
+            </a:extLst>
+          </p:cNvPr>
           <p:cNvSpPr/>
           <p:nvPr/>
         </p:nvSpPr>
         <p:spPr>
           <a:xfrm>
-            <a:off x="7543800" y="4023360"/>
+            <a:off x="7543800" y="2715769"/>
             <a:ext cx="2103120" cy="493775"/>
           </a:xfrm>
           <a:prstGeom prst="roundRect">
@@ -21966,13 +21532,19 @@
       </p:sp>
       <p:sp>
         <p:nvSpPr>
-          <p:cNvPr id="29" name="TextBox 28"/>
-          <p:cNvSpPr txBox="1"/>
-          <p:nvPr/>
-        </p:nvSpPr>
-        <p:spPr>
-          <a:xfrm>
-            <a:off x="7635240" y="4023360"/>
+          <p:cNvPr id="47" name="TextBox 46">
+            <a:extLst>
+              <a:ext uri="{FF2B5EF4-FFF2-40B4-BE49-F238E27FC236}">
+                <a16:creationId xmlns:a16="http://schemas.microsoft.com/office/drawing/2014/main" id="{D233B7BC-6EFB-BAE0-93A5-D39F03C7D576}"/>
+              </a:ext>
+            </a:extLst>
+          </p:cNvPr>
+          <p:cNvSpPr txBox="1"/>
+          <p:nvPr/>
+        </p:nvSpPr>
+        <p:spPr>
+          <a:xfrm>
+            <a:off x="7635240" y="2715769"/>
             <a:ext cx="1920240" cy="493775"/>
           </a:xfrm>
           <a:prstGeom prst="rect">
@@ -22017,13 +21589,19 @@
       </p:sp>
       <p:sp>
         <p:nvSpPr>
-          <p:cNvPr id="30" name="TextBox 29"/>
-          <p:cNvSpPr txBox="1"/>
-          <p:nvPr/>
-        </p:nvSpPr>
-        <p:spPr>
-          <a:xfrm>
-            <a:off x="9966960" y="3721608"/>
+          <p:cNvPr id="49" name="TextBox 48">
+            <a:extLst>
+              <a:ext uri="{FF2B5EF4-FFF2-40B4-BE49-F238E27FC236}">
+                <a16:creationId xmlns:a16="http://schemas.microsoft.com/office/drawing/2014/main" id="{227ACCA9-8AE8-ACB0-1E0F-63119C1A6DE7}"/>
+              </a:ext>
+            </a:extLst>
+          </p:cNvPr>
+          <p:cNvSpPr txBox="1"/>
+          <p:nvPr/>
+        </p:nvSpPr>
+        <p:spPr>
+          <a:xfrm>
+            <a:off x="9966960" y="2414017"/>
             <a:ext cx="1645920" cy="1097280"/>
           </a:xfrm>
           <a:prstGeom prst="rect">
@@ -22068,13 +21646,19 @@
       </p:sp>
       <p:sp>
         <p:nvSpPr>
-          <p:cNvPr id="31" name="Isosceles Triangle 30"/>
+          <p:cNvPr id="51" name="Isosceles Triangle 30">
+            <a:extLst>
+              <a:ext uri="{FF2B5EF4-FFF2-40B4-BE49-F238E27FC236}">
+                <a16:creationId xmlns:a16="http://schemas.microsoft.com/office/drawing/2014/main" id="{4BD635CA-0E7D-0616-7A49-EFE7DE47B1D6}"/>
+              </a:ext>
+            </a:extLst>
+          </p:cNvPr>
           <p:cNvSpPr/>
           <p:nvPr/>
         </p:nvSpPr>
         <p:spPr>
           <a:xfrm rot="5400000">
-            <a:off x="2990088" y="4197096"/>
+            <a:off x="2990088" y="2889505"/>
             <a:ext cx="201168" cy="146304"/>
           </a:xfrm>
           <a:prstGeom prst="triangle">
@@ -22113,13 +21697,19 @@
       </p:sp>
       <p:sp>
         <p:nvSpPr>
-          <p:cNvPr id="32" name="Isosceles Triangle 31"/>
+          <p:cNvPr id="53" name="Isosceles Triangle 31">
+            <a:extLst>
+              <a:ext uri="{FF2B5EF4-FFF2-40B4-BE49-F238E27FC236}">
+                <a16:creationId xmlns:a16="http://schemas.microsoft.com/office/drawing/2014/main" id="{D7A4EEC5-AEB5-99A9-16F9-9C4821E592C9}"/>
+              </a:ext>
+            </a:extLst>
+          </p:cNvPr>
           <p:cNvSpPr/>
           <p:nvPr/>
         </p:nvSpPr>
         <p:spPr>
           <a:xfrm rot="5400000">
-            <a:off x="7242048" y="4197096"/>
+            <a:off x="7242048" y="2889505"/>
             <a:ext cx="201168" cy="146304"/>
           </a:xfrm>
           <a:prstGeom prst="triangle">
@@ -22158,13 +21748,19 @@
       </p:sp>
       <p:sp>
         <p:nvSpPr>
-          <p:cNvPr id="33" name="Isosceles Triangle 32"/>
+          <p:cNvPr id="55" name="Isosceles Triangle 32">
+            <a:extLst>
+              <a:ext uri="{FF2B5EF4-FFF2-40B4-BE49-F238E27FC236}">
+                <a16:creationId xmlns:a16="http://schemas.microsoft.com/office/drawing/2014/main" id="{D09ECC70-0D22-DA2C-BB5F-96DC1B7C205F}"/>
+              </a:ext>
+            </a:extLst>
+          </p:cNvPr>
           <p:cNvSpPr/>
           <p:nvPr/>
         </p:nvSpPr>
         <p:spPr>
           <a:xfrm rot="5400000">
-            <a:off x="9665208" y="4197096"/>
+            <a:off x="9665208" y="2889505"/>
             <a:ext cx="201168" cy="146304"/>
           </a:xfrm>
           <a:prstGeom prst="triangle">
@@ -22198,101 +21794,6 @@
           <a:p>
             <a:pPr algn="ctr"/>
             <a:endParaRPr/>
-          </a:p>
-        </p:txBody>
-      </p:sp>
-      <p:sp>
-        <p:nvSpPr>
-          <p:cNvPr id="34" name="Event Note Bar"/>
-          <p:cNvSpPr/>
-          <p:nvPr/>
-        </p:nvSpPr>
-        <p:spPr>
-          <a:xfrm>
-            <a:off x="548640" y="5102352"/>
-            <a:ext cx="11064240" cy="365760"/>
-          </a:xfrm>
-          <a:prstGeom prst="roundRect">
-            <a:avLst>
-              <a:gd name="adj" fmla="val 20000"/>
-            </a:avLst>
-          </a:prstGeom>
-          <a:solidFill>
-            <a:srgbClr val="F5F5F5"/>
-          </a:solidFill>
-          <a:ln>
-            <a:noFill/>
-          </a:ln>
-          <a:effectLst/>
-        </p:spPr>
-        <p:style>
-          <a:lnRef idx="1">
-            <a:schemeClr val="accent1"/>
-          </a:lnRef>
-          <a:fillRef idx="3">
-            <a:schemeClr val="accent1"/>
-          </a:fillRef>
-          <a:effectRef idx="2">
-            <a:schemeClr val="accent1"/>
-          </a:effectRef>
-          <a:fontRef idx="minor">
-            <a:schemeClr val="lt1"/>
-          </a:fontRef>
-        </p:style>
-        <p:txBody>
-          <a:bodyPr rtlCol="0" anchor="ctr"/>
-          <a:lstStyle/>
-          <a:p>
-            <a:pPr algn="ctr"/>
-            <a:endParaRPr/>
-          </a:p>
-        </p:txBody>
-      </p:sp>
-      <p:sp>
-        <p:nvSpPr>
-          <p:cNvPr id="35" name="Event Note Text"/>
-          <p:cNvSpPr txBox="1"/>
-          <p:nvPr/>
-        </p:nvSpPr>
-        <p:spPr>
-          <a:xfrm>
-            <a:off x="731520" y="5102352"/>
-            <a:ext cx="10698480" cy="365760"/>
-          </a:xfrm>
-          <a:prstGeom prst="rect">
-            <a:avLst/>
-          </a:prstGeom>
-          <a:noFill/>
-        </p:spPr>
-        <p:txBody>
-          <a:bodyPr wrap="square" lIns="0" tIns="0" rIns="0" bIns="0" anchor="ctr">
-            <a:spAutoFit/>
-          </a:bodyPr>
-          <a:lstStyle/>
-          <a:p>
-            <a:pPr algn="l"/>
-            <a:r>
-              <a:rPr sz="1150" b="0">
-                <a:solidFill>
-                  <a:srgbClr val="004F9F"/>
-                </a:solidFill>
-                <a:latin typeface="에이투지체 6 SemiBold"/>
-                <a:ea typeface="에이투지체 6 SemiBold"/>
-                <a:cs typeface="에이투지체 6 SemiBold"/>
-              </a:rPr>
-              <a:t>행사 기간  </a:t>
-            </a:r>
-            <a:r>
-              <a:rPr sz="1150" b="0">
-                <a:solidFill>
-                  <a:srgbClr val="222222"/>
-                </a:solidFill>
-                <a:latin typeface="에이투지체 5 Medium"/>
-                <a:ea typeface="에이투지체 5 Medium"/>
-                <a:cs typeface="에이투지체 5 Medium"/>
-              </a:rPr>
-              <a:t>상시 캠페인을 그대로 두고 블프 기간 예산과 목표 ROAS만 조정합니다</a:t>
-            </a:r>
           </a:p>
         </p:txBody>
       </p:sp>

</xml_diff>

<commit_message>
Merge Coupang diagnosis card 3 body into one line
Co-Authored-By: Claude Opus 5.5 <noreply@anthropic.com>
Claude-Session: https://claude.ai/code/session_01LNckV4PF1WFWnv5VJ442kU
</commit_message>
<xml_diff>
--- a/쿠팡_오픈마켓_11월_261013_취합본.pptx
+++ b/쿠팡_오픈마켓_11월_261013_취합본.pptx
@@ -5584,48 +5584,8 @@
                 <a:latin typeface="에이투지체 4 Regular"/>
                 <a:ea typeface="에이투지체 4 Regular"/>
               </a:rPr>
-              <a:t>키움정, 하우투키 검색 결과에</a:t>
-            </a:r>
-          </a:p>
-          <a:p>
-            <a:r>
-              <a:rPr lang="ko-KR" altLang="ko-KR" sz="1300" dirty="0">
-                <a:solidFill>
-                  <a:srgbClr val="5C5C5C"/>
-                </a:solidFill>
-                <a:latin typeface="에이투지체 4 Regular"/>
-                <a:ea typeface="에이투지체 4 Regular"/>
-              </a:rPr>
-              <a:t>두드림 상품 노출 없음</a:t>
-            </a:r>
-          </a:p>
-          <a:p>
-            <a:r>
-              <a:rPr lang="ko-KR" altLang="ko-KR" sz="1300" dirty="0">
-                <a:solidFill>
-                  <a:srgbClr val="5C5C5C"/>
-                </a:solidFill>
-                <a:latin typeface="에이투지체 4 Regular"/>
-                <a:ea typeface="에이투지체 4 Regular"/>
-              </a:rPr>
-              <a:t>경쟁사 상품만 노출</a:t>
-            </a:r>
-            <a:br>
-              <a:rPr lang="ko-KR" altLang="ko-KR" sz="1300" dirty="0">
-                <a:solidFill>
-                  <a:srgbClr val="5C5C5C"/>
-                </a:solidFill>
-                <a:latin typeface="에이투지체 4 Regular"/>
-                <a:ea typeface="에이투지체 4 Regular"/>
-              </a:rPr>
-            </a:br>
-            <a:endParaRPr sz="1300" dirty="0">
-              <a:solidFill>
-                <a:srgbClr val="5C5C5C"/>
-              </a:solidFill>
-              <a:latin typeface="에이투지체 4 Regular"/>
-              <a:ea typeface="에이투지체 4 Regular"/>
-            </a:endParaRPr>
+              <a:t>키움정, 하우투키 검색은 경쟁사 상품뿐</a:t>
+            </a:r>
           </a:p>
         </p:txBody>
       </p:sp>

</xml_diff>

<commit_message>
Rework Gmarket core-task slide to split roles across ad types; update slide 8 wording
Co-Authored-By: Claude Opus 5.5 <noreply@anthropic.com>
Claude-Session: https://claude.ai/code/session_01LNckV4PF1WFWnv5VJ442kU
</commit_message>
<xml_diff>
--- a/쿠팡_오픈마켓_11월_261013_취합본.pptx
+++ b/쿠팡_오픈마켓_11월_261013_취합본.pptx
@@ -7788,7 +7788,7 @@
                 <a:ea typeface="에이투지체 8 ExtraBold"/>
                 <a:cs typeface="에이투지체 8 ExtraBold"/>
               </a:rPr>
-              <a:t>직접 운영형 광고를 중심으로 관리하겠습니다</a:t>
+              <a:t>통합·집중·직접 운영형을 역할별로 나눠 운영하겠습니다</a:t>
             </a:r>
           </a:p>
         </p:txBody>
@@ -8266,7 +8266,21 @@
                 <a:ea typeface="에이투지체 6 SemiBold"/>
                 <a:cs typeface="에이투지체 6 SemiBold"/>
               </a:rPr>
-              <a:t>브랜드 검색어 채우기</a:t>
+              <a:t>브랜드 검색 시</a:t>
+            </a:r>
+          </a:p>
+          <a:p>
+            <a:pPr algn="l"/>
+            <a:r>
+              <a:rPr sz="1300" b="0">
+                <a:solidFill>
+                  <a:srgbClr val="FFFFFF"/>
+                </a:solidFill>
+                <a:latin typeface="에이투지체 6 SemiBold"/>
+                <a:ea typeface="에이투지체 6 SemiBold"/>
+                <a:cs typeface="에이투지체 6 SemiBold"/>
+              </a:rPr>
+              <a:t>광고 상품 확대</a:t>
             </a:r>
           </a:p>
         </p:txBody>
@@ -8832,7 +8846,7 @@
                 <a:ea typeface="에이투지체 5 Medium"/>
                 <a:cs typeface="에이투지체 5 Medium"/>
               </a:rPr>
-              <a:t>리뷰 격차가 큰 검색어는 CPC 상한을 낮추고</a:t>
+              <a:t>리뷰 수 차이가 큰 검색어는 적정 입찰가로 순위를 낮추고</a:t>
             </a:r>
           </a:p>
           <a:p>
@@ -9314,7 +9328,7 @@
                 <a:ea typeface="에이투지체 5 Medium"/>
                 <a:cs typeface="에이투지체 5 Medium"/>
               </a:rPr>
-              <a:t>대표 검색어는 CPC 상한 안에서 순위 관리</a:t>
+              <a:t>대표·세부 검색어는 통합 운영형이 찾고</a:t>
             </a:r>
           </a:p>
           <a:p>
@@ -9328,7 +9342,7 @@
                 <a:ea typeface="에이투지체 5 Medium"/>
                 <a:cs typeface="에이투지체 5 Medium"/>
               </a:rPr>
-              <a:t>경쟁사 검색어는 매체 정책 확인 후 테스트</a:t>
+              <a:t>카무트는 집중 운영형으로 성과를 검증합니다</a:t>
             </a:r>
           </a:p>
         </p:txBody>
@@ -9414,7 +9428,7 @@
                 <a:ea typeface="에이투지체 6 SemiBold"/>
                 <a:cs typeface="에이투지체 6 SemiBold"/>
               </a:rPr>
-              <a:t>직접 운영형</a:t>
+              <a:t>통합 운영형</a:t>
             </a:r>
           </a:p>
           <a:p>
@@ -22089,7 +22103,7 @@
                 <a:latin typeface="에이투지체 6 SemiBold"/>
                 <a:ea typeface="에이투지체 6 SemiBold"/>
               </a:rPr>
-              <a:t>지마켓은 광고 영역을 채우는 것이 시작 과제입니다</a:t>
+              <a:t>지마켓은 광고 노출 상품을 늘리고, 리뷰 수 차이가 큰 검색어는 순위를 낮추어 적정 입찰가로 운영합니다</a:t>
             </a:r>
             <a:endParaRPr sz="1350" dirty="0">
               <a:solidFill>
@@ -22805,7 +22819,7 @@
                 <a:ea typeface="에이투지체 6 SemiBold"/>
                 <a:cs typeface="에이투지체 6 SemiBold"/>
               </a:rPr>
-              <a:t>브랜드 검색어부터 채우기</a:t>
+              <a:t>브랜드 검색 시 광고 상품 확대</a:t>
             </a:r>
           </a:p>
         </p:txBody>

</xml_diff>

<commit_message>
Restructure Gmarket section as diagnosis, tasks 1-3, summary to mirror Coupang
Co-Authored-By: Claude Opus 5.5 <noreply@anthropic.com>
Claude-Session: https://claude.ai/code/session_01LNckV4PF1WFWnv5VJ442kU
</commit_message>
<xml_diff>
--- a/쿠팡_오픈마켓_11월_261013_취합본.pptx
+++ b/쿠팡_오픈마켓_11월_261013_취합본.pptx
@@ -19,9 +19,9 @@
     <p:sldId id="441" r:id="rId10"/>
     <p:sldId id="435" r:id="rId11"/>
     <p:sldId id="436" r:id="rId12"/>
+    <p:sldId id="440" r:id="rId15"/>
     <p:sldId id="438" r:id="rId13"/>
     <p:sldId id="439" r:id="rId14"/>
-    <p:sldId id="440" r:id="rId15"/>
   </p:sldIdLst>
   <p:sldSz cx="12192000" cy="6858000"/>
   <p:notesSz cx="6858000" cy="9144000"/>
@@ -6058,7 +6058,7 @@
                 <a:ea typeface="에이투지체 5 Medium"/>
                 <a:cs typeface="에이투지체 5 Medium"/>
               </a:rPr>
-              <a:t>지마켓 현황 진단 ③  대표 검색어</a:t>
+              <a:t>지마켓 핵심과제 2  대표 검색어</a:t>
             </a:r>
           </a:p>
         </p:txBody>
@@ -6851,128 +6851,7 @@
                 <a:ea typeface="에이투지체 5 Medium"/>
                 <a:cs typeface="에이투지체 5 Medium"/>
               </a:rPr>
-              <a:t>지마켓</a:t>
-            </a:r>
-            <a:r>
-              <a:rPr sz="1100" b="0" dirty="0">
-                <a:solidFill>
-                  <a:srgbClr val="5C5C5C"/>
-                </a:solidFill>
-                <a:latin typeface="에이투지체 5 Medium"/>
-                <a:ea typeface="에이투지체 5 Medium"/>
-                <a:cs typeface="에이투지체 5 Medium"/>
-              </a:rPr>
-              <a:t> </a:t>
-            </a:r>
-            <a:r>
-              <a:rPr sz="1100" b="0" dirty="0" err="1">
-                <a:solidFill>
-                  <a:srgbClr val="5C5C5C"/>
-                </a:solidFill>
-                <a:latin typeface="에이투지체 5 Medium"/>
-                <a:ea typeface="에이투지체 5 Medium"/>
-                <a:cs typeface="에이투지체 5 Medium"/>
-              </a:rPr>
-              <a:t>현황</a:t>
-            </a:r>
-            <a:r>
-              <a:rPr sz="1100" b="0" dirty="0">
-                <a:solidFill>
-                  <a:srgbClr val="5C5C5C"/>
-                </a:solidFill>
-                <a:latin typeface="에이투지체 5 Medium"/>
-                <a:ea typeface="에이투지체 5 Medium"/>
-                <a:cs typeface="에이투지체 5 Medium"/>
-              </a:rPr>
-              <a:t> </a:t>
-            </a:r>
-            <a:r>
-              <a:rPr sz="1100" b="0" dirty="0" err="1">
-                <a:solidFill>
-                  <a:srgbClr val="5C5C5C"/>
-                </a:solidFill>
-                <a:latin typeface="에이투지체 5 Medium"/>
-                <a:ea typeface="에이투지체 5 Medium"/>
-                <a:cs typeface="에이투지체 5 Medium"/>
-              </a:rPr>
-              <a:t>진단</a:t>
-            </a:r>
-            <a:r>
-              <a:rPr sz="1100" b="0" dirty="0">
-                <a:solidFill>
-                  <a:srgbClr val="5C5C5C"/>
-                </a:solidFill>
-                <a:latin typeface="에이투지체 5 Medium"/>
-                <a:ea typeface="에이투지체 5 Medium"/>
-                <a:cs typeface="에이투지체 5 Medium"/>
-              </a:rPr>
-              <a:t> ④  </a:t>
-            </a:r>
-            <a:r>
-              <a:rPr sz="1100" b="0" dirty="0" err="1">
-                <a:solidFill>
-                  <a:srgbClr val="5C5C5C"/>
-                </a:solidFill>
-                <a:latin typeface="에이투지체 5 Medium"/>
-                <a:ea typeface="에이투지체 5 Medium"/>
-                <a:cs typeface="에이투지체 5 Medium"/>
-              </a:rPr>
-              <a:t>상세</a:t>
-            </a:r>
-            <a:r>
-              <a:rPr sz="1100" b="0" dirty="0">
-                <a:solidFill>
-                  <a:srgbClr val="5C5C5C"/>
-                </a:solidFill>
-                <a:latin typeface="에이투지체 5 Medium"/>
-                <a:ea typeface="에이투지체 5 Medium"/>
-                <a:cs typeface="에이투지체 5 Medium"/>
-              </a:rPr>
-              <a:t> </a:t>
-            </a:r>
-            <a:r>
-              <a:rPr sz="1100" b="0" dirty="0" err="1">
-                <a:solidFill>
-                  <a:srgbClr val="5C5C5C"/>
-                </a:solidFill>
-                <a:latin typeface="에이투지체 5 Medium"/>
-                <a:ea typeface="에이투지체 5 Medium"/>
-                <a:cs typeface="에이투지체 5 Medium"/>
-              </a:rPr>
-              <a:t>페이지</a:t>
-            </a:r>
-            <a:r>
-              <a:rPr sz="1100" b="0" dirty="0">
-                <a:solidFill>
-                  <a:srgbClr val="5C5C5C"/>
-                </a:solidFill>
-                <a:latin typeface="에이투지체 5 Medium"/>
-                <a:ea typeface="에이투지체 5 Medium"/>
-                <a:cs typeface="에이투지체 5 Medium"/>
-              </a:rPr>
-              <a:t> </a:t>
-            </a:r>
-            <a:r>
-              <a:rPr sz="1100" b="0" dirty="0" err="1">
-                <a:solidFill>
-                  <a:srgbClr val="5C5C5C"/>
-                </a:solidFill>
-                <a:latin typeface="에이투지체 5 Medium"/>
-                <a:ea typeface="에이투지체 5 Medium"/>
-                <a:cs typeface="에이투지체 5 Medium"/>
-              </a:rPr>
-              <a:t>추가구성</a:t>
-            </a:r>
-            <a:r>
-              <a:rPr sz="1100" b="0" dirty="0">
-                <a:solidFill>
-                  <a:srgbClr val="5C5C5C"/>
-                </a:solidFill>
-                <a:latin typeface="에이투지체 5 Medium"/>
-                <a:ea typeface="에이투지체 5 Medium"/>
-                <a:cs typeface="에이투지체 5 Medium"/>
-              </a:rPr>
-              <a:t> </a:t>
+              <a:t>지마켓 핵심과제 2  상세 페이지 추가구성</a:t>
             </a:r>
           </a:p>
         </p:txBody>
@@ -12754,172 +12633,7 @@
                 <a:ea typeface="에이투지체 5 Medium"/>
                 <a:cs typeface="에이투지체 5 Medium"/>
               </a:rPr>
-              <a:t>오픈마켓</a:t>
-            </a:r>
-            <a:r>
-              <a:rPr sz="1100" b="0" dirty="0">
-                <a:solidFill>
-                  <a:srgbClr val="5C5C5C"/>
-                </a:solidFill>
-                <a:latin typeface="에이투지체 5 Medium"/>
-                <a:ea typeface="에이투지체 5 Medium"/>
-                <a:cs typeface="에이투지체 5 Medium"/>
-              </a:rPr>
-              <a:t> </a:t>
-            </a:r>
-            <a:r>
-              <a:rPr sz="1100" b="0" dirty="0" err="1">
-                <a:solidFill>
-                  <a:srgbClr val="5C5C5C"/>
-                </a:solidFill>
-                <a:latin typeface="에이투지체 5 Medium"/>
-                <a:ea typeface="에이투지체 5 Medium"/>
-                <a:cs typeface="에이투지체 5 Medium"/>
-              </a:rPr>
-              <a:t>운영</a:t>
-            </a:r>
-            <a:r>
-              <a:rPr sz="1100" b="0" dirty="0">
-                <a:solidFill>
-                  <a:srgbClr val="5C5C5C"/>
-                </a:solidFill>
-                <a:latin typeface="에이투지체 5 Medium"/>
-                <a:ea typeface="에이투지체 5 Medium"/>
-                <a:cs typeface="에이투지체 5 Medium"/>
-              </a:rPr>
-              <a:t> </a:t>
-            </a:r>
-            <a:r>
-              <a:rPr sz="1100" b="0" dirty="0" err="1">
-                <a:solidFill>
-                  <a:srgbClr val="5C5C5C"/>
-                </a:solidFill>
-                <a:latin typeface="에이투지체 5 Medium"/>
-                <a:ea typeface="에이투지체 5 Medium"/>
-                <a:cs typeface="에이투지체 5 Medium"/>
-              </a:rPr>
-              <a:t>관리</a:t>
-            </a:r>
-            <a:r>
-              <a:rPr sz="1100" b="0" dirty="0">
-                <a:solidFill>
-                  <a:srgbClr val="5C5C5C"/>
-                </a:solidFill>
-                <a:latin typeface="에이투지체 5 Medium"/>
-                <a:ea typeface="에이투지체 5 Medium"/>
-                <a:cs typeface="에이투지체 5 Medium"/>
-              </a:rPr>
-              <a:t>  </a:t>
-            </a:r>
-            <a:r>
-              <a:rPr sz="1100" b="0" dirty="0" err="1">
-                <a:solidFill>
-                  <a:srgbClr val="5C5C5C"/>
-                </a:solidFill>
-                <a:latin typeface="에이투지체 5 Medium"/>
-                <a:ea typeface="에이투지체 5 Medium"/>
-                <a:cs typeface="에이투지체 5 Medium"/>
-              </a:rPr>
-              <a:t>사내</a:t>
-            </a:r>
-            <a:r>
-              <a:rPr sz="1100" b="0" dirty="0">
-                <a:solidFill>
-                  <a:srgbClr val="5C5C5C"/>
-                </a:solidFill>
-                <a:latin typeface="에이투지체 5 Medium"/>
-                <a:ea typeface="에이투지체 5 Medium"/>
-                <a:cs typeface="에이투지체 5 Medium"/>
-              </a:rPr>
-              <a:t> </a:t>
-            </a:r>
-            <a:r>
-              <a:rPr sz="1100" b="0" dirty="0" err="1">
-                <a:solidFill>
-                  <a:srgbClr val="5C5C5C"/>
-                </a:solidFill>
-                <a:latin typeface="에이투지체 5 Medium"/>
-                <a:ea typeface="에이투지체 5 Medium"/>
-                <a:cs typeface="에이투지체 5 Medium"/>
-              </a:rPr>
-              <a:t>리포트</a:t>
-            </a:r>
-            <a:r>
-              <a:rPr sz="1100" b="0" dirty="0">
-                <a:solidFill>
-                  <a:srgbClr val="5C5C5C"/>
-                </a:solidFill>
-                <a:latin typeface="에이투지체 5 Medium"/>
-                <a:ea typeface="에이투지체 5 Medium"/>
-                <a:cs typeface="에이투지체 5 Medium"/>
-              </a:rPr>
-              <a:t> (</a:t>
-            </a:r>
-            <a:r>
-              <a:rPr sz="1100" b="0" dirty="0" err="1">
-                <a:solidFill>
-                  <a:srgbClr val="5C5C5C"/>
-                </a:solidFill>
-                <a:latin typeface="에이투지체 5 Medium"/>
-                <a:ea typeface="에이투지체 5 Medium"/>
-                <a:cs typeface="에이투지체 5 Medium"/>
-              </a:rPr>
-              <a:t>동종</a:t>
-            </a:r>
-            <a:r>
-              <a:rPr sz="1100" b="0" dirty="0">
-                <a:solidFill>
-                  <a:srgbClr val="5C5C5C"/>
-                </a:solidFill>
-                <a:latin typeface="에이투지체 5 Medium"/>
-                <a:ea typeface="에이투지체 5 Medium"/>
-                <a:cs typeface="에이투지체 5 Medium"/>
-              </a:rPr>
-              <a:t> </a:t>
-            </a:r>
-            <a:r>
-              <a:rPr sz="1100" b="0" dirty="0" err="1">
-                <a:solidFill>
-                  <a:srgbClr val="5C5C5C"/>
-                </a:solidFill>
-                <a:latin typeface="에이투지체 5 Medium"/>
-                <a:ea typeface="에이투지체 5 Medium"/>
-                <a:cs typeface="에이투지체 5 Medium"/>
-              </a:rPr>
-              <a:t>건기식</a:t>
-            </a:r>
-            <a:r>
-              <a:rPr sz="1100" b="0" dirty="0">
-                <a:solidFill>
-                  <a:srgbClr val="5C5C5C"/>
-                </a:solidFill>
-                <a:latin typeface="에이투지체 5 Medium"/>
-                <a:ea typeface="에이투지체 5 Medium"/>
-                <a:cs typeface="에이투지체 5 Medium"/>
-              </a:rPr>
-              <a:t> </a:t>
-            </a:r>
-            <a:r>
-              <a:rPr sz="1100" b="0" dirty="0" err="1">
-                <a:solidFill>
-                  <a:srgbClr val="5C5C5C"/>
-                </a:solidFill>
-                <a:latin typeface="에이투지체 5 Medium"/>
-                <a:ea typeface="에이투지체 5 Medium"/>
-                <a:cs typeface="에이투지체 5 Medium"/>
-              </a:rPr>
-              <a:t>사례</a:t>
-            </a:r>
-            <a:r>
-              <a:rPr sz="1100" b="0" dirty="0">
-                <a:solidFill>
-                  <a:srgbClr val="5C5C5C"/>
-                </a:solidFill>
-                <a:latin typeface="에이투지체 5 Medium"/>
-                <a:ea typeface="에이투지체 5 Medium"/>
-                <a:cs typeface="에이투지체 5 Medium"/>
-              </a:rPr>
-              <a:t>)</a:t>
+              <a:t>지마켓 핵심과제 3  운영형별 예산 관리 (동종 건기식 사례)</a:t>
             </a:r>
           </a:p>
         </p:txBody>
@@ -21975,51 +21689,7 @@
                 <a:ea typeface="에이투지체 5 Medium"/>
                 <a:cs typeface="에이투지체 5 Medium"/>
               </a:rPr>
-              <a:t>지마켓 </a:t>
-            </a:r>
-            <a:r>
-              <a:rPr sz="1100" b="0" dirty="0" err="1">
-                <a:solidFill>
-                  <a:srgbClr val="5C5C5C"/>
-                </a:solidFill>
-                <a:latin typeface="에이투지체 5 Medium"/>
-                <a:ea typeface="에이투지체 5 Medium"/>
-                <a:cs typeface="에이투지체 5 Medium"/>
-              </a:rPr>
-              <a:t>현황</a:t>
-            </a:r>
-            <a:r>
-              <a:rPr sz="1100" b="0" dirty="0">
-                <a:solidFill>
-                  <a:srgbClr val="5C5C5C"/>
-                </a:solidFill>
-                <a:latin typeface="에이투지체 5 Medium"/>
-                <a:ea typeface="에이투지체 5 Medium"/>
-                <a:cs typeface="에이투지체 5 Medium"/>
-              </a:rPr>
-              <a:t> </a:t>
-            </a:r>
-            <a:r>
-              <a:rPr sz="1100" b="0" dirty="0" err="1">
-                <a:solidFill>
-                  <a:srgbClr val="5C5C5C"/>
-                </a:solidFill>
-                <a:latin typeface="에이투지체 5 Medium"/>
-                <a:ea typeface="에이투지체 5 Medium"/>
-                <a:cs typeface="에이투지체 5 Medium"/>
-              </a:rPr>
-              <a:t>진단</a:t>
-            </a:r>
-            <a:r>
-              <a:rPr sz="1100" b="0" dirty="0">
-                <a:solidFill>
-                  <a:srgbClr val="5C5C5C"/>
-                </a:solidFill>
-                <a:latin typeface="에이투지체 5 Medium"/>
-                <a:ea typeface="에이투지체 5 Medium"/>
-                <a:cs typeface="에이투지체 5 Medium"/>
-              </a:rPr>
-              <a:t> ①</a:t>
+              <a:t>지마켓 현황 진단</a:t>
             </a:r>
           </a:p>
         </p:txBody>
@@ -23456,7 +23126,7 @@
                 <a:ea typeface="에이투지체 5 Medium"/>
                 <a:cs typeface="에이투지체 5 Medium"/>
               </a:rPr>
-              <a:t>지마켓 현황 진단 ②  판매 상품과 광고 상품</a:t>
+              <a:t>지마켓 핵심과제 1  판매 상품과 광고 상품</a:t>
             </a:r>
           </a:p>
         </p:txBody>

</xml_diff>

<commit_message>
Correct competitor-brand finding to partial exposure and switch to per-competitor exclusion logic
Co-Authored-By: Claude Opus 5.5 <noreply@anthropic.com>
Claude-Session: https://claude.ai/code/session_01LNckV4PF1WFWnv5VJ442kU
</commit_message>
<xml_diff>
--- a/쿠팡_오픈마켓_11월_261013_취합본.pptx
+++ b/쿠팡_오픈마켓_11월_261013_취합본.pptx
@@ -4418,7 +4418,7 @@
                 <a:ea typeface="에이투지체 3 Light"/>
                 <a:cs typeface="에이투지체 3 Light"/>
               </a:rPr>
-              <a:t>상품: 2026.10.12 (주)두드림비엔비 쿠팡 브랜드샵 / 검색: 2026.10.13 쿠팡 PC 검색 화면 기준 (비로그인). 검색 결과는 새로고침, 사용자별로 달라짐</a:t>
+              <a:t>상품: 2026.10.12 (주)두드림비엔비 쿠팡 브랜드샵 / 검색: 2026.10.13 쿠팡 PC 검색 화면 기준 (비로그인). 검색 결과는 새로고침, 사용자별로 달라짐 / 경쟁사 브랜드: 키움정, 하우투키, 키즈픽션, 종근당아이커키성장, 그로스템포, 피크하이트 검색 기준</a:t>
             </a:r>
           </a:p>
         </p:txBody>
@@ -5459,7 +5459,7 @@
                 <a:ea typeface="에이투지체 8 ExtraBold"/>
                 <a:cs typeface="에이투지체 8 ExtraBold"/>
               </a:rPr>
-              <a:t>미노출</a:t>
+              <a:t>6개 중 1개</a:t>
             </a:r>
           </a:p>
         </p:txBody>
@@ -5496,7 +5496,7 @@
                 <a:ea typeface="에이투지체 6 SemiBold"/>
                 <a:cs typeface="에이투지체 6 SemiBold"/>
               </a:rPr>
-              <a:t>경쟁사 브랜드 검색 결과</a:t>
+              <a:t>경쟁사 브랜드 검색 노출</a:t>
             </a:r>
             <a:endParaRPr sz="1150" b="0" dirty="0">
               <a:solidFill>
@@ -5541,7 +5541,7 @@
                 <a:ea typeface="에이투지체 6 SemiBold"/>
                 <a:cs typeface="에이투지체 6 SemiBold"/>
               </a:rPr>
-              <a:t>경쟁사 브랜드 검색에 두드림 없음</a:t>
+              <a:t>경쟁사 브랜드 검색 노출은 일부</a:t>
             </a:r>
             <a:endParaRPr sz="1575" b="0" dirty="0">
               <a:solidFill>
@@ -5584,7 +5584,7 @@
                 <a:latin typeface="에이투지체 4 Regular"/>
                 <a:ea typeface="에이투지체 4 Regular"/>
               </a:rPr>
-              <a:t>키움정, 하우투키 검색은 경쟁사 상품뿐</a:t>
+              <a:t>종근당아이커 검색에만 FGO 노출</a:t>
             </a:r>
           </a:p>
         </p:txBody>
@@ -13946,7 +13946,7 @@
                 <a:ea typeface="에이투지체 8 ExtraBold"/>
                 <a:cs typeface="에이투지체 8 ExtraBold"/>
               </a:rPr>
-              <a:t>경쟁사 브랜드 검색 결과에는</a:t>
+              <a:t>경쟁사 브랜드 검색에서</a:t>
             </a:r>
             <a:endParaRPr sz="1900" b="0" dirty="0">
               <a:solidFill>
@@ -13975,7 +13975,7 @@
                 <a:ea typeface="에이투지체 8 ExtraBold"/>
                 <a:cs typeface="에이투지체 8 ExtraBold"/>
               </a:rPr>
-              <a:t>두드림 상품이 없습니다</a:t>
+              <a:t>두드림 상품은 일부에만 노출됩니다</a:t>
             </a:r>
             <a:endParaRPr sz="1900" b="0" dirty="0">
               <a:solidFill>
@@ -14112,7 +14112,7 @@
                 <a:ea typeface="에이투지체 6 SemiBold"/>
                 <a:cs typeface="에이투지체 6 SemiBold"/>
               </a:rPr>
-              <a:t>경쟁사 브랜드 검색어는 제외하지 않고 노출해 전환 성과를 확인하겠습니다</a:t>
+              <a:t>경쟁사 브랜드 검색어는 경쟁사별로 성과를 보고, 효율이 낮은 곳은 제외해 잘 되는 키워드만 남기겠습니다</a:t>
             </a:r>
           </a:p>
         </p:txBody>
@@ -14149,7 +14149,7 @@
                 <a:ea typeface="에이투지체 3 Light"/>
                 <a:cs typeface="에이투지체 3 Light"/>
               </a:rPr>
-              <a:t>2026.10.13 쿠팡 PC 검색 화면 기준 (비로그인). 검색 결과는 새로고침, 사용자별로 달라짐</a:t>
+              <a:t>2026.10.13 쿠팡 PC 검색 화면 기준 (비로그인). 검색 결과는 새로고침, 사용자별로 달라짐 / 키즈픽션·그로스템포·피크하이트 검색에도 두드림 미노출</a:t>
             </a:r>
           </a:p>
         </p:txBody>
@@ -14274,7 +14274,7 @@
         <p:spPr>
           <a:xfrm>
             <a:off x="548640" y="1993392"/>
-            <a:ext cx="4593355" cy="292608"/>
+            <a:ext cx="3505200" cy="292608"/>
           </a:xfrm>
           <a:prstGeom prst="rect">
             <a:avLst/>
@@ -14321,8 +14321,8 @@
         </p:nvSpPr>
         <p:spPr>
           <a:xfrm>
-            <a:off x="6980723" y="1993392"/>
-            <a:ext cx="4632157" cy="292608"/>
+            <a:off x="4328160" y="1993392"/>
+            <a:ext cx="3505200" cy="292608"/>
           </a:xfrm>
           <a:prstGeom prst="rect">
             <a:avLst/>
@@ -14378,7 +14378,7 @@
         <p:spPr>
           <a:xfrm>
             <a:off x="548640" y="2331720"/>
-            <a:ext cx="4593355" cy="2560320"/>
+            <a:ext cx="3505200" cy="1953786"/>
           </a:xfrm>
           <a:prstGeom prst="rect">
             <a:avLst/>
@@ -14406,8 +14406,85 @@
         </p:blipFill>
         <p:spPr>
           <a:xfrm>
-            <a:off x="6980723" y="2331720"/>
-            <a:ext cx="4632157" cy="2560320"/>
+            <a:off x="4328160" y="2331720"/>
+            <a:ext cx="3505200" cy="1937420"/>
+          </a:xfrm>
+          <a:prstGeom prst="rect">
+            <a:avLst/>
+          </a:prstGeom>
+          <a:ln w="9525">
+            <a:solidFill>
+              <a:srgbClr val="DDDDDD"/>
+            </a:solidFill>
+          </a:ln>
+        </p:spPr>
+      </p:pic>
+      <p:sp>
+        <p:nvSpPr>
+          <p:cNvPr id="18" name="TextBox 30"/>
+          <p:cNvSpPr txBox="1"/>
+          <p:nvPr/>
+        </p:nvSpPr>
+        <p:spPr>
+          <a:xfrm>
+            <a:off x="8107680" y="1993392"/>
+            <a:ext cx="3505200" cy="292608"/>
+          </a:xfrm>
+          <a:prstGeom prst="rect">
+            <a:avLst/>
+          </a:prstGeom>
+          <a:noFill/>
+        </p:spPr>
+        <p:txBody>
+          <a:bodyPr wrap="square" lIns="0" tIns="0" rIns="0" bIns="0" anchor="t">
+            <a:spAutoFit/>
+          </a:bodyPr>
+          <a:lstStyle/>
+          <a:p>
+            <a:pPr algn="l"/>
+            <a:r>
+              <a:rPr sz="1250" b="0">
+                <a:solidFill>
+                  <a:srgbClr val="004F9F"/>
+                </a:solidFill>
+                <a:latin typeface="에이투지체 8 ExtraBold"/>
+                <a:ea typeface="에이투지체 8 ExtraBold"/>
+                <a:cs typeface="에이투지체 8 ExtraBold"/>
+              </a:rPr>
+              <a:t>"종근당아이커키성장" 검색  </a:t>
+            </a:r>
+            <a:r>
+              <a:rPr sz="1250" b="0">
+                <a:solidFill>
+                  <a:srgbClr val="222222"/>
+                </a:solidFill>
+                <a:latin typeface="에이투지체 6 SemiBold"/>
+                <a:ea typeface="에이투지체 6 SemiBold"/>
+                <a:cs typeface="에이투지체 6 SemiBold"/>
+              </a:rPr>
+              <a:t>FGO 광고 노출</a:t>
+            </a:r>
+          </a:p>
+        </p:txBody>
+      </p:sp>
+      <p:pic>
+        <p:nvPicPr>
+          <p:cNvPr id="19" name="Picture 31" descr="howtoki.png"/>
+          <p:cNvPicPr>
+            <a:picLocks noChangeAspect="1"/>
+          </p:cNvPicPr>
+          <p:nvPr/>
+        </p:nvPicPr>
+        <p:blipFill>
+          <a:blip r:embed="rId9"/>
+          <a:stretch>
+            <a:fillRect/>
+          </a:stretch>
+        </p:blipFill>
+        <p:spPr>
+          <a:xfrm>
+            <a:off x="8107680" y="2331720"/>
+            <a:ext cx="3505200" cy="1909337"/>
           </a:xfrm>
           <a:prstGeom prst="rect">
             <a:avLst/>
@@ -16771,7 +16848,7 @@
                 <a:ea typeface="에이투지체 4 Regular"/>
                 <a:cs typeface="에이투지체 4 Regular"/>
               </a:rPr>
-              <a:t>두드림 노출 없음</a:t>
+              <a:t>일부 검색어에만 노출</a:t>
             </a:r>
           </a:p>
         </p:txBody>
@@ -16823,7 +16900,7 @@
                 <a:ea typeface="에이투지체 4 Regular"/>
                 <a:cs typeface="에이투지체 4 Regular"/>
               </a:rPr>
-              <a:t>제외 키워드로 막지 않고 성과 확인</a:t>
+              <a:t>경쟁사별로 성과 확인</a:t>
             </a:r>
           </a:p>
           <a:p>
@@ -16841,7 +16918,7 @@
                 <a:ea typeface="에이투지체 4 Regular"/>
                 <a:cs typeface="에이투지체 4 Regular"/>
               </a:rPr>
-              <a:t>          5클릭 이상 무전환 검색어만 제외</a:t>
+              <a:t>          효율 낮은 경쟁사 키워드는 제외</a:t>
             </a:r>
           </a:p>
         </p:txBody>
@@ -21212,7 +21289,7 @@
                 <a:ea typeface="에이투지체 5 Medium"/>
                 <a:cs typeface="에이투지체 5 Medium"/>
               </a:rPr>
-              <a:t>대표·경쟁사 검색어는 제외 없이 성과를 봅니다</a:t>
+              <a:t>대표는 열어 두고, 경쟁사는 효율 낮은 곳만 제외합니다</a:t>
             </a:r>
           </a:p>
         </p:txBody>

</xml_diff>

<commit_message>
Revise Coupang competitor-brand search slide: title, label, footnote, spacing
Co-Authored-By: Claude Opus 5.5 <noreply@anthropic.com>
Claude-Session: https://claude.ai/code/session_01LNckV4PF1WFWnv5VJ442kU
</commit_message>
<xml_diff>
--- a/쿠팡_오픈마켓_11월_261013_취합본.pptx
+++ b/쿠팡_오픈마켓_11월_261013_취합본.pptx
@@ -13975,7 +13975,7 @@
                 <a:ea typeface="에이투지체 8 ExtraBold"/>
                 <a:cs typeface="에이투지체 8 ExtraBold"/>
               </a:rPr>
-              <a:t>두드림 상품은 일부에만 노출됩니다</a:t>
+              <a:t>두드림 상품은 일부 경쟁사에만 노출됩니다</a:t>
             </a:r>
             <a:endParaRPr sz="1900" b="0" dirty="0">
               <a:solidFill>
@@ -14149,7 +14149,7 @@
                 <a:ea typeface="에이투지체 3 Light"/>
                 <a:cs typeface="에이투지체 3 Light"/>
               </a:rPr>
-              <a:t>2026.10.13 쿠팡 PC 검색 화면 기준 (비로그인). 검색 결과는 새로고침, 사용자별로 달라짐 / 키즈픽션·그로스템포·피크하이트 검색에도 두드림 미노출</a:t>
+              <a:t>2026.10.13 쿠팡 PC 검색 화면 기준 (비로그인). 검색 결과는 새로고침, 사용자별로 달라짐 / 키즈픽션·그로스템포·피크하이트 검색에도 두드림 미노출 / 키앤이거 검색에서는 두드림 노출</a:t>
             </a:r>
           </a:p>
         </p:txBody>
@@ -14273,7 +14273,7 @@
         </p:nvSpPr>
         <p:spPr>
           <a:xfrm>
-            <a:off x="548640" y="1993392"/>
+            <a:off x="548640" y="2548119"/>
             <a:ext cx="3505200" cy="292608"/>
           </a:xfrm>
           <a:prstGeom prst="rect">
@@ -14321,7 +14321,7 @@
         </p:nvSpPr>
         <p:spPr>
           <a:xfrm>
-            <a:off x="4328160" y="1993392"/>
+            <a:off x="4328160" y="2548119"/>
             <a:ext cx="3505200" cy="292608"/>
           </a:xfrm>
           <a:prstGeom prst="rect">
@@ -14377,7 +14377,7 @@
         </p:blipFill>
         <p:spPr>
           <a:xfrm>
-            <a:off x="548640" y="2331720"/>
+            <a:off x="548640" y="2886447"/>
             <a:ext cx="3505200" cy="1953786"/>
           </a:xfrm>
           <a:prstGeom prst="rect">
@@ -14406,7 +14406,7 @@
         </p:blipFill>
         <p:spPr>
           <a:xfrm>
-            <a:off x="4328160" y="2331720"/>
+            <a:off x="4328160" y="2886447"/>
             <a:ext cx="3505200" cy="1937420"/>
           </a:xfrm>
           <a:prstGeom prst="rect">
@@ -14427,7 +14427,7 @@
         </p:nvSpPr>
         <p:spPr>
           <a:xfrm>
-            <a:off x="8107680" y="1993392"/>
+            <a:off x="8107680" y="2548119"/>
             <a:ext cx="3505200" cy="292608"/>
           </a:xfrm>
           <a:prstGeom prst="rect">
@@ -14462,7 +14462,7 @@
                 <a:ea typeface="에이투지체 6 SemiBold"/>
                 <a:cs typeface="에이투지체 6 SemiBold"/>
               </a:rPr>
-              <a:t>FGO 광고 노출</a:t>
+              <a:t>두드림 광고 노출</a:t>
             </a:r>
           </a:p>
         </p:txBody>
@@ -14483,7 +14483,7 @@
         </p:blipFill>
         <p:spPr>
           <a:xfrm>
-            <a:off x="8107680" y="2331720"/>
+            <a:off x="8107680" y="2886447"/>
             <a:ext cx="3505200" cy="1909337"/>
           </a:xfrm>
           <a:prstGeom prst="rect">

</xml_diff>